<commit_message>
docs: refresh verified presentation and case follow-up demo
</commit_message>
<xml_diff>
--- a/submission/Claro-Hackathon-2026.pptx
+++ b/submission/Claro-Hackathon-2026.pptx
@@ -2,18 +2,18 @@
 <file path=ppt/presentation.xml><?xml version="1.0" encoding="utf-8"?>
 <p:presentation xmlns:p="http://schemas.openxmlformats.org/presentationml/2006/main">
   <p:sldMasterIdLst>
-    <p:sldMasterId xmlns:r="http://schemas.openxmlformats.org/officeDocument/2006/relationships" id="2147483648" r:id="R14737d00c4f64877"/>
+    <p:sldMasterId xmlns:r="http://schemas.openxmlformats.org/officeDocument/2006/relationships" id="2147483648" r:id="R50a10161cf2f454e"/>
   </p:sldMasterIdLst>
   <p:notesMasterIdLst>
-    <p:notesMasterId xmlns:r="http://schemas.openxmlformats.org/officeDocument/2006/relationships" r:id="R6a148e78678b4973"/>
+    <p:notesMasterId xmlns:r="http://schemas.openxmlformats.org/officeDocument/2006/relationships" r:id="R897237d383af48d3"/>
   </p:notesMasterIdLst>
   <p:sldIdLst>
-    <p:sldId xmlns:r="http://schemas.openxmlformats.org/officeDocument/2006/relationships" id="256" r:id="R76ed03ec5619416d"/>
-    <p:sldId xmlns:r="http://schemas.openxmlformats.org/officeDocument/2006/relationships" id="257" r:id="R6a687ad81fff47cf"/>
-    <p:sldId xmlns:r="http://schemas.openxmlformats.org/officeDocument/2006/relationships" id="258" r:id="Ra9ff6a118fce42ce"/>
-    <p:sldId xmlns:r="http://schemas.openxmlformats.org/officeDocument/2006/relationships" id="259" r:id="R85a5fecd9f454667"/>
-    <p:sldId xmlns:r="http://schemas.openxmlformats.org/officeDocument/2006/relationships" id="260" r:id="Rc3c6a655f3f74b39"/>
-    <p:sldId xmlns:r="http://schemas.openxmlformats.org/officeDocument/2006/relationships" id="261" r:id="R0c7ad7eda89a4b63"/>
+    <p:sldId xmlns:r="http://schemas.openxmlformats.org/officeDocument/2006/relationships" id="256" r:id="R29fa5a6ae2ab4f66"/>
+    <p:sldId xmlns:r="http://schemas.openxmlformats.org/officeDocument/2006/relationships" id="257" r:id="R9622feaa70d34cd1"/>
+    <p:sldId xmlns:r="http://schemas.openxmlformats.org/officeDocument/2006/relationships" id="258" r:id="R46103cfbd4424ee3"/>
+    <p:sldId xmlns:r="http://schemas.openxmlformats.org/officeDocument/2006/relationships" id="259" r:id="R3af15fb7794f4264"/>
+    <p:sldId xmlns:r="http://schemas.openxmlformats.org/officeDocument/2006/relationships" id="260" r:id="Rfd15df70ccff4fca"/>
+    <p:sldId xmlns:r="http://schemas.openxmlformats.org/officeDocument/2006/relationships" id="261" r:id="R4963a64e48e44405"/>
   </p:sldIdLst>
   <p:sldSz cx="12192000" cy="6858000"/>
   <p:notesSz cx="6858000" cy="9144000"/>
@@ -517,7 +517,7 @@
           <a:lstStyle xmlns:a="http://schemas.openxmlformats.org/drawingml/2006/main"/>
           <a:p xmlns:a="http://schemas.openxmlformats.org/drawingml/2006/main">
             <a:r>
-              <a:t>Screenshot: real running Claro UI, team-authored synthetic fixtures. Workflow: trusted test session, scoped record tools, exact versioned synthetic policy retrieval, a separate confirmation endpoint, atomic case commit, read-back verification, analyst queue. No real money movement, refunds or card blocking. Sources: README.md, docs/OPERATIONS.md, src/factored_banking/api.py and workflow.py.</a:t>
+              <a:t>Screenshot: actual local Claro UI, team-authored synthetic fixtures, with external providers disabled. The customer report preserves specific redacted allegations through transaction clarification and is labeled unverified; permitted record facts remain separate. Customer sees the text before confirming. Atomic case commit and fresh read-back precede the receipt. Analyst questions and customer replies persist as scoped, idempotent case history. No real money movement, refunds or card blocking. Sources: docs/SYSTEM_EVALUATION.md, docs/OPERATIONS.md, api.py, privacy.py, store.py and workflow.py.</a:t>
             </a:r>
           </a:p>
         </p:txBody>
@@ -587,7 +587,7 @@
           <a:lstStyle xmlns:a="http://schemas.openxmlformats.org/drawingml/2006/main"/>
           <a:p xmlns:a="http://schemas.openxmlformats.org/drawingml/2006/main">
             <a:r>
-              <a:t>Diagram objects and connectors are native/editable. Online sequence shows logical responsibility boundaries, not an exhaustive call graph. Public personas issue scoped sandbox identities, not bank customer authentication. Native SQLite persistence uses one worker, with reserved idempotency fingerprint before case side effect and fresh-connection read-back before receipt. Separate private DuckDB data/training jobs never serve organizer raw rows. Sources: docs/OPERATIONS.md, api.py, store.py, workflow.py.</a:t>
+              <a:t>Diagram objects/connectors are native and editable. Sequence shows responsibility boundaries, not an exhaustive call graph. Optional Jev one-shot classification and DeepSeek Flash composition are implemented and tested using mocked transports. Live provider inference has not been verified. No claimed provider accuracy or actual spend. Classifier never chooses identity or performs tools. Composer receives minimized permitted context and cannot replace authoritative financial facts, case receipts or policy actions. Provider attempts, validated token usage, tariff estimates, unknown cost and budget reservations are separately accounted. Public personas are sandbox identities. SQLite uses reserved idempotency fingerprints and fresh read-back. Private DuckDB jobs never serve organizer raw rows. Sources: docs/AI_PROVIDERS.md, docs/OPERATIONS.md, api.py, providers.py, privacy.py, store.py, workflow.py.</a:t>
             </a:r>
           </a:p>
         </p:txBody>
@@ -727,7 +727,7 @@
           <a:lstStyle xmlns:a="http://schemas.openxmlformats.org/drawingml/2006/main"/>
           <a:p xmlns:a="http://schemas.openxmlformats.org/drawingml/2006/main">
             <a:r>
-              <a:t>Sources: docs/LANGUAGE_EVALUATION.md, docs/SYSTEM_EVALUATION.md, docs/evidence/language-evaluation.json, system-challenge-evaluation.json. Component: training196/development56/test140 balanced synthetic cases, frozen semantic groups. Local ML TF-IDF/logistic117/140 macroF10.8230; rules65/140 F10.4207; local Gemma3 4B115/140 F10.8045. Small ML/Gemma difference is not claimed significant. Fresh system first pass61/70 versus43/70. Learned ES31/35, PT30/35, required verified handoffs28/30, unnecessary proposals4/70. Labels/translations are assistant-authored without independent human/native-language review. Author saw earlier workflow code, so not externally blinded. Model API spend0 excludes electricity/hardware/hosting. First-pass workflow sources remain immutable; later fixes are regression, not untouched validation.</a:t>
+              <a:t>Sources: docs/LANGUAGE_EVALUATION.md, docs/SYSTEM_EVALUATION.md and aggregate evidence. Component train196/development56/test140 uses frozen semantic groups. Local TF-IDF/logistic117/140 macroF10.8230; rules65/140 F10.4207; local Gemma3 4B115/140 F10.8045. Small ML/Gemma difference is not claimed significant. Workflow figure is request-preservation-v2 current local regression. First untouched challenge remains61/70 learned versus43/70 rules, with28/30 required transfers. Separate exposed regression 63/70 follows fixes; it is never relabeled blind. Six strata contain140 unique utterances and70 semantic pairs, counterbalanced ES/PT,840replays/system. These are selected-transaction status/currency groups, not demographic fairness. All labels/translations are assistant-authored without independent human/native-language review. Fresh prospective70 is frozen but unscored. Zero offline provider attempts do not establish free provider inference. No hardware/hosting or representative customer cost claim.</a:t>
             </a:r>
           </a:p>
         </p:txBody>
@@ -797,7 +797,7 @@
           <a:lstStyle xmlns:a="http://schemas.openxmlformats.org/drawingml/2006/main"/>
           <a:p xmlns:a="http://schemas.openxmlformats.org/drawingml/2006/main">
             <a:r>
-              <a:t>Repository: https://github.com/nicoceron/factored-hackathon-2026-nicoceron . Deployed URL only appears as verified when submission/deployment.json verified=true, supplied after root verifies live service. Until then the editable deck clearly states pending. Screenshot is a real running sandbox UI with team fixtures. Free-host filesystem may reset. Source docs/OPERATIONS.md and submission/deployment.json. Next deployment gates include independent labels/language review, real bank entitlements/MFA, approved jurisdiction/product policies, durable transactional data, monitored rollout, privacy/retention controls and operational human staffing. No real-bank operation or production readiness certification.</a:t>
+              <a:t>Repository: https://github.com/nicoceron/factored-hackathon-2026-nicoceron . Public URL is tied to the commit and verification date in submission/deployment.json. Current local screenshots do not independently prove that a newer branch is deployed. Optional Jev/DeepSeek adapters are implemented/mocked but live inference remains unverified pending authorized metered use. External tariff estimates are not invoice spend. Screenshot is the actual local app using team fixtures and disabled providers. Free-host filesystem may reset. Sources: docs/AI_PROVIDERS.md, docs/OPERATIONS.md and submission/deployment.json. Real-bank requirements include approved identity/entitlements/MFA/policies, durable data, monitored rollout, privacy controls, independent ES/PT review and staffing. Organizer submission is intentionally outside requested scope. No real-bank operation or production safety certification.</a:t>
             </a:r>
           </a:p>
         </p:txBody>
@@ -865,7 +865,7 @@
   </p:cSld>
   <p:clrMap bg1="lt1" tx1="dk1" bg2="lt2" tx2="dk2" accent1="accent1" accent2="accent2" accent3="accent3" accent4="accent4" accent5="accent5" accent6="accent6" hlink="hlink" folHlink="folHlink"/>
   <p:sldLayoutIdLst>
-    <p:sldLayoutId xmlns:r="http://schemas.openxmlformats.org/officeDocument/2006/relationships" id="2147483649" r:id="R7f3a373be0b84e07"/>
+    <p:sldLayoutId xmlns:r="http://schemas.openxmlformats.org/officeDocument/2006/relationships" id="2147483649" r:id="R0f03c26ae4a54025"/>
   </p:sldLayoutIdLst>
   <p:txStyles>
     <p:titleStyle>
@@ -2149,7 +2149,7 @@
                         <a:ea typeface="Noto Sans"/>
                         <a:cs typeface="Noto Sans"/>
                       </a:rPr>
-                      <a:t>43 / 70</a:t>
+                      <a:t>77 / 140</a:t>
                     </a:r>
                   </a:p>
                 </c:rich>
@@ -2194,7 +2194,7 @@
                         <a:ea typeface="Noto Sans"/>
                         <a:cs typeface="Noto Sans"/>
                       </a:rPr>
-                      <a:t>61 / 70</a:t>
+                      <a:t>122 / 140</a:t>
                     </a:r>
                   </a:p>
                 </c:rich>
@@ -2245,7 +2245,7 @@
                 <c:formatCode>0%</c:formatCode>
                 <c:ptCount val="2"/>
                 <c:pt idx="0">
-                  <c:v>0.614285714</c:v>
+                  <c:v>0.55</c:v>
                 </c:pt>
                 <c:pt idx="1">
                   <c:v>0.871428571</c:v>
@@ -2409,7 +2409,7 @@
           <p:cNvPr id="10" name="">
             <a:extLst xmlns:a="http://schemas.openxmlformats.org/drawingml/2006/main">
               <a:ext uri="{FF2B5EF4-FFF2-40B4-BE49-F238E27FC236}">
-                <a16:creationId xmlns:a16="http://schemas.microsoft.com/office/drawing/2014/main" id="{69D90226-8822-4D26-90FF-2DFF1E596D99}"/>
+                <a16:creationId xmlns:a16="http://schemas.microsoft.com/office/drawing/2014/main" id="{E90D1040-AD79-4BD0-B659-5A892027A2F9}"/>
               </a:ext>
             </a:extLst>
           </p:cNvPr>
@@ -2466,7 +2466,7 @@
           <p:cNvPr id="2" name="">
             <a:extLst xmlns:a="http://schemas.openxmlformats.org/drawingml/2006/main">
               <a:ext uri="{FF2B5EF4-FFF2-40B4-BE49-F238E27FC236}">
-                <a16:creationId xmlns:a16="http://schemas.microsoft.com/office/drawing/2014/main" id="{914D27B5-8994-42AA-A977-5ED5334AF134}"/>
+                <a16:creationId xmlns:a16="http://schemas.microsoft.com/office/drawing/2014/main" id="{A47BC5E6-28D2-4DCD-A00B-43EFE43644A7}"/>
               </a:ext>
             </a:extLst>
           </p:cNvPr>
@@ -2546,7 +2546,7 @@
           <p:cNvPr id="3" name="">
             <a:extLst xmlns:a="http://schemas.openxmlformats.org/drawingml/2006/main">
               <a:ext uri="{FF2B5EF4-FFF2-40B4-BE49-F238E27FC236}">
-                <a16:creationId xmlns:a16="http://schemas.microsoft.com/office/drawing/2014/main" id="{171A5E72-4D05-4B81-ABC1-C47BE1210A90}"/>
+                <a16:creationId xmlns:a16="http://schemas.microsoft.com/office/drawing/2014/main" id="{B0495FCD-857F-43CC-A234-346CC5A2CB3D}"/>
               </a:ext>
             </a:extLst>
           </p:cNvPr>
@@ -2626,7 +2626,7 @@
           <p:cNvPr id="4" name="">
             <a:extLst xmlns:a="http://schemas.openxmlformats.org/drawingml/2006/main">
               <a:ext uri="{FF2B5EF4-FFF2-40B4-BE49-F238E27FC236}">
-                <a16:creationId xmlns:a16="http://schemas.microsoft.com/office/drawing/2014/main" id="{FE451530-5E92-4321-AB27-AAD1496FC93D}"/>
+                <a16:creationId xmlns:a16="http://schemas.microsoft.com/office/drawing/2014/main" id="{A778DC8E-C406-4EE7-A838-A2D8CBEF4A6B}"/>
               </a:ext>
             </a:extLst>
           </p:cNvPr>
@@ -2683,7 +2683,7 @@
           <p:cNvPr id="5" name="">
             <a:extLst xmlns:a="http://schemas.openxmlformats.org/drawingml/2006/main">
               <a:ext uri="{FF2B5EF4-FFF2-40B4-BE49-F238E27FC236}">
-                <a16:creationId xmlns:a16="http://schemas.microsoft.com/office/drawing/2014/main" id="{F34778F1-F2AA-40BA-B3EE-C82EF23F3D69}"/>
+                <a16:creationId xmlns:a16="http://schemas.microsoft.com/office/drawing/2014/main" id="{5440CA68-3E02-4852-9174-E2D1D753FD81}"/>
               </a:ext>
             </a:extLst>
           </p:cNvPr>
@@ -2740,7 +2740,7 @@
           <p:cNvPr id="6" name="">
             <a:extLst xmlns:a="http://schemas.openxmlformats.org/drawingml/2006/main">
               <a:ext uri="{FF2B5EF4-FFF2-40B4-BE49-F238E27FC236}">
-                <a16:creationId xmlns:a16="http://schemas.microsoft.com/office/drawing/2014/main" id="{AC84122E-7542-4A32-8114-7CDB10E8E520}"/>
+                <a16:creationId xmlns:a16="http://schemas.microsoft.com/office/drawing/2014/main" id="{8D1E7D37-FC2D-44EE-97F3-04CD5E3EA0A5}"/>
               </a:ext>
             </a:extLst>
           </p:cNvPr>
@@ -2797,7 +2797,7 @@
           <p:cNvPr id="7" name="">
             <a:extLst xmlns:a="http://schemas.openxmlformats.org/drawingml/2006/main">
               <a:ext uri="{FF2B5EF4-FFF2-40B4-BE49-F238E27FC236}">
-                <a16:creationId xmlns:a16="http://schemas.microsoft.com/office/drawing/2014/main" id="{44F6566C-B583-4E97-828D-2B1E99E7E29C}"/>
+                <a16:creationId xmlns:a16="http://schemas.microsoft.com/office/drawing/2014/main" id="{E2DCAD9C-92B4-452D-8306-E99710E0D1A6}"/>
               </a:ext>
             </a:extLst>
           </p:cNvPr>
@@ -2877,7 +2877,7 @@
           <p:cNvPr id="8" name="">
             <a:extLst xmlns:a="http://schemas.openxmlformats.org/drawingml/2006/main">
               <a:ext uri="{FF2B5EF4-FFF2-40B4-BE49-F238E27FC236}">
-                <a16:creationId xmlns:a16="http://schemas.microsoft.com/office/drawing/2014/main" id="{BD8A4836-8D41-4E48-9004-03C60A73B949}"/>
+                <a16:creationId xmlns:a16="http://schemas.microsoft.com/office/drawing/2014/main" id="{47A7FCD2-5C73-4252-9D8E-ECE0A7DAA268}"/>
               </a:ext>
             </a:extLst>
           </p:cNvPr>
@@ -2934,7 +2934,7 @@
           <p:cNvPr id="9" name="">
             <a:extLst xmlns:a="http://schemas.openxmlformats.org/drawingml/2006/main">
               <a:ext uri="{FF2B5EF4-FFF2-40B4-BE49-F238E27FC236}">
-                <a16:creationId xmlns:a16="http://schemas.microsoft.com/office/drawing/2014/main" id="{05490F93-361B-4B8E-B5B5-27F61F60D96C}"/>
+                <a16:creationId xmlns:a16="http://schemas.microsoft.com/office/drawing/2014/main" id="{3741C0F0-968D-4BDE-AAD4-6880DB40CC7B}"/>
               </a:ext>
             </a:extLst>
           </p:cNvPr>
@@ -2989,7 +2989,7 @@
     </p:spTree>
     <p:extLst>
       <p:ext uri="{BB962C8B-B14F-4D97-AF65-F5344CB8AC3E}">
-        <p14:creationId xmlns:p14="http://schemas.microsoft.com/office/powerpoint/2010/main" val="1818900643"/>
+        <p14:creationId xmlns:p14="http://schemas.microsoft.com/office/powerpoint/2010/main" val="859109147"/>
       </p:ext>
     </p:extLst>
   </p:cSld>
@@ -3020,7 +3020,7 @@
           <p:cNvPr id="10" name="">
             <a:extLst xmlns:a="http://schemas.openxmlformats.org/drawingml/2006/main">
               <a:ext uri="{FF2B5EF4-FFF2-40B4-BE49-F238E27FC236}">
-                <a16:creationId xmlns:a16="http://schemas.microsoft.com/office/drawing/2014/main" id="{4C5B212B-6EED-4EBD-943D-EF3E9791B3F1}"/>
+                <a16:creationId xmlns:a16="http://schemas.microsoft.com/office/drawing/2014/main" id="{79EE69BA-6015-4779-9C44-3E422D74E76B}"/>
               </a:ext>
             </a:extLst>
           </p:cNvPr>
@@ -3067,7 +3067,7 @@
                 <a:ea typeface="Noto Sans"/>
                 <a:cs typeface="Noto Sans"/>
               </a:rPr>
-              <a:t>Customer evidence and verified cases</a:t>
+              <a:t>Specific requests, verified cases and follow-up</a:t>
             </a:r>
           </a:p>
         </p:txBody>
@@ -3077,7 +3077,7 @@
           <p:cNvPr id="2" name="">
             <a:extLst xmlns:a="http://schemas.openxmlformats.org/drawingml/2006/main">
               <a:ext uri="{FF2B5EF4-FFF2-40B4-BE49-F238E27FC236}">
-                <a16:creationId xmlns:a16="http://schemas.microsoft.com/office/drawing/2014/main" id="{694FC903-944E-4A84-8C3F-BBED67504914}"/>
+                <a16:creationId xmlns:a16="http://schemas.microsoft.com/office/drawing/2014/main" id="{33F0BC40-032C-4F45-A95F-E9AD87AB00DF}"/>
               </a:ext>
             </a:extLst>
           </p:cNvPr>
@@ -3138,13 +3138,16 @@
           <p:nvPr/>
         </p:nvPicPr>
         <p:blipFill>
-          <a:blip xmlns:r="http://schemas.openxmlformats.org/officeDocument/2006/relationships" xmlns:a="http://schemas.openxmlformats.org/drawingml/2006/main" r:embed="Recaf6e4f693b4785"/>
-          <a:stretch xmlns:a="http://schemas.openxmlformats.org/drawingml/2006/main"/>
+          <a:blip xmlns:r="http://schemas.openxmlformats.org/officeDocument/2006/relationships" xmlns:a="http://schemas.openxmlformats.org/drawingml/2006/main" r:embed="R4ab8a7d441bc4fe3"/>
+          <a:srcRect xmlns:a="http://schemas.openxmlformats.org/drawingml/2006/main" l="0" t="8158" r="0" b="8158"/>
+          <a:stretch xmlns:a="http://schemas.openxmlformats.org/drawingml/2006/main">
+            <a:fillRect l="0" t="0" r="0" b="0"/>
+          </a:stretch>
         </p:blipFill>
         <p:spPr>
           <a:xfrm xmlns:a="http://schemas.openxmlformats.org/drawingml/2006/main">
-            <a:off x="1036227" y="1647825"/>
-            <a:ext cx="6538146" cy="4314825"/>
+            <a:off x="609600" y="1647825"/>
+            <a:ext cx="7391400" cy="4314825"/>
           </a:xfrm>
           <a:prstGeom xmlns:a="http://schemas.openxmlformats.org/drawingml/2006/main" prst="rect">
             <a:avLst/>
@@ -3156,7 +3159,7 @@
           <p:cNvPr id="4" name="">
             <a:extLst xmlns:a="http://schemas.openxmlformats.org/drawingml/2006/main">
               <a:ext uri="{FF2B5EF4-FFF2-40B4-BE49-F238E27FC236}">
-                <a16:creationId xmlns:a16="http://schemas.microsoft.com/office/drawing/2014/main" id="{C7D716FC-5900-46A6-B272-0E6C90249ABE}"/>
+                <a16:creationId xmlns:a16="http://schemas.microsoft.com/office/drawing/2014/main" id="{EC6B5BE2-FE44-496C-952F-18AA74F4A2C2}"/>
               </a:ext>
             </a:extLst>
           </p:cNvPr>
@@ -3203,7 +3206,7 @@
                 <a:ea typeface="Noto Sans"/>
                 <a:cs typeface="Noto Sans"/>
               </a:rPr>
-              <a:t>1  Understand</a:t>
+              <a:t>1  Preserve the request</a:t>
             </a:r>
           </a:p>
         </p:txBody>
@@ -3213,7 +3216,7 @@
           <p:cNvPr id="5" name="">
             <a:extLst xmlns:a="http://schemas.openxmlformats.org/drawingml/2006/main">
               <a:ext uri="{FF2B5EF4-FFF2-40B4-BE49-F238E27FC236}">
-                <a16:creationId xmlns:a16="http://schemas.microsoft.com/office/drawing/2014/main" id="{25372C9C-8BDE-42BD-A47C-B3CFBB60A0FA}"/>
+                <a16:creationId xmlns:a16="http://schemas.microsoft.com/office/drawing/2014/main" id="{88353A29-D938-40B4-908A-131B05E39DEC}"/>
               </a:ext>
             </a:extLst>
           </p:cNvPr>
@@ -3260,7 +3263,7 @@
                 <a:ea typeface="Noto Sans"/>
                 <a:cs typeface="Noto Sans"/>
               </a:rPr>
-              <a:t>Ask for the transaction</a:t>
+              <a:t>Retain redacted customer</a:t>
             </a:r>
           </a:p>
           <a:p xmlns:a="http://schemas.openxmlformats.org/drawingml/2006/main">
@@ -3283,7 +3286,7 @@
                 <a:ea typeface="Noto Sans"/>
                 <a:cs typeface="Noto Sans"/>
               </a:rPr>
-              <a:t>when the request is unclear.</a:t>
+              <a:t>words beside verified facts.</a:t>
             </a:r>
           </a:p>
         </p:txBody>
@@ -3293,7 +3296,7 @@
           <p:cNvPr id="6" name="">
             <a:extLst xmlns:a="http://schemas.openxmlformats.org/drawingml/2006/main">
               <a:ext uri="{FF2B5EF4-FFF2-40B4-BE49-F238E27FC236}">
-                <a16:creationId xmlns:a16="http://schemas.microsoft.com/office/drawing/2014/main" id="{5DB2FD48-575F-45FA-82A5-9F0E0BA5C43E}"/>
+                <a16:creationId xmlns:a16="http://schemas.microsoft.com/office/drawing/2014/main" id="{46B0BE49-4F7D-47F7-BB63-F2C27506FDCC}"/>
               </a:ext>
             </a:extLst>
           </p:cNvPr>
@@ -3340,7 +3343,7 @@
                 <a:ea typeface="Noto Sans"/>
                 <a:cs typeface="Noto Sans"/>
               </a:rPr>
-              <a:t>2  Show the evidence</a:t>
+              <a:t>2  Confirm and verify</a:t>
             </a:r>
           </a:p>
         </p:txBody>
@@ -3350,7 +3353,7 @@
           <p:cNvPr id="7" name="">
             <a:extLst xmlns:a="http://schemas.openxmlformats.org/drawingml/2006/main">
               <a:ext uri="{FF2B5EF4-FFF2-40B4-BE49-F238E27FC236}">
-                <a16:creationId xmlns:a16="http://schemas.microsoft.com/office/drawing/2014/main" id="{738C808B-E04F-4F01-9135-EDEB80527C4D}"/>
+                <a16:creationId xmlns:a16="http://schemas.microsoft.com/office/drawing/2014/main" id="{E8752C21-55EC-4280-B2FF-6CAA4B9CB30D}"/>
               </a:ext>
             </a:extLst>
           </p:cNvPr>
@@ -3397,7 +3400,7 @@
                 <a:ea typeface="Noto Sans"/>
                 <a:cs typeface="Noto Sans"/>
               </a:rPr>
-              <a:t>Preserve amount, currency,</a:t>
+              <a:t>Commit one sandbox case.</a:t>
             </a:r>
           </a:p>
           <a:p xmlns:a="http://schemas.openxmlformats.org/drawingml/2006/main">
@@ -3420,7 +3423,7 @@
                 <a:ea typeface="Noto Sans"/>
                 <a:cs typeface="Noto Sans"/>
               </a:rPr>
-              <a:t>status and historical source.</a:t>
+              <a:t>Read it back before success.</a:t>
             </a:r>
           </a:p>
         </p:txBody>
@@ -3430,7 +3433,7 @@
           <p:cNvPr id="8" name="">
             <a:extLst xmlns:a="http://schemas.openxmlformats.org/drawingml/2006/main">
               <a:ext uri="{FF2B5EF4-FFF2-40B4-BE49-F238E27FC236}">
-                <a16:creationId xmlns:a16="http://schemas.microsoft.com/office/drawing/2014/main" id="{2F2BD79F-EE3F-4F4E-9302-21405C6A5C3C}"/>
+                <a16:creationId xmlns:a16="http://schemas.microsoft.com/office/drawing/2014/main" id="{6FC4D793-456B-4E54-8DF3-4828455FC692}"/>
               </a:ext>
             </a:extLst>
           </p:cNvPr>
@@ -3477,7 +3480,7 @@
                 <a:ea typeface="Noto Sans"/>
                 <a:cs typeface="Noto Sans"/>
               </a:rPr>
-              <a:t>3  Confirm and verify</a:t>
+              <a:t>3  Persist follow-up</a:t>
             </a:r>
           </a:p>
         </p:txBody>
@@ -3487,7 +3490,7 @@
           <p:cNvPr id="9" name="">
             <a:extLst xmlns:a="http://schemas.openxmlformats.org/drawingml/2006/main">
               <a:ext uri="{FF2B5EF4-FFF2-40B4-BE49-F238E27FC236}">
-                <a16:creationId xmlns:a16="http://schemas.microsoft.com/office/drawing/2014/main" id="{3411FAA1-235E-4509-B4B7-53DD8795C97A}"/>
+                <a16:creationId xmlns:a16="http://schemas.microsoft.com/office/drawing/2014/main" id="{C82DB530-25C6-42EE-A7DB-E84138EAABB4}"/>
               </a:ext>
             </a:extLst>
           </p:cNvPr>
@@ -3534,7 +3537,7 @@
                 <a:ea typeface="Noto Sans"/>
                 <a:cs typeface="Noto Sans"/>
               </a:rPr>
-              <a:t>Create one sandbox case.</a:t>
+              <a:t>Save the analyst question,</a:t>
             </a:r>
           </a:p>
           <a:p xmlns:a="http://schemas.openxmlformats.org/drawingml/2006/main">
@@ -3557,7 +3560,7 @@
                 <a:ea typeface="Noto Sans"/>
                 <a:cs typeface="Noto Sans"/>
               </a:rPr>
-              <a:t>Read it back before success.</a:t>
+              <a:t>customer reply and status.</a:t>
             </a:r>
           </a:p>
         </p:txBody>
@@ -3565,7 +3568,7 @@
     </p:spTree>
     <p:extLst>
       <p:ext uri="{BB962C8B-B14F-4D97-AF65-F5344CB8AC3E}">
-        <p14:creationId xmlns:p14="http://schemas.microsoft.com/office/powerpoint/2010/main" val="1986978378"/>
+        <p14:creationId xmlns:p14="http://schemas.microsoft.com/office/powerpoint/2010/main" val="369806862"/>
       </p:ext>
     </p:extLst>
   </p:cSld>
@@ -3596,7 +3599,7 @@
           <p:cNvPr id="19" name="">
             <a:extLst xmlns:a="http://schemas.openxmlformats.org/drawingml/2006/main">
               <a:ext uri="{FF2B5EF4-FFF2-40B4-BE49-F238E27FC236}">
-                <a16:creationId xmlns:a16="http://schemas.microsoft.com/office/drawing/2014/main" id="{8659CC21-7ABD-4147-AEF3-803788E299B7}"/>
+                <a16:creationId xmlns:a16="http://schemas.microsoft.com/office/drawing/2014/main" id="{48DD85EA-F621-4887-BBB9-5331E6D9FEB1}"/>
               </a:ext>
             </a:extLst>
           </p:cNvPr>
@@ -3653,7 +3656,7 @@
           <p:cNvPr id="2" name="">
             <a:extLst xmlns:a="http://schemas.openxmlformats.org/drawingml/2006/main">
               <a:ext uri="{FF2B5EF4-FFF2-40B4-BE49-F238E27FC236}">
-                <a16:creationId xmlns:a16="http://schemas.microsoft.com/office/drawing/2014/main" id="{5AF073DF-DD84-4CA8-849F-005FD98A737B}"/>
+                <a16:creationId xmlns:a16="http://schemas.microsoft.com/office/drawing/2014/main" id="{AD223706-5504-4582-BE8D-BE9160266CDA}"/>
               </a:ext>
             </a:extLst>
           </p:cNvPr>
@@ -3710,7 +3713,7 @@
           <p:cNvPr id="3" name="">
             <a:extLst xmlns:a="http://schemas.openxmlformats.org/drawingml/2006/main">
               <a:ext uri="{FF2B5EF4-FFF2-40B4-BE49-F238E27FC236}">
-                <a16:creationId xmlns:a16="http://schemas.microsoft.com/office/drawing/2014/main" id="{CF12D48C-F727-40E6-BD68-09EEDFB9A0CC}"/>
+                <a16:creationId xmlns:a16="http://schemas.microsoft.com/office/drawing/2014/main" id="{B7A43573-474A-48DF-8227-5E29949B85A0}"/>
               </a:ext>
             </a:extLst>
           </p:cNvPr>
@@ -3757,7 +3760,7 @@
                 <a:ea typeface="Noto Sans"/>
                 <a:cs typeface="Noto Sans"/>
               </a:rPr>
-              <a:t>The model advises the workflow. It cannot select an identity or execute a banking action.</a:t>
+              <a:t>Optional providers are implemented and mock-tested. Live inference remains unverified.</a:t>
             </a:r>
           </a:p>
         </p:txBody>
@@ -3767,7 +3770,7 @@
           <p:cNvPr id="4" name="">
             <a:extLst xmlns:a="http://schemas.openxmlformats.org/drawingml/2006/main">
               <a:ext uri="{FF2B5EF4-FFF2-40B4-BE49-F238E27FC236}">
-                <a16:creationId xmlns:a16="http://schemas.microsoft.com/office/drawing/2014/main" id="{9546601A-DE57-4A0E-9A2A-DDB7D8977396}"/>
+                <a16:creationId xmlns:a16="http://schemas.microsoft.com/office/drawing/2014/main" id="{E30FF52F-2DA1-4735-8B6E-C3F42E59D639}"/>
               </a:ext>
             </a:extLst>
           </p:cNvPr>
@@ -3826,7 +3829,7 @@
           <p:cNvPr id="5" name="">
             <a:extLst xmlns:a="http://schemas.openxmlformats.org/drawingml/2006/main">
               <a:ext uri="{FF2B5EF4-FFF2-40B4-BE49-F238E27FC236}">
-                <a16:creationId xmlns:a16="http://schemas.microsoft.com/office/drawing/2014/main" id="{03C94C81-488C-4356-8F1B-86B8EFBFDB62}"/>
+                <a16:creationId xmlns:a16="http://schemas.microsoft.com/office/drawing/2014/main" id="{5D9B76A0-E26D-4715-A57D-C232BA2A906C}"/>
               </a:ext>
             </a:extLst>
           </p:cNvPr>
@@ -3908,7 +3911,7 @@
           <p:cNvPr id="6" name="">
             <a:extLst xmlns:a="http://schemas.openxmlformats.org/drawingml/2006/main">
               <a:ext uri="{FF2B5EF4-FFF2-40B4-BE49-F238E27FC236}">
-                <a16:creationId xmlns:a16="http://schemas.microsoft.com/office/drawing/2014/main" id="{075C2342-F14E-40B6-8D22-1CCCBB4D835D}"/>
+                <a16:creationId xmlns:a16="http://schemas.microsoft.com/office/drawing/2014/main" id="{8AEDA6F6-86B3-459F-B929-6CD1BAA29EE7}"/>
               </a:ext>
             </a:extLst>
           </p:cNvPr>
@@ -3957,7 +3960,7 @@
                 <a:ea typeface="Noto Sans"/>
                 <a:cs typeface="Noto Sans"/>
               </a:rPr>
-              <a:t>Local language</a:t>
+              <a:t>Jev or local</a:t>
             </a:r>
           </a:p>
           <a:p xmlns:a="http://schemas.openxmlformats.org/drawingml/2006/main">
@@ -3980,7 +3983,7 @@
                 <a:ea typeface="Noto Sans"/>
                 <a:cs typeface="Noto Sans"/>
               </a:rPr>
-              <a:t>classifier</a:t>
+              <a:t>routing</a:t>
             </a:r>
           </a:p>
         </p:txBody>
@@ -3990,7 +3993,7 @@
           <p:cNvPr id="7" name="">
             <a:extLst xmlns:a="http://schemas.openxmlformats.org/drawingml/2006/main">
               <a:ext uri="{FF2B5EF4-FFF2-40B4-BE49-F238E27FC236}">
-                <a16:creationId xmlns:a16="http://schemas.microsoft.com/office/drawing/2014/main" id="{22D37600-406B-4A4F-A54A-072B7460B972}"/>
+                <a16:creationId xmlns:a16="http://schemas.microsoft.com/office/drawing/2014/main" id="{BDD3DA9E-00D9-4EB5-92B0-F69AFDB3471D}"/>
               </a:ext>
             </a:extLst>
           </p:cNvPr>
@@ -4072,7 +4075,7 @@
           <p:cNvPr id="8" name="">
             <a:extLst xmlns:a="http://schemas.openxmlformats.org/drawingml/2006/main">
               <a:ext uri="{FF2B5EF4-FFF2-40B4-BE49-F238E27FC236}">
-                <a16:creationId xmlns:a16="http://schemas.microsoft.com/office/drawing/2014/main" id="{2E835290-C18E-420D-B969-C265F7931515}"/>
+                <a16:creationId xmlns:a16="http://schemas.microsoft.com/office/drawing/2014/main" id="{AC024DCA-B7E8-4973-8501-EC7DE0FF6A29}"/>
               </a:ext>
             </a:extLst>
           </p:cNvPr>
@@ -4121,7 +4124,7 @@
                 <a:ea typeface="Noto Sans"/>
                 <a:cs typeface="Noto Sans"/>
               </a:rPr>
-              <a:t>Receipt and</a:t>
+              <a:t>Case history</a:t>
             </a:r>
           </a:p>
           <a:p xmlns:a="http://schemas.openxmlformats.org/drawingml/2006/main">
@@ -4144,7 +4147,7 @@
                 <a:ea typeface="Noto Sans"/>
                 <a:cs typeface="Noto Sans"/>
               </a:rPr>
-              <a:t>analyst queue</a:t>
+              <a:t>and follow-up</a:t>
             </a:r>
           </a:p>
         </p:txBody>
@@ -4154,7 +4157,7 @@
           <p:cNvPr id="9" name="">
             <a:extLst xmlns:a="http://schemas.openxmlformats.org/drawingml/2006/main">
               <a:ext uri="{FF2B5EF4-FFF2-40B4-BE49-F238E27FC236}">
-                <a16:creationId xmlns:a16="http://schemas.microsoft.com/office/drawing/2014/main" id="{16513AF1-5CE0-4E6D-9150-F3CDB10E2D11}"/>
+                <a16:creationId xmlns:a16="http://schemas.microsoft.com/office/drawing/2014/main" id="{C8CD0C96-638D-4806-8DC2-15EF555C04A7}"/>
               </a:ext>
             </a:extLst>
           </p:cNvPr>
@@ -4236,7 +4239,7 @@
           <p:cNvPr id="10" name="">
             <a:extLst xmlns:a="http://schemas.openxmlformats.org/drawingml/2006/main">
               <a:ext uri="{FF2B5EF4-FFF2-40B4-BE49-F238E27FC236}">
-                <a16:creationId xmlns:a16="http://schemas.microsoft.com/office/drawing/2014/main" id="{5048C8B4-63B0-4B7D-8A14-6F87BA677956}"/>
+                <a16:creationId xmlns:a16="http://schemas.microsoft.com/office/drawing/2014/main" id="{46F756A0-B5C5-46A8-AE7D-60D6EA771E54}"/>
               </a:ext>
             </a:extLst>
           </p:cNvPr>
@@ -4468,7 +4471,7 @@
           <p:cNvPr id="17" name="">
             <a:extLst xmlns:a="http://schemas.openxmlformats.org/drawingml/2006/main">
               <a:ext uri="{FF2B5EF4-FFF2-40B4-BE49-F238E27FC236}">
-                <a16:creationId xmlns:a16="http://schemas.microsoft.com/office/drawing/2014/main" id="{DA64CDCC-7443-4D4A-931A-C8E7F8CF2388}"/>
+                <a16:creationId xmlns:a16="http://schemas.microsoft.com/office/drawing/2014/main" id="{0C4ABB0C-EA1B-4BDE-9B09-D9C164436701}"/>
               </a:ext>
             </a:extLst>
           </p:cNvPr>
@@ -4479,8 +4482,8 @@
         </p:nvSpPr>
         <p:spPr>
           <a:xfrm xmlns:a="http://schemas.openxmlformats.org/drawingml/2006/main">
-            <a:off x="609600" y="4324350"/>
-            <a:ext cx="2333625" cy="838200"/>
+            <a:off x="609600" y="4286250"/>
+            <a:ext cx="2590800" cy="1009650"/>
           </a:xfrm>
           <a:prstGeom xmlns:a="http://schemas.openxmlformats.org/drawingml/2006/main" prst="rect">
             <a:avLst/>
@@ -4497,7 +4500,7 @@
           <a:lstStyle xmlns:a="http://schemas.openxmlformats.org/drawingml/2006/main"/>
           <a:p xmlns:a="http://schemas.openxmlformats.org/drawingml/2006/main">
             <a:pPr algn="l">
-              <a:defRPr sz="1725" b="0">
+              <a:defRPr sz="1650" b="0">
                 <a:solidFill>
                   <a:srgbClr val="A4B7C8"/>
                 </a:solidFill>
@@ -4507,7 +4510,7 @@
               </a:defRPr>
             </a:pPr>
             <a:r>
-              <a:rPr sz="1725" b="0">
+              <a:rPr sz="1650" b="0">
                 <a:solidFill>
                   <a:srgbClr val="A4B7C8"/>
                 </a:solidFill>
@@ -4515,12 +4518,12 @@
                 <a:ea typeface="Noto Sans"/>
                 <a:cs typeface="Noto Sans"/>
               </a:rPr>
-              <a:t>Exact fixture facts</a:t>
+              <a:t>Optional DeepSeek Flash</a:t>
             </a:r>
           </a:p>
           <a:p xmlns:a="http://schemas.openxmlformats.org/drawingml/2006/main">
             <a:pPr algn="l">
-              <a:defRPr sz="1725" b="0">
+              <a:defRPr sz="1650" b="0">
                 <a:solidFill>
                   <a:srgbClr val="A4B7C8"/>
                 </a:solidFill>
@@ -4530,7 +4533,7 @@
               </a:defRPr>
             </a:pPr>
             <a:r>
-              <a:rPr sz="1725" b="0">
+              <a:rPr sz="1650" b="0">
                 <a:solidFill>
                   <a:srgbClr val="A4B7C8"/>
                 </a:solidFill>
@@ -4538,7 +4541,30 @@
                 <a:ea typeface="Noto Sans"/>
                 <a:cs typeface="Noto Sans"/>
               </a:rPr>
-              <a:t>Versioned demo policies</a:t>
+              <a:t>phrasing with constrained</a:t>
+            </a:r>
+          </a:p>
+          <a:p xmlns:a="http://schemas.openxmlformats.org/drawingml/2006/main">
+            <a:pPr algn="l">
+              <a:defRPr sz="1650" b="0">
+                <a:solidFill>
+                  <a:srgbClr val="A4B7C8"/>
+                </a:solidFill>
+                <a:latin typeface="Noto Sans"/>
+                <a:ea typeface="Noto Sans"/>
+                <a:cs typeface="Noto Sans"/>
+              </a:defRPr>
+            </a:pPr>
+            <a:r>
+              <a:rPr sz="1650" b="0">
+                <a:solidFill>
+                  <a:srgbClr val="A4B7C8"/>
+                </a:solidFill>
+                <a:latin typeface="Noto Sans"/>
+                <a:ea typeface="Noto Sans"/>
+                <a:cs typeface="Noto Sans"/>
+              </a:rPr>
+              <a:t>facts and local fallback</a:t>
             </a:r>
           </a:p>
         </p:txBody>
@@ -4548,7 +4574,7 @@
           <p:cNvPr id="18" name="">
             <a:extLst xmlns:a="http://schemas.openxmlformats.org/drawingml/2006/main">
               <a:ext uri="{FF2B5EF4-FFF2-40B4-BE49-F238E27FC236}">
-                <a16:creationId xmlns:a16="http://schemas.microsoft.com/office/drawing/2014/main" id="{33DCC1B9-B6FD-4689-AE15-584DC7414F87}"/>
+                <a16:creationId xmlns:a16="http://schemas.microsoft.com/office/drawing/2014/main" id="{1C35C1DF-D01B-430F-844C-1D4B4A1ED99C}"/>
               </a:ext>
             </a:extLst>
           </p:cNvPr>
@@ -4603,7 +4629,7 @@
     </p:spTree>
     <p:extLst>
       <p:ext uri="{BB962C8B-B14F-4D97-AF65-F5344CB8AC3E}">
-        <p14:creationId xmlns:p14="http://schemas.microsoft.com/office/powerpoint/2010/main" val="197626147"/>
+        <p14:creationId xmlns:p14="http://schemas.microsoft.com/office/powerpoint/2010/main" val="2020346041"/>
       </p:ext>
     </p:extLst>
   </p:cSld>
@@ -4634,7 +4660,7 @@
           <p:cNvPr id="13" name="">
             <a:extLst xmlns:a="http://schemas.openxmlformats.org/drawingml/2006/main">
               <a:ext uri="{FF2B5EF4-FFF2-40B4-BE49-F238E27FC236}">
-                <a16:creationId xmlns:a16="http://schemas.microsoft.com/office/drawing/2014/main" id="{F7E4FBFC-0E79-474B-96D6-A57772A5A0C4}"/>
+                <a16:creationId xmlns:a16="http://schemas.microsoft.com/office/drawing/2014/main" id="{1A972775-8A74-4E7D-AA98-C8991AAD600B}"/>
               </a:ext>
             </a:extLst>
           </p:cNvPr>
@@ -4691,7 +4717,7 @@
           <p:cNvPr id="2" name="">
             <a:extLst xmlns:a="http://schemas.openxmlformats.org/drawingml/2006/main">
               <a:ext uri="{FF2B5EF4-FFF2-40B4-BE49-F238E27FC236}">
-                <a16:creationId xmlns:a16="http://schemas.microsoft.com/office/drawing/2014/main" id="{178FCA83-52AA-4C32-AF8C-12FD808BD95F}"/>
+                <a16:creationId xmlns:a16="http://schemas.microsoft.com/office/drawing/2014/main" id="{A8A810AB-0E98-4267-927E-0CE3C07BF9BC}"/>
               </a:ext>
             </a:extLst>
           </p:cNvPr>
@@ -4748,7 +4774,7 @@
           <p:cNvPr id="3" name="">
             <a:extLst xmlns:a="http://schemas.openxmlformats.org/drawingml/2006/main">
               <a:ext uri="{FF2B5EF4-FFF2-40B4-BE49-F238E27FC236}">
-                <a16:creationId xmlns:a16="http://schemas.microsoft.com/office/drawing/2014/main" id="{9F816263-B520-4D11-9D2A-EAB0CDD3A4D0}"/>
+                <a16:creationId xmlns:a16="http://schemas.microsoft.com/office/drawing/2014/main" id="{FED72CA0-818B-4A72-9223-E2A4B2C4C9E3}"/>
               </a:ext>
             </a:extLst>
           </p:cNvPr>
@@ -4805,7 +4831,7 @@
           <p:cNvPr id="4" name="">
             <a:extLst xmlns:a="http://schemas.openxmlformats.org/drawingml/2006/main">
               <a:ext uri="{FF2B5EF4-FFF2-40B4-BE49-F238E27FC236}">
-                <a16:creationId xmlns:a16="http://schemas.microsoft.com/office/drawing/2014/main" id="{A33ABAF7-0DDF-42EB-9BDB-75C89007469C}"/>
+                <a16:creationId xmlns:a16="http://schemas.microsoft.com/office/drawing/2014/main" id="{20C139CD-32EB-47F4-9A24-9A35F4D41081}"/>
               </a:ext>
             </a:extLst>
           </p:cNvPr>
@@ -4908,7 +4934,7 @@
           <p:cNvPr id="5" name="">
             <a:extLst xmlns:a="http://schemas.openxmlformats.org/drawingml/2006/main">
               <a:ext uri="{FF2B5EF4-FFF2-40B4-BE49-F238E27FC236}">
-                <a16:creationId xmlns:a16="http://schemas.microsoft.com/office/drawing/2014/main" id="{601BF29F-3989-4873-8BCE-BD69F85A1BF5}"/>
+                <a16:creationId xmlns:a16="http://schemas.microsoft.com/office/drawing/2014/main" id="{E37F50AA-BC62-49AC-8B6E-732B45BFF14A}"/>
               </a:ext>
             </a:extLst>
           </p:cNvPr>
@@ -4965,7 +4991,7 @@
           <p:cNvPr id="6" name="">
             <a:extLst xmlns:a="http://schemas.openxmlformats.org/drawingml/2006/main">
               <a:ext uri="{FF2B5EF4-FFF2-40B4-BE49-F238E27FC236}">
-                <a16:creationId xmlns:a16="http://schemas.microsoft.com/office/drawing/2014/main" id="{A3F694BE-0F2D-4A60-8D42-28B8EC3EBFD4}"/>
+                <a16:creationId xmlns:a16="http://schemas.microsoft.com/office/drawing/2014/main" id="{8B35FCFD-312D-48B8-9FBD-1372CDE18884}"/>
               </a:ext>
             </a:extLst>
           </p:cNvPr>
@@ -5068,7 +5094,7 @@
           <p:cNvPr id="7" name="">
             <a:extLst xmlns:a="http://schemas.openxmlformats.org/drawingml/2006/main">
               <a:ext uri="{FF2B5EF4-FFF2-40B4-BE49-F238E27FC236}">
-                <a16:creationId xmlns:a16="http://schemas.microsoft.com/office/drawing/2014/main" id="{77A6D15D-2733-4A6C-868E-F698770C5A68}"/>
+                <a16:creationId xmlns:a16="http://schemas.microsoft.com/office/drawing/2014/main" id="{45D98E21-4E7B-4C7A-921F-B112EE1DB0F5}"/>
               </a:ext>
             </a:extLst>
           </p:cNvPr>
@@ -5125,7 +5151,7 @@
           <p:cNvPr id="8" name="">
             <a:extLst xmlns:a="http://schemas.openxmlformats.org/drawingml/2006/main">
               <a:ext uri="{FF2B5EF4-FFF2-40B4-BE49-F238E27FC236}">
-                <a16:creationId xmlns:a16="http://schemas.microsoft.com/office/drawing/2014/main" id="{DAECCBD0-80D3-407B-A274-B8AE643718F6}"/>
+                <a16:creationId xmlns:a16="http://schemas.microsoft.com/office/drawing/2014/main" id="{5959AC15-E5F2-4C60-919F-9AF36917E698}"/>
               </a:ext>
             </a:extLst>
           </p:cNvPr>
@@ -5189,7 +5215,7 @@
         </p:xfrm>
         <a:graphic xmlns:a="http://schemas.openxmlformats.org/drawingml/2006/main">
           <a:graphicData uri="http://schemas.openxmlformats.org/drawingml/2006/chart">
-            <c:chart xmlns:r="http://schemas.openxmlformats.org/officeDocument/2006/relationships" xmlns:c="http://schemas.openxmlformats.org/drawingml/2006/chart" r:id="R59a0d8e30b174d95"/>
+            <c:chart xmlns:r="http://schemas.openxmlformats.org/officeDocument/2006/relationships" xmlns:c="http://schemas.openxmlformats.org/drawingml/2006/chart" r:id="R69af81f195f74134"/>
           </a:graphicData>
         </a:graphic>
       </p:graphicFrame>
@@ -5198,7 +5224,7 @@
           <p:cNvPr id="10" name="">
             <a:extLst xmlns:a="http://schemas.openxmlformats.org/drawingml/2006/main">
               <a:ext uri="{FF2B5EF4-FFF2-40B4-BE49-F238E27FC236}">
-                <a16:creationId xmlns:a16="http://schemas.microsoft.com/office/drawing/2014/main" id="{117DE1CE-72A9-485F-9709-023884B1142E}"/>
+                <a16:creationId xmlns:a16="http://schemas.microsoft.com/office/drawing/2014/main" id="{8E413214-556B-4F7B-9303-3C4BE35F0D26}"/>
               </a:ext>
             </a:extLst>
           </p:cNvPr>
@@ -5255,7 +5281,7 @@
           <p:cNvPr id="11" name="">
             <a:extLst xmlns:a="http://schemas.openxmlformats.org/drawingml/2006/main">
               <a:ext uri="{FF2B5EF4-FFF2-40B4-BE49-F238E27FC236}">
-                <a16:creationId xmlns:a16="http://schemas.microsoft.com/office/drawing/2014/main" id="{EA49D9AE-7F80-46E8-94B2-B0BB3DB2A9EB}"/>
+                <a16:creationId xmlns:a16="http://schemas.microsoft.com/office/drawing/2014/main" id="{E2A29645-D4CA-4C99-B330-F7DBDB388392}"/>
               </a:ext>
             </a:extLst>
           </p:cNvPr>
@@ -5335,7 +5361,7 @@
           <p:cNvPr id="12" name="">
             <a:extLst xmlns:a="http://schemas.openxmlformats.org/drawingml/2006/main">
               <a:ext uri="{FF2B5EF4-FFF2-40B4-BE49-F238E27FC236}">
-                <a16:creationId xmlns:a16="http://schemas.microsoft.com/office/drawing/2014/main" id="{B8264D9C-7701-430E-BB59-76BBEC250D5D}"/>
+                <a16:creationId xmlns:a16="http://schemas.microsoft.com/office/drawing/2014/main" id="{DAC0EA6E-2E63-4E98-BE44-970AB55150E7}"/>
               </a:ext>
             </a:extLst>
           </p:cNvPr>
@@ -5390,7 +5416,7 @@
     </p:spTree>
     <p:extLst>
       <p:ext uri="{BB962C8B-B14F-4D97-AF65-F5344CB8AC3E}">
-        <p14:creationId xmlns:p14="http://schemas.microsoft.com/office/powerpoint/2010/main" val="1707842607"/>
+        <p14:creationId xmlns:p14="http://schemas.microsoft.com/office/powerpoint/2010/main" val="1922396985"/>
       </p:ext>
     </p:extLst>
   </p:cSld>
@@ -5421,7 +5447,7 @@
           <p:cNvPr id="13" name="">
             <a:extLst xmlns:a="http://schemas.openxmlformats.org/drawingml/2006/main">
               <a:ext uri="{FF2B5EF4-FFF2-40B4-BE49-F238E27FC236}">
-                <a16:creationId xmlns:a16="http://schemas.microsoft.com/office/drawing/2014/main" id="{362DFD64-03B0-4888-96E6-0ED8090A0762}"/>
+                <a16:creationId xmlns:a16="http://schemas.microsoft.com/office/drawing/2014/main" id="{8884DF14-2A04-4F71-B934-670C8E14895B}"/>
               </a:ext>
             </a:extLst>
           </p:cNvPr>
@@ -5478,7 +5504,7 @@
           <p:cNvPr id="2" name="">
             <a:extLst xmlns:a="http://schemas.openxmlformats.org/drawingml/2006/main">
               <a:ext uri="{FF2B5EF4-FFF2-40B4-BE49-F238E27FC236}">
-                <a16:creationId xmlns:a16="http://schemas.microsoft.com/office/drawing/2014/main" id="{FB5E78BF-B03C-4AE2-A7AC-F6838DAF3E2E}"/>
+                <a16:creationId xmlns:a16="http://schemas.microsoft.com/office/drawing/2014/main" id="{BEB3EF82-A594-4337-A880-3BF4D4D3C750}"/>
               </a:ext>
             </a:extLst>
           </p:cNvPr>
@@ -5535,7 +5561,7 @@
           <p:cNvPr id="3" name="">
             <a:extLst xmlns:a="http://schemas.openxmlformats.org/drawingml/2006/main">
               <a:ext uri="{FF2B5EF4-FFF2-40B4-BE49-F238E27FC236}">
-                <a16:creationId xmlns:a16="http://schemas.microsoft.com/office/drawing/2014/main" id="{A842DBCF-19F2-403C-B753-6123B8550288}"/>
+                <a16:creationId xmlns:a16="http://schemas.microsoft.com/office/drawing/2014/main" id="{4C6988F4-40F0-447D-ADAD-0990AF7BA8AC}"/>
               </a:ext>
             </a:extLst>
           </p:cNvPr>
@@ -5592,7 +5618,7 @@
           <p:cNvPr id="4" name="">
             <a:extLst xmlns:a="http://schemas.openxmlformats.org/drawingml/2006/main">
               <a:ext uri="{FF2B5EF4-FFF2-40B4-BE49-F238E27FC236}">
-                <a16:creationId xmlns:a16="http://schemas.microsoft.com/office/drawing/2014/main" id="{FBA2948E-236F-4F1A-A6C6-DC3281F8D63D}"/>
+                <a16:creationId xmlns:a16="http://schemas.microsoft.com/office/drawing/2014/main" id="{CA5161D5-DE60-4D1D-8631-2AED03ED0C4F}"/>
               </a:ext>
             </a:extLst>
           </p:cNvPr>
@@ -5651,12 +5677,12 @@
           <p:nvPr/>
         </p:nvGraphicFramePr>
         <p:xfrm>
-          <a:off xmlns:a="http://schemas.openxmlformats.org/drawingml/2006/main" x="581025" y="2409825"/>
-          <a:ext xmlns:a="http://schemas.openxmlformats.org/drawingml/2006/main" cx="5191125" cy="2733675"/>
+          <a:off xmlns:a="http://schemas.openxmlformats.org/drawingml/2006/main" x="581025" y="2352675"/>
+          <a:ext xmlns:a="http://schemas.openxmlformats.org/drawingml/2006/main" cx="5191125" cy="2638425"/>
         </p:xfrm>
         <a:graphic xmlns:a="http://schemas.openxmlformats.org/drawingml/2006/main">
           <a:graphicData uri="http://schemas.openxmlformats.org/drawingml/2006/chart">
-            <c:chart xmlns:r="http://schemas.openxmlformats.org/officeDocument/2006/relationships" xmlns:c="http://schemas.openxmlformats.org/drawingml/2006/chart" r:id="Rd0b559a6e2074508"/>
+            <c:chart xmlns:r="http://schemas.openxmlformats.org/officeDocument/2006/relationships" xmlns:c="http://schemas.openxmlformats.org/drawingml/2006/chart" r:id="R53dda46d526e4237"/>
           </a:graphicData>
         </a:graphic>
       </p:graphicFrame>
@@ -5665,7 +5691,7 @@
           <p:cNvPr id="6" name="">
             <a:extLst xmlns:a="http://schemas.openxmlformats.org/drawingml/2006/main">
               <a:ext uri="{FF2B5EF4-FFF2-40B4-BE49-F238E27FC236}">
-                <a16:creationId xmlns:a16="http://schemas.microsoft.com/office/drawing/2014/main" id="{EEB7FFE2-5DC6-4ADA-A378-59E5A98664AF}"/>
+                <a16:creationId xmlns:a16="http://schemas.microsoft.com/office/drawing/2014/main" id="{D80550C6-578A-418C-982B-9EBB1B483D4E}"/>
               </a:ext>
             </a:extLst>
           </p:cNvPr>
@@ -5712,7 +5738,7 @@
                 <a:ea typeface="Noto Sans"/>
                 <a:cs typeface="Noto Sans"/>
               </a:rPr>
-              <a:t>First workflow challenge</a:t>
+              <a:t>Current local workflow</a:t>
             </a:r>
           </a:p>
         </p:txBody>
@@ -5722,7 +5748,7 @@
           <p:cNvPr id="7" name="">
             <a:extLst xmlns:a="http://schemas.openxmlformats.org/drawingml/2006/main">
               <a:ext uri="{FF2B5EF4-FFF2-40B4-BE49-F238E27FC236}">
-                <a16:creationId xmlns:a16="http://schemas.microsoft.com/office/drawing/2014/main" id="{9412B5E0-C809-40C1-875D-76F0AECCBEEB}"/>
+                <a16:creationId xmlns:a16="http://schemas.microsoft.com/office/drawing/2014/main" id="{AB179CB1-2832-47B7-8CB2-83FD99E11582}"/>
               </a:ext>
             </a:extLst>
           </p:cNvPr>
@@ -5769,7 +5795,7 @@
                 <a:ea typeface="Noto Sans"/>
                 <a:cs typeface="Noto Sans"/>
               </a:rPr>
-              <a:t>70 independent-agent cases / correct outcomes</a:t>
+              <a:t>140 exposed cases / correct regression outcomes</a:t>
             </a:r>
           </a:p>
         </p:txBody>
@@ -5781,12 +5807,12 @@
           <p:nvPr/>
         </p:nvGraphicFramePr>
         <p:xfrm>
-          <a:off xmlns:a="http://schemas.openxmlformats.org/drawingml/2006/main" x="6315075" y="2409825"/>
-          <a:ext xmlns:a="http://schemas.openxmlformats.org/drawingml/2006/main" cx="5191125" cy="2733675"/>
+          <a:off xmlns:a="http://schemas.openxmlformats.org/drawingml/2006/main" x="6315075" y="2352675"/>
+          <a:ext xmlns:a="http://schemas.openxmlformats.org/drawingml/2006/main" cx="5191125" cy="2638425"/>
         </p:xfrm>
         <a:graphic xmlns:a="http://schemas.openxmlformats.org/drawingml/2006/main">
           <a:graphicData uri="http://schemas.openxmlformats.org/drawingml/2006/chart">
-            <c:chart xmlns:r="http://schemas.openxmlformats.org/officeDocument/2006/relationships" xmlns:c="http://schemas.openxmlformats.org/drawingml/2006/chart" r:id="Rc58dd701bd9e4cc5"/>
+            <c:chart xmlns:r="http://schemas.openxmlformats.org/officeDocument/2006/relationships" xmlns:c="http://schemas.openxmlformats.org/drawingml/2006/chart" r:id="R8d59a20d0d5a41f4"/>
           </a:graphicData>
         </a:graphic>
       </p:graphicFrame>
@@ -5795,7 +5821,7 @@
           <p:cNvPr id="9" name="">
             <a:extLst xmlns:a="http://schemas.openxmlformats.org/drawingml/2006/main">
               <a:ext uri="{FF2B5EF4-FFF2-40B4-BE49-F238E27FC236}">
-                <a16:creationId xmlns:a16="http://schemas.microsoft.com/office/drawing/2014/main" id="{DB93F7E8-1C15-479F-B178-9418C2E343FC}"/>
+                <a16:creationId xmlns:a16="http://schemas.microsoft.com/office/drawing/2014/main" id="{2C370169-DF68-4DD2-8E25-099CE2948DFF}"/>
               </a:ext>
             </a:extLst>
           </p:cNvPr>
@@ -5806,7 +5832,7 @@
         </p:nvSpPr>
         <p:spPr>
           <a:xfrm xmlns:a="http://schemas.openxmlformats.org/drawingml/2006/main">
-            <a:off x="619125" y="5267325"/>
+            <a:off x="619125" y="5114925"/>
             <a:ext cx="5238750" cy="428625"/>
           </a:xfrm>
           <a:prstGeom xmlns:a="http://schemas.openxmlformats.org/drawingml/2006/main" prst="rect">
@@ -5852,7 +5878,7 @@
           <p:cNvPr id="10" name="">
             <a:extLst xmlns:a="http://schemas.openxmlformats.org/drawingml/2006/main">
               <a:ext uri="{FF2B5EF4-FFF2-40B4-BE49-F238E27FC236}">
-                <a16:creationId xmlns:a16="http://schemas.microsoft.com/office/drawing/2014/main" id="{54006A5A-0EED-403E-9AEB-9309DAF156BF}"/>
+                <a16:creationId xmlns:a16="http://schemas.microsoft.com/office/drawing/2014/main" id="{007669F8-A7CB-4713-B9C1-03A8C156218E}"/>
               </a:ext>
             </a:extLst>
           </p:cNvPr>
@@ -5863,8 +5889,8 @@
         </p:nvSpPr>
         <p:spPr>
           <a:xfrm xmlns:a="http://schemas.openxmlformats.org/drawingml/2006/main">
-            <a:off x="6362700" y="5267325"/>
-            <a:ext cx="5143500" cy="428625"/>
+            <a:off x="6362700" y="5114925"/>
+            <a:ext cx="5143500" cy="571500"/>
           </a:xfrm>
           <a:prstGeom xmlns:a="http://schemas.openxmlformats.org/drawingml/2006/main" prst="rect">
             <a:avLst/>
@@ -5881,7 +5907,7 @@
           <a:lstStyle xmlns:a="http://schemas.openxmlformats.org/drawingml/2006/main"/>
           <a:p xmlns:a="http://schemas.openxmlformats.org/drawingml/2006/main">
             <a:pPr algn="l">
-              <a:defRPr sz="1875" b="1">
+              <a:defRPr sz="1800" b="1">
                 <a:solidFill>
                   <a:srgbClr val="14243B"/>
                 </a:solidFill>
@@ -5891,7 +5917,7 @@
               </a:defRPr>
             </a:pPr>
             <a:r>
-              <a:rPr sz="1875" b="1">
+              <a:rPr sz="1800" b="1">
                 <a:solidFill>
                   <a:srgbClr val="14243B"/>
                 </a:solidFill>
@@ -5899,7 +5925,7 @@
                 <a:ea typeface="Noto Sans"/>
                 <a:cs typeface="Noto Sans"/>
               </a:rPr>
-              <a:t>28/30 required handoffs on first pass</a:t>
+              <a:t>60/60 handoffs preserve the request</a:t>
             </a:r>
           </a:p>
         </p:txBody>
@@ -5909,7 +5935,7 @@
           <p:cNvPr id="11" name="">
             <a:extLst xmlns:a="http://schemas.openxmlformats.org/drawingml/2006/main">
               <a:ext uri="{FF2B5EF4-FFF2-40B4-BE49-F238E27FC236}">
-                <a16:creationId xmlns:a16="http://schemas.microsoft.com/office/drawing/2014/main" id="{A55F609E-83A8-4F96-B1FB-8D7D81B16ACB}"/>
+                <a16:creationId xmlns:a16="http://schemas.microsoft.com/office/drawing/2014/main" id="{F5232CE0-5889-4A23-93DF-0DF14E898BCE}"/>
               </a:ext>
             </a:extLst>
           </p:cNvPr>
@@ -5920,8 +5946,8 @@
         </p:nvSpPr>
         <p:spPr>
           <a:xfrm xmlns:a="http://schemas.openxmlformats.org/drawingml/2006/main">
-            <a:off x="609600" y="5781675"/>
-            <a:ext cx="10906125" cy="285750"/>
+            <a:off x="609600" y="5686425"/>
+            <a:ext cx="10906125" cy="304800"/>
           </a:xfrm>
           <a:prstGeom xmlns:a="http://schemas.openxmlformats.org/drawingml/2006/main" prst="rect">
             <a:avLst/>
@@ -5938,7 +5964,7 @@
           <a:lstStyle xmlns:a="http://schemas.openxmlformats.org/drawingml/2006/main"/>
           <a:p xmlns:a="http://schemas.openxmlformats.org/drawingml/2006/main">
             <a:pPr algn="l">
-              <a:defRPr sz="1500" b="0">
+              <a:defRPr sz="1575" b="0">
                 <a:solidFill>
                   <a:srgbClr val="587087"/>
                 </a:solidFill>
@@ -5948,7 +5974,7 @@
               </a:defRPr>
             </a:pPr>
             <a:r>
-              <a:rPr sz="1500" b="0">
+              <a:rPr sz="1575" b="0">
                 <a:solidFill>
                   <a:srgbClr val="587087"/>
                 </a:solidFill>
@@ -5956,7 +5982,7 @@
                 <a:ea typeface="Noto Sans"/>
                 <a:cs typeface="Noto Sans"/>
               </a:rPr>
-              <a:t>Authored synthetic cases, without independent human language review.</a:t>
+              <a:t>Six status/currency strata: 122/140 each. Same utterances, no demographic claim.</a:t>
             </a:r>
           </a:p>
         </p:txBody>
@@ -5966,7 +5992,7 @@
           <p:cNvPr id="12" name="">
             <a:extLst xmlns:a="http://schemas.openxmlformats.org/drawingml/2006/main">
               <a:ext uri="{FF2B5EF4-FFF2-40B4-BE49-F238E27FC236}">
-                <a16:creationId xmlns:a16="http://schemas.microsoft.com/office/drawing/2014/main" id="{A9495C14-786F-4B2E-AE93-7CF86B8EAA59}"/>
+                <a16:creationId xmlns:a16="http://schemas.microsoft.com/office/drawing/2014/main" id="{77A3BC32-EF99-4E14-AB4C-1B3D84978713}"/>
               </a:ext>
             </a:extLst>
           </p:cNvPr>
@@ -5977,7 +6003,7 @@
         </p:nvSpPr>
         <p:spPr>
           <a:xfrm xmlns:a="http://schemas.openxmlformats.org/drawingml/2006/main">
-            <a:off x="609600" y="6067425"/>
+            <a:off x="609600" y="6029325"/>
             <a:ext cx="10906125" cy="266700"/>
           </a:xfrm>
           <a:prstGeom xmlns:a="http://schemas.openxmlformats.org/drawingml/2006/main" prst="rect">
@@ -5995,7 +6021,7 @@
           <a:lstStyle xmlns:a="http://schemas.openxmlformats.org/drawingml/2006/main"/>
           <a:p xmlns:a="http://schemas.openxmlformats.org/drawingml/2006/main">
             <a:pPr algn="l">
-              <a:defRPr sz="1425" b="0">
+              <a:defRPr sz="1500" b="0">
                 <a:solidFill>
                   <a:srgbClr val="587087"/>
                 </a:solidFill>
@@ -6005,7 +6031,7 @@
               </a:defRPr>
             </a:pPr>
             <a:r>
-              <a:rPr sz="1425" b="0">
+              <a:rPr sz="1500" b="0">
                 <a:solidFill>
                   <a:srgbClr val="587087"/>
                 </a:solidFill>
@@ -6013,7 +6039,7 @@
                 <a:ea typeface="Noto Sans"/>
                 <a:cs typeface="Noto Sans"/>
               </a:rPr>
-              <a:t>After correcting cancellation: 63/70 outcomes and 30/30 handoffs in a regression replay.</a:t>
+              <a:t>Authored tests, no independent human review. New 70-case provider challenge unscored.</a:t>
             </a:r>
           </a:p>
         </p:txBody>
@@ -6021,7 +6047,7 @@
     </p:spTree>
     <p:extLst>
       <p:ext uri="{BB962C8B-B14F-4D97-AF65-F5344CB8AC3E}">
-        <p14:creationId xmlns:p14="http://schemas.microsoft.com/office/powerpoint/2010/main" val="33490399"/>
+        <p14:creationId xmlns:p14="http://schemas.microsoft.com/office/powerpoint/2010/main" val="1794214335"/>
       </p:ext>
     </p:extLst>
   </p:cSld>
@@ -6052,7 +6078,7 @@
           <p:cNvPr id="11" name="">
             <a:extLst xmlns:a="http://schemas.openxmlformats.org/drawingml/2006/main">
               <a:ext uri="{FF2B5EF4-FFF2-40B4-BE49-F238E27FC236}">
-                <a16:creationId xmlns:a16="http://schemas.microsoft.com/office/drawing/2014/main" id="{5A4C2263-0596-462F-AC64-C3E21D131F90}"/>
+                <a16:creationId xmlns:a16="http://schemas.microsoft.com/office/drawing/2014/main" id="{56500774-B1C5-44F9-A047-524E6B49B9DD}"/>
               </a:ext>
             </a:extLst>
           </p:cNvPr>
@@ -6109,7 +6135,7 @@
           <p:cNvPr id="2" name="">
             <a:extLst xmlns:a="http://schemas.openxmlformats.org/drawingml/2006/main">
               <a:ext uri="{FF2B5EF4-FFF2-40B4-BE49-F238E27FC236}">
-                <a16:creationId xmlns:a16="http://schemas.microsoft.com/office/drawing/2014/main" id="{AB099D1E-0031-4DAB-952E-D18E710E991F}"/>
+                <a16:creationId xmlns:a16="http://schemas.microsoft.com/office/drawing/2014/main" id="{F27AE826-6CC7-4A75-85DA-B72EC77110C2}"/>
               </a:ext>
             </a:extLst>
           </p:cNvPr>
@@ -6170,8 +6196,8 @@
           <p:nvPr/>
         </p:nvPicPr>
         <p:blipFill>
-          <a:blip xmlns:r="http://schemas.openxmlformats.org/officeDocument/2006/relationships" xmlns:a="http://schemas.openxmlformats.org/drawingml/2006/main" r:embed="R788522a9b0a64c81"/>
-          <a:srcRect xmlns:a="http://schemas.openxmlformats.org/drawingml/2006/main" l="0" t="19050" r="0" b="19050"/>
+          <a:blip xmlns:r="http://schemas.openxmlformats.org/officeDocument/2006/relationships" xmlns:a="http://schemas.openxmlformats.org/drawingml/2006/main" r:embed="R386a6be8073445b0"/>
+          <a:srcRect xmlns:a="http://schemas.openxmlformats.org/drawingml/2006/main" l="0" t="7749" r="0" b="7749"/>
           <a:stretch xmlns:a="http://schemas.openxmlformats.org/drawingml/2006/main">
             <a:fillRect l="0" t="0" r="0" b="0"/>
           </a:stretch>
@@ -6191,7 +6217,7 @@
           <p:cNvPr id="4" name="">
             <a:extLst xmlns:a="http://schemas.openxmlformats.org/drawingml/2006/main">
               <a:ext uri="{FF2B5EF4-FFF2-40B4-BE49-F238E27FC236}">
-                <a16:creationId xmlns:a16="http://schemas.microsoft.com/office/drawing/2014/main" id="{F605BD8C-D20B-43B5-9B20-421B53238D5B}"/>
+                <a16:creationId xmlns:a16="http://schemas.microsoft.com/office/drawing/2014/main" id="{9126824C-848C-4943-B6BF-55C2C666D5B4}"/>
               </a:ext>
             </a:extLst>
           </p:cNvPr>
@@ -6220,7 +6246,7 @@
           <a:lstStyle xmlns:a="http://schemas.openxmlformats.org/drawingml/2006/main"/>
           <a:p xmlns:a="http://schemas.openxmlformats.org/drawingml/2006/main">
             <a:pPr algn="l">
-              <a:defRPr sz="1950" b="1">
+              <a:defRPr sz="1875" b="1">
                 <a:solidFill>
                   <a:srgbClr val="67E2C4"/>
                 </a:solidFill>
@@ -6230,7 +6256,7 @@
               </a:defRPr>
             </a:pPr>
             <a:r>
-              <a:rPr sz="1950" b="1">
+              <a:rPr sz="1875" b="1">
                 <a:solidFill>
                   <a:srgbClr val="67E2C4"/>
                 </a:solidFill>
@@ -6238,7 +6264,7 @@
                 <a:ea typeface="Noto Sans"/>
                 <a:cs typeface="Noto Sans"/>
               </a:rPr>
-              <a:t>Verified deployed demo</a:t>
+              <a:t>Public demo / release receipt linked</a:t>
             </a:r>
           </a:p>
         </p:txBody>
@@ -6248,7 +6274,7 @@
           <p:cNvPr id="5" name="">
             <a:extLst xmlns:a="http://schemas.openxmlformats.org/drawingml/2006/main">
               <a:ext uri="{FF2B5EF4-FFF2-40B4-BE49-F238E27FC236}">
-                <a16:creationId xmlns:a16="http://schemas.microsoft.com/office/drawing/2014/main" id="{E204B7B1-5405-48E3-B487-1B7F7B287B3E}"/>
+                <a16:creationId xmlns:a16="http://schemas.microsoft.com/office/drawing/2014/main" id="{3D1AC7C3-749D-4B36-8ED6-A86D5031B4C3}"/>
               </a:ext>
             </a:extLst>
           </p:cNvPr>
@@ -6305,7 +6331,7 @@
           <p:cNvPr id="6" name="">
             <a:extLst xmlns:a="http://schemas.openxmlformats.org/drawingml/2006/main">
               <a:ext uri="{FF2B5EF4-FFF2-40B4-BE49-F238E27FC236}">
-                <a16:creationId xmlns:a16="http://schemas.microsoft.com/office/drawing/2014/main" id="{D9785B92-90B7-47C6-9FEC-E3B8AE6EF346}"/>
+                <a16:creationId xmlns:a16="http://schemas.microsoft.com/office/drawing/2014/main" id="{2CAC9F97-BFEE-4BC7-ADB8-E3F199D05434}"/>
               </a:ext>
             </a:extLst>
           </p:cNvPr>
@@ -6362,7 +6388,7 @@
           <p:cNvPr id="7" name="">
             <a:extLst xmlns:a="http://schemas.openxmlformats.org/drawingml/2006/main">
               <a:ext uri="{FF2B5EF4-FFF2-40B4-BE49-F238E27FC236}">
-                <a16:creationId xmlns:a16="http://schemas.microsoft.com/office/drawing/2014/main" id="{06110AD2-BC62-4F62-B2A4-FCC79DB79219}"/>
+                <a16:creationId xmlns:a16="http://schemas.microsoft.com/office/drawing/2014/main" id="{2A4694A8-CA0E-4B6A-9770-73CF7EC148CE}"/>
               </a:ext>
             </a:extLst>
           </p:cNvPr>
@@ -6465,7 +6491,7 @@
           <p:cNvPr id="8" name="">
             <a:extLst xmlns:a="http://schemas.openxmlformats.org/drawingml/2006/main">
               <a:ext uri="{FF2B5EF4-FFF2-40B4-BE49-F238E27FC236}">
-                <a16:creationId xmlns:a16="http://schemas.microsoft.com/office/drawing/2014/main" id="{5DE42493-4160-4E28-889F-569418D324D5}"/>
+                <a16:creationId xmlns:a16="http://schemas.microsoft.com/office/drawing/2014/main" id="{37104DFE-EE70-4159-8288-00B1706785A2}"/>
               </a:ext>
             </a:extLst>
           </p:cNvPr>
@@ -6512,7 +6538,7 @@
                 <a:ea typeface="Noto Sans"/>
                 <a:cs typeface="Noto Sans"/>
               </a:rPr>
-              <a:t>Local model, no remote model calls</a:t>
+              <a:t>Optional external models</a:t>
             </a:r>
           </a:p>
           <a:p xmlns:a="http://schemas.openxmlformats.org/drawingml/2006/main">
@@ -6535,7 +6561,7 @@
                 <a:ea typeface="Noto Sans"/>
                 <a:cs typeface="Noto Sans"/>
               </a:rPr>
-              <a:t>Portable CPU inference. Synthetic tests</a:t>
+              <a:t>Usage and tariff estimates are logged.</a:t>
             </a:r>
           </a:p>
           <a:p xmlns:a="http://schemas.openxmlformats.org/drawingml/2006/main">
@@ -6558,7 +6584,7 @@
                 <a:ea typeface="Noto Sans"/>
                 <a:cs typeface="Noto Sans"/>
               </a:rPr>
-              <a:t>limit claims about real customer demand.</a:t>
+              <a:t>Live provider results are still unverified.</a:t>
             </a:r>
           </a:p>
         </p:txBody>
@@ -6568,7 +6594,7 @@
           <p:cNvPr id="9" name="">
             <a:extLst xmlns:a="http://schemas.openxmlformats.org/drawingml/2006/main">
               <a:ext uri="{FF2B5EF4-FFF2-40B4-BE49-F238E27FC236}">
-                <a16:creationId xmlns:a16="http://schemas.microsoft.com/office/drawing/2014/main" id="{62ECEEA8-CC2D-49D5-9CBD-907AE92EB723}"/>
+                <a16:creationId xmlns:a16="http://schemas.microsoft.com/office/drawing/2014/main" id="{C7E4D431-1B83-47E7-B0DE-FADA05046868}"/>
               </a:ext>
             </a:extLst>
           </p:cNvPr>
@@ -6625,7 +6651,7 @@
           <p:cNvPr id="10" name="">
             <a:extLst xmlns:a="http://schemas.openxmlformats.org/drawingml/2006/main">
               <a:ext uri="{FF2B5EF4-FFF2-40B4-BE49-F238E27FC236}">
-                <a16:creationId xmlns:a16="http://schemas.microsoft.com/office/drawing/2014/main" id="{ECB2AE7E-6BF3-4C53-ACC2-969DE44D91A8}"/>
+                <a16:creationId xmlns:a16="http://schemas.microsoft.com/office/drawing/2014/main" id="{4C5B1D7D-9034-460B-AB20-EE7D850E9B6A}"/>
               </a:ext>
             </a:extLst>
           </p:cNvPr>
@@ -6703,7 +6729,7 @@
     </p:spTree>
     <p:extLst>
       <p:ext uri="{BB962C8B-B14F-4D97-AF65-F5344CB8AC3E}">
-        <p14:creationId xmlns:p14="http://schemas.microsoft.com/office/powerpoint/2010/main" val="1291466833"/>
+        <p14:creationId xmlns:p14="http://schemas.microsoft.com/office/powerpoint/2010/main" val="186951206"/>
       </p:ext>
     </p:extLst>
   </p:cSld>

</xml_diff>

<commit_message>
Make banking support chat-first and strengthen grounded workflow checks
</commit_message>
<xml_diff>
--- a/submission/Claro-Hackathon-2026.pptx
+++ b/submission/Claro-Hackathon-2026.pptx
@@ -2,18 +2,18 @@
 <file path=ppt/presentation.xml><?xml version="1.0" encoding="utf-8"?>
 <p:presentation xmlns:p="http://schemas.openxmlformats.org/presentationml/2006/main">
   <p:sldMasterIdLst>
-    <p:sldMasterId xmlns:r="http://schemas.openxmlformats.org/officeDocument/2006/relationships" id="2147483648" r:id="R50a10161cf2f454e"/>
+    <p:sldMasterId xmlns:r="http://schemas.openxmlformats.org/officeDocument/2006/relationships" id="2147483648" r:id="Rb38acc3795834b0c"/>
   </p:sldMasterIdLst>
   <p:notesMasterIdLst>
-    <p:notesMasterId xmlns:r="http://schemas.openxmlformats.org/officeDocument/2006/relationships" r:id="R897237d383af48d3"/>
+    <p:notesMasterId xmlns:r="http://schemas.openxmlformats.org/officeDocument/2006/relationships" r:id="R87151ddffe9a4de9"/>
   </p:notesMasterIdLst>
   <p:sldIdLst>
-    <p:sldId xmlns:r="http://schemas.openxmlformats.org/officeDocument/2006/relationships" id="256" r:id="R29fa5a6ae2ab4f66"/>
-    <p:sldId xmlns:r="http://schemas.openxmlformats.org/officeDocument/2006/relationships" id="257" r:id="R9622feaa70d34cd1"/>
-    <p:sldId xmlns:r="http://schemas.openxmlformats.org/officeDocument/2006/relationships" id="258" r:id="R46103cfbd4424ee3"/>
-    <p:sldId xmlns:r="http://schemas.openxmlformats.org/officeDocument/2006/relationships" id="259" r:id="R3af15fb7794f4264"/>
-    <p:sldId xmlns:r="http://schemas.openxmlformats.org/officeDocument/2006/relationships" id="260" r:id="Rfd15df70ccff4fca"/>
-    <p:sldId xmlns:r="http://schemas.openxmlformats.org/officeDocument/2006/relationships" id="261" r:id="R4963a64e48e44405"/>
+    <p:sldId xmlns:r="http://schemas.openxmlformats.org/officeDocument/2006/relationships" id="256" r:id="R0430d690aa9e4ef2"/>
+    <p:sldId xmlns:r="http://schemas.openxmlformats.org/officeDocument/2006/relationships" id="257" r:id="Rbc124856a8cf48c1"/>
+    <p:sldId xmlns:r="http://schemas.openxmlformats.org/officeDocument/2006/relationships" id="258" r:id="Rb01446d11fd34802"/>
+    <p:sldId xmlns:r="http://schemas.openxmlformats.org/officeDocument/2006/relationships" id="259" r:id="R8721c1c67cf84262"/>
+    <p:sldId xmlns:r="http://schemas.openxmlformats.org/officeDocument/2006/relationships" id="260" r:id="R5cffc4a3f5df4a3d"/>
+    <p:sldId xmlns:r="http://schemas.openxmlformats.org/officeDocument/2006/relationships" id="261" r:id="Rafa164445f2a4ac9"/>
   </p:sldIdLst>
   <p:sldSz cx="12192000" cy="6858000"/>
   <p:notesSz cx="6858000" cy="9144000"/>
@@ -517,7 +517,7 @@
           <a:lstStyle xmlns:a="http://schemas.openxmlformats.org/drawingml/2006/main"/>
           <a:p xmlns:a="http://schemas.openxmlformats.org/drawingml/2006/main">
             <a:r>
-              <a:t>Screenshot: actual local Claro UI, team-authored synthetic fixtures, with external providers disabled. The customer report preserves specific redacted allegations through transaction clarification and is labeled unverified; permitted record facts remain separate. Customer sees the text before confirming. Atomic case commit and fresh read-back precede the receipt. Analyst questions and customer replies persist as scoped, idempotent case history. No real money movement, refunds or card blocking. Sources: docs/SYSTEM_EVALUATION.md, docs/OPERATIONS.md, api.py, privacy.py, store.py and workflow.py.</a:t>
+              <a:t>Screenshot: current local Claro chat captured with CUA at http://127.0.0.1:8096 on October 4, 2026 America/Bogota, team-authored synthetic fixtures and external providers disabled. The UI creates a trusted sandbox session without persona or language selectors. ES/PT detection never changes customer identity. Exact references narrow validated authorized records and ambiguity prompts clarification. The customer report preserves specific redacted allegations through transaction clarification and is labeled unverified; permitted record facts remain separate. Customer sees the text before confirming. Atomic case commit and fresh read-back precede the receipt. The reviewer route is /?review=1. The owning customer answers a persisted question in the same composer. Case events remain scoped and idempotent. No real money movement, refunds or card blocking. Sources: docs/SYSTEM_EVALUATION.md, docs/OPERATIONS.md, api.py, privacy.py, store.py and workflow.py.</a:t>
             </a:r>
           </a:p>
         </p:txBody>
@@ -727,7 +727,7 @@
           <a:lstStyle xmlns:a="http://schemas.openxmlformats.org/drawingml/2006/main"/>
           <a:p xmlns:a="http://schemas.openxmlformats.org/drawingml/2006/main">
             <a:r>
-              <a:t>Sources: docs/LANGUAGE_EVALUATION.md, docs/SYSTEM_EVALUATION.md and aggregate evidence. Component train196/development56/test140 uses frozen semantic groups. Local TF-IDF/logistic117/140 macroF10.8230; rules65/140 F10.4207; local Gemma3 4B115/140 F10.8045. Small ML/Gemma difference is not claimed significant. Workflow figure is request-preservation-v2 current local regression. First untouched challenge remains61/70 learned versus43/70 rules, with28/30 required transfers. Separate exposed regression 63/70 follows fixes; it is never relabeled blind. Six strata contain140 unique utterances and70 semantic pairs, counterbalanced ES/PT,840replays/system. These are selected-transaction status/currency groups, not demographic fairness. All labels/translations are assistant-authored without independent human/native-language review. Fresh prospective70 is frozen but unscored. Zero offline provider attempts do not establish free provider inference. No hardware/hosting or representative customer cost claim.</a:t>
+              <a:t>Sources: docs/LANGUAGE_EVALUATION.md, docs/SYSTEM_EVALUATION.md and aggregate evidence. Component train196/development56/test140 uses frozen semantic groups. Local TF-IDF/logistic117/140 macroF10.8230; rules65/140 F10.4207; local Gemma3 4B115/140 F10.8045. Small ML/Gemma difference is not claimed significant. Workflow figure is current v3 chat regression with a stronger case-lookup scorer. Current v3 requires the returned exact persisted case, localized status, timestamp, supporting case evidence and pending question. Independently reading the endpoint is insufficient. The scorer differs from v1.1, so old and new correctness percentages are not directly comparable. Original labels remain unchanged, including two CASE-009 requests for a nonexistent seeded case, recorded as fixture/reference mismatches rather than silently relabeled successes. Current safe automated resolutions: 38/120. Current incorrect outcomes: 10; unnecessary proposals: 1. Language slices and all errors are published. First untouched challenge remains61/70 learned versus43/70 rules, with28/30 required transfers. Separate exposed regression 64/70 follows fixes; it is never relabeled blind. Source-matched current files are docs/evidence/chat-system-regression.json and docs/evidence/chat-challenge-regression.json. Historical v1.1 sources remain preserved. Current six strata contain140 unique utterances and70 semantic pairs, counterbalanced ES/PT,840replays/system. These are selected-transaction status/currency groups, not demographic fairness. All labels/translations are assistant-authored without independent human/native-language review. Fresh prospective70 is frozen but unscored. Zero offline provider attempts do not establish free provider inference. No hardware/hosting or representative customer cost claim.</a:t>
             </a:r>
           </a:p>
         </p:txBody>
@@ -797,7 +797,7 @@
           <a:lstStyle xmlns:a="http://schemas.openxmlformats.org/drawingml/2006/main"/>
           <a:p xmlns:a="http://schemas.openxmlformats.org/drawingml/2006/main">
             <a:r>
-              <a:t>Repository: https://github.com/nicoceron/factored-hackathon-2026-nicoceron . Public URL is tied to the commit and verification date in submission/deployment.json. Current local screenshots do not independently prove that a newer branch is deployed. Optional Jev/DeepSeek adapters are implemented/mocked but live inference remains unverified pending authorized metered use. External tariff estimates are not invoice spend. Screenshot is the actual local app using team fixtures and disabled providers. Free-host filesystem may reset. Sources: docs/AI_PROVIDERS.md, docs/OPERATIONS.md and submission/deployment.json. Real-bank requirements include approved identity/entitlements/MFA/policies, durable data, monitored rollout, privacy controls, independent ES/PT review and staffing. Organizer submission is intentionally outside requested scope. No real-bank operation or production safety certification.</a:t>
+              <a:t>Repository: https://github.com/nicoceron/factored-hackathon-2026-nicoceron . Public URL is tied to the prior v1.1 commit and verification date in submission/deployment.json. The current chat redesign is local and has not been deployed. Reviewer access is /?review=1 and customer chat is /. Current local screenshots do not independently prove that a newer branch is deployed. Optional Jev/DeepSeek adapters are implemented/mocked but live inference remains unverified pending authorized metered use. External tariff estimates are not invoice spend. Screenshot is a declared geometry crop of the current local reviewer timeline. Its Spanish interface retains the original Spanish report plus Portuguese question and reply; the filename does not imply a Portuguese-only interface. Screenshot was captured with CUA at http://127.0.0.1:8096 on October 4, 2026 America/Bogota using team fixtures and disabled providers. Free-host filesystem may reset. Sources: docs/AI_PROVIDERS.md, docs/OPERATIONS.md and submission/deployment.json. Real-bank requirements include approved identity/entitlements/MFA/policies, durable data, monitored rollout, privacy controls, independent ES/PT review and staffing. Organizer submission is intentionally outside requested scope. No real-bank operation or production safety certification.</a:t>
             </a:r>
           </a:p>
         </p:txBody>
@@ -865,7 +865,7 @@
   </p:cSld>
   <p:clrMap bg1="lt1" tx1="dk1" bg2="lt2" tx2="dk2" accent1="accent1" accent2="accent2" accent3="accent3" accent4="accent4" accent5="accent5" accent6="accent6" hlink="hlink" folHlink="folHlink"/>
   <p:sldLayoutIdLst>
-    <p:sldLayoutId xmlns:r="http://schemas.openxmlformats.org/officeDocument/2006/relationships" id="2147483649" r:id="R0f03c26ae4a54025"/>
+    <p:sldLayoutId xmlns:r="http://schemas.openxmlformats.org/officeDocument/2006/relationships" id="2147483649" r:id="R3512fa17c0534a58"/>
   </p:sldLayoutIdLst>
   <p:txStyles>
     <p:titleStyle>
@@ -2149,7 +2149,7 @@
                         <a:ea typeface="Noto Sans"/>
                         <a:cs typeface="Noto Sans"/>
                       </a:rPr>
-                      <a:t>77 / 140</a:t>
+                      <a:t>83 / 140</a:t>
                     </a:r>
                   </a:p>
                 </c:rich>
@@ -2194,7 +2194,7 @@
                         <a:ea typeface="Noto Sans"/>
                         <a:cs typeface="Noto Sans"/>
                       </a:rPr>
-                      <a:t>122 / 140</a:t>
+                      <a:t>130 / 140</a:t>
                     </a:r>
                   </a:p>
                 </c:rich>
@@ -2245,10 +2245,10 @@
                 <c:formatCode>0%</c:formatCode>
                 <c:ptCount val="2"/>
                 <c:pt idx="0">
-                  <c:v>0.55</c:v>
+                  <c:v>0.592857143</c:v>
                 </c:pt>
                 <c:pt idx="1">
-                  <c:v>0.871428571</c:v>
+                  <c:v>0.928571429</c:v>
                 </c:pt>
               </c:numCache>
             </c:numRef>
@@ -2409,7 +2409,7 @@
           <p:cNvPr id="10" name="">
             <a:extLst xmlns:a="http://schemas.openxmlformats.org/drawingml/2006/main">
               <a:ext uri="{FF2B5EF4-FFF2-40B4-BE49-F238E27FC236}">
-                <a16:creationId xmlns:a16="http://schemas.microsoft.com/office/drawing/2014/main" id="{E90D1040-AD79-4BD0-B659-5A892027A2F9}"/>
+                <a16:creationId xmlns:a16="http://schemas.microsoft.com/office/drawing/2014/main" id="{528F6D99-C8DE-4663-9572-023DB6F4C27B}"/>
               </a:ext>
             </a:extLst>
           </p:cNvPr>
@@ -2466,7 +2466,7 @@
           <p:cNvPr id="2" name="">
             <a:extLst xmlns:a="http://schemas.openxmlformats.org/drawingml/2006/main">
               <a:ext uri="{FF2B5EF4-FFF2-40B4-BE49-F238E27FC236}">
-                <a16:creationId xmlns:a16="http://schemas.microsoft.com/office/drawing/2014/main" id="{A47BC5E6-28D2-4DCD-A00B-43EFE43644A7}"/>
+                <a16:creationId xmlns:a16="http://schemas.microsoft.com/office/drawing/2014/main" id="{E79BCA99-06BE-4DC3-948A-546972ED164F}"/>
               </a:ext>
             </a:extLst>
           </p:cNvPr>
@@ -2546,7 +2546,7 @@
           <p:cNvPr id="3" name="">
             <a:extLst xmlns:a="http://schemas.openxmlformats.org/drawingml/2006/main">
               <a:ext uri="{FF2B5EF4-FFF2-40B4-BE49-F238E27FC236}">
-                <a16:creationId xmlns:a16="http://schemas.microsoft.com/office/drawing/2014/main" id="{B0495FCD-857F-43CC-A234-346CC5A2CB3D}"/>
+                <a16:creationId xmlns:a16="http://schemas.microsoft.com/office/drawing/2014/main" id="{2EA5A2D1-9B37-4CA5-A429-CF082A8929CA}"/>
               </a:ext>
             </a:extLst>
           </p:cNvPr>
@@ -2593,7 +2593,7 @@
                 <a:ea typeface="Noto Sans"/>
                 <a:cs typeface="Noto Sans"/>
               </a:rPr>
-              <a:t>Spanish and Portuguese transaction support</a:t>
+              <a:t>Immediate Spanish and Portuguese chat</a:t>
             </a:r>
           </a:p>
           <a:p xmlns:a="http://schemas.openxmlformats.org/drawingml/2006/main">
@@ -2616,7 +2616,7 @@
                 <a:ea typeface="Noto Sans"/>
                 <a:cs typeface="Noto Sans"/>
               </a:rPr>
-              <a:t>with confirmed cases for human review</a:t>
+              <a:t>with verified cases for human review</a:t>
             </a:r>
           </a:p>
         </p:txBody>
@@ -2626,7 +2626,7 @@
           <p:cNvPr id="4" name="">
             <a:extLst xmlns:a="http://schemas.openxmlformats.org/drawingml/2006/main">
               <a:ext uri="{FF2B5EF4-FFF2-40B4-BE49-F238E27FC236}">
-                <a16:creationId xmlns:a16="http://schemas.microsoft.com/office/drawing/2014/main" id="{A778DC8E-C406-4EE7-A838-A2D8CBEF4A6B}"/>
+                <a16:creationId xmlns:a16="http://schemas.microsoft.com/office/drawing/2014/main" id="{14CF9785-B531-41F2-9A38-93BE998048F7}"/>
               </a:ext>
             </a:extLst>
           </p:cNvPr>
@@ -2683,7 +2683,7 @@
           <p:cNvPr id="5" name="">
             <a:extLst xmlns:a="http://schemas.openxmlformats.org/drawingml/2006/main">
               <a:ext uri="{FF2B5EF4-FFF2-40B4-BE49-F238E27FC236}">
-                <a16:creationId xmlns:a16="http://schemas.microsoft.com/office/drawing/2014/main" id="{5440CA68-3E02-4852-9174-E2D1D753FD81}"/>
+                <a16:creationId xmlns:a16="http://schemas.microsoft.com/office/drawing/2014/main" id="{33A3483D-53F7-453F-8AC3-E2E79656E7F4}"/>
               </a:ext>
             </a:extLst>
           </p:cNvPr>
@@ -2740,7 +2740,7 @@
           <p:cNvPr id="6" name="">
             <a:extLst xmlns:a="http://schemas.openxmlformats.org/drawingml/2006/main">
               <a:ext uri="{FF2B5EF4-FFF2-40B4-BE49-F238E27FC236}">
-                <a16:creationId xmlns:a16="http://schemas.microsoft.com/office/drawing/2014/main" id="{8D1E7D37-FC2D-44EE-97F3-04CD5E3EA0A5}"/>
+                <a16:creationId xmlns:a16="http://schemas.microsoft.com/office/drawing/2014/main" id="{E0C1C79C-2F1E-42B5-AF0B-397C05DE24DF}"/>
               </a:ext>
             </a:extLst>
           </p:cNvPr>
@@ -2797,7 +2797,7 @@
           <p:cNvPr id="7" name="">
             <a:extLst xmlns:a="http://schemas.openxmlformats.org/drawingml/2006/main">
               <a:ext uri="{FF2B5EF4-FFF2-40B4-BE49-F238E27FC236}">
-                <a16:creationId xmlns:a16="http://schemas.microsoft.com/office/drawing/2014/main" id="{E2DCAD9C-92B4-452D-8306-E99710E0D1A6}"/>
+                <a16:creationId xmlns:a16="http://schemas.microsoft.com/office/drawing/2014/main" id="{E31A42E2-9BCB-4B9D-BD4B-7E8F96F94531}"/>
               </a:ext>
             </a:extLst>
           </p:cNvPr>
@@ -2877,7 +2877,7 @@
           <p:cNvPr id="8" name="">
             <a:extLst xmlns:a="http://schemas.openxmlformats.org/drawingml/2006/main">
               <a:ext uri="{FF2B5EF4-FFF2-40B4-BE49-F238E27FC236}">
-                <a16:creationId xmlns:a16="http://schemas.microsoft.com/office/drawing/2014/main" id="{47A7FCD2-5C73-4252-9D8E-ECE0A7DAA268}"/>
+                <a16:creationId xmlns:a16="http://schemas.microsoft.com/office/drawing/2014/main" id="{B349D92E-130B-4ADE-A2F8-2228868310D4}"/>
               </a:ext>
             </a:extLst>
           </p:cNvPr>
@@ -2934,7 +2934,7 @@
           <p:cNvPr id="9" name="">
             <a:extLst xmlns:a="http://schemas.openxmlformats.org/drawingml/2006/main">
               <a:ext uri="{FF2B5EF4-FFF2-40B4-BE49-F238E27FC236}">
-                <a16:creationId xmlns:a16="http://schemas.microsoft.com/office/drawing/2014/main" id="{3741C0F0-968D-4BDE-AAD4-6880DB40CC7B}"/>
+                <a16:creationId xmlns:a16="http://schemas.microsoft.com/office/drawing/2014/main" id="{257126D9-4F0D-476C-8713-C81200472DE0}"/>
               </a:ext>
             </a:extLst>
           </p:cNvPr>
@@ -2989,7 +2989,7 @@
     </p:spTree>
     <p:extLst>
       <p:ext uri="{BB962C8B-B14F-4D97-AF65-F5344CB8AC3E}">
-        <p14:creationId xmlns:p14="http://schemas.microsoft.com/office/powerpoint/2010/main" val="859109147"/>
+        <p14:creationId xmlns:p14="http://schemas.microsoft.com/office/powerpoint/2010/main" val="1914710011"/>
       </p:ext>
     </p:extLst>
   </p:cSld>
@@ -3020,7 +3020,7 @@
           <p:cNvPr id="10" name="">
             <a:extLst xmlns:a="http://schemas.openxmlformats.org/drawingml/2006/main">
               <a:ext uri="{FF2B5EF4-FFF2-40B4-BE49-F238E27FC236}">
-                <a16:creationId xmlns:a16="http://schemas.microsoft.com/office/drawing/2014/main" id="{79EE69BA-6015-4779-9C44-3E422D74E76B}"/>
+                <a16:creationId xmlns:a16="http://schemas.microsoft.com/office/drawing/2014/main" id="{E8BC33E3-1802-4895-ADDD-60952447150D}"/>
               </a:ext>
             </a:extLst>
           </p:cNvPr>
@@ -3067,7 +3067,7 @@
                 <a:ea typeface="Noto Sans"/>
                 <a:cs typeface="Noto Sans"/>
               </a:rPr>
-              <a:t>Specific requests, verified cases and follow-up</a:t>
+              <a:t>One conversation from inquiry to follow-up</a:t>
             </a:r>
           </a:p>
         </p:txBody>
@@ -3077,7 +3077,7 @@
           <p:cNvPr id="2" name="">
             <a:extLst xmlns:a="http://schemas.openxmlformats.org/drawingml/2006/main">
               <a:ext uri="{FF2B5EF4-FFF2-40B4-BE49-F238E27FC236}">
-                <a16:creationId xmlns:a16="http://schemas.microsoft.com/office/drawing/2014/main" id="{33F0BC40-032C-4F45-A95F-E9AD87AB00DF}"/>
+                <a16:creationId xmlns:a16="http://schemas.microsoft.com/office/drawing/2014/main" id="{75F02D76-F9D9-4CF2-9284-86E4C9EF513B}"/>
               </a:ext>
             </a:extLst>
           </p:cNvPr>
@@ -3138,16 +3138,14 @@
           <p:nvPr/>
         </p:nvPicPr>
         <p:blipFill>
-          <a:blip xmlns:r="http://schemas.openxmlformats.org/officeDocument/2006/relationships" xmlns:a="http://schemas.openxmlformats.org/drawingml/2006/main" r:embed="R4ab8a7d441bc4fe3"/>
-          <a:srcRect xmlns:a="http://schemas.openxmlformats.org/drawingml/2006/main" l="0" t="8158" r="0" b="8158"/>
-          <a:stretch xmlns:a="http://schemas.openxmlformats.org/drawingml/2006/main">
-            <a:fillRect l="0" t="0" r="0" b="0"/>
-          </a:stretch>
+          <a:blip xmlns:r="http://schemas.openxmlformats.org/officeDocument/2006/relationships" xmlns:a="http://schemas.openxmlformats.org/drawingml/2006/main" r:embed="R60d180a0fc934b98"/>
+          <a:srcRect xmlns:a="http://schemas.openxmlformats.org/drawingml/2006/main" l="33266" t="23121" r="33132" b="22447"/>
+          <a:stretch xmlns:a="http://schemas.openxmlformats.org/drawingml/2006/main"/>
         </p:blipFill>
         <p:spPr>
           <a:xfrm xmlns:a="http://schemas.openxmlformats.org/drawingml/2006/main">
-            <a:off x="609600" y="1647825"/>
-            <a:ext cx="7391400" cy="4314825"/>
+            <a:off x="2396085" y="1647825"/>
+            <a:ext cx="3818429" cy="4314825"/>
           </a:xfrm>
           <a:prstGeom xmlns:a="http://schemas.openxmlformats.org/drawingml/2006/main" prst="rect">
             <a:avLst/>
@@ -3159,7 +3157,7 @@
           <p:cNvPr id="4" name="">
             <a:extLst xmlns:a="http://schemas.openxmlformats.org/drawingml/2006/main">
               <a:ext uri="{FF2B5EF4-FFF2-40B4-BE49-F238E27FC236}">
-                <a16:creationId xmlns:a16="http://schemas.microsoft.com/office/drawing/2014/main" id="{EC6B5BE2-FE44-496C-952F-18AA74F4A2C2}"/>
+                <a16:creationId xmlns:a16="http://schemas.microsoft.com/office/drawing/2014/main" id="{3AC32383-CBDF-4384-9E06-C5A80189218C}"/>
               </a:ext>
             </a:extLst>
           </p:cNvPr>
@@ -3206,7 +3204,7 @@
                 <a:ea typeface="Noto Sans"/>
                 <a:cs typeface="Noto Sans"/>
               </a:rPr>
-              <a:t>1  Preserve the request</a:t>
+              <a:t>1  Start in chat</a:t>
             </a:r>
           </a:p>
         </p:txBody>
@@ -3216,7 +3214,7 @@
           <p:cNvPr id="5" name="">
             <a:extLst xmlns:a="http://schemas.openxmlformats.org/drawingml/2006/main">
               <a:ext uri="{FF2B5EF4-FFF2-40B4-BE49-F238E27FC236}">
-                <a16:creationId xmlns:a16="http://schemas.microsoft.com/office/drawing/2014/main" id="{88353A29-D938-40B4-908A-131B05E39DEC}"/>
+                <a16:creationId xmlns:a16="http://schemas.microsoft.com/office/drawing/2014/main" id="{1101482C-FEA1-4D39-B7E5-73EE3A4809D7}"/>
               </a:ext>
             </a:extLst>
           </p:cNvPr>
@@ -3263,7 +3261,7 @@
                 <a:ea typeface="Noto Sans"/>
                 <a:cs typeface="Noto Sans"/>
               </a:rPr>
-              <a:t>Retain redacted customer</a:t>
+              <a:t>Automatic ES/PT language.</a:t>
             </a:r>
           </a:p>
           <a:p xmlns:a="http://schemas.openxmlformats.org/drawingml/2006/main">
@@ -3286,7 +3284,7 @@
                 <a:ea typeface="Noto Sans"/>
                 <a:cs typeface="Noto Sans"/>
               </a:rPr>
-              <a:t>words beside verified facts.</a:t>
+              <a:t>Clarify the transaction in chat.</a:t>
             </a:r>
           </a:p>
         </p:txBody>
@@ -3296,7 +3294,7 @@
           <p:cNvPr id="6" name="">
             <a:extLst xmlns:a="http://schemas.openxmlformats.org/drawingml/2006/main">
               <a:ext uri="{FF2B5EF4-FFF2-40B4-BE49-F238E27FC236}">
-                <a16:creationId xmlns:a16="http://schemas.microsoft.com/office/drawing/2014/main" id="{46B0BE49-4F7D-47F7-BB63-F2C27506FDCC}"/>
+                <a16:creationId xmlns:a16="http://schemas.microsoft.com/office/drawing/2014/main" id="{7B42EBA1-6580-4DAC-8265-5ACA045267B4}"/>
               </a:ext>
             </a:extLst>
           </p:cNvPr>
@@ -3353,7 +3351,7 @@
           <p:cNvPr id="7" name="">
             <a:extLst xmlns:a="http://schemas.openxmlformats.org/drawingml/2006/main">
               <a:ext uri="{FF2B5EF4-FFF2-40B4-BE49-F238E27FC236}">
-                <a16:creationId xmlns:a16="http://schemas.microsoft.com/office/drawing/2014/main" id="{E8752C21-55EC-4280-B2FF-6CAA4B9CB30D}"/>
+                <a16:creationId xmlns:a16="http://schemas.microsoft.com/office/drawing/2014/main" id="{68B56CEC-1A34-44CF-B148-78EB9335D66F}"/>
               </a:ext>
             </a:extLst>
           </p:cNvPr>
@@ -3433,7 +3431,7 @@
           <p:cNvPr id="8" name="">
             <a:extLst xmlns:a="http://schemas.openxmlformats.org/drawingml/2006/main">
               <a:ext uri="{FF2B5EF4-FFF2-40B4-BE49-F238E27FC236}">
-                <a16:creationId xmlns:a16="http://schemas.microsoft.com/office/drawing/2014/main" id="{6FC4D793-456B-4E54-8DF3-4828455FC692}"/>
+                <a16:creationId xmlns:a16="http://schemas.microsoft.com/office/drawing/2014/main" id="{0175D72D-4538-46EB-B433-92CC9E682E42}"/>
               </a:ext>
             </a:extLst>
           </p:cNvPr>
@@ -3490,7 +3488,7 @@
           <p:cNvPr id="9" name="">
             <a:extLst xmlns:a="http://schemas.openxmlformats.org/drawingml/2006/main">
               <a:ext uri="{FF2B5EF4-FFF2-40B4-BE49-F238E27FC236}">
-                <a16:creationId xmlns:a16="http://schemas.microsoft.com/office/drawing/2014/main" id="{C82DB530-25C6-42EE-A7DB-E84138EAABB4}"/>
+                <a16:creationId xmlns:a16="http://schemas.microsoft.com/office/drawing/2014/main" id="{AC992A43-49E7-4040-964E-3974519034C2}"/>
               </a:ext>
             </a:extLst>
           </p:cNvPr>
@@ -3537,7 +3535,7 @@
                 <a:ea typeface="Noto Sans"/>
                 <a:cs typeface="Noto Sans"/>
               </a:rPr>
-              <a:t>Save the analyst question,</a:t>
+              <a:t>Ask a specific question.</a:t>
             </a:r>
           </a:p>
           <a:p xmlns:a="http://schemas.openxmlformats.org/drawingml/2006/main">
@@ -3560,7 +3558,7 @@
                 <a:ea typeface="Noto Sans"/>
                 <a:cs typeface="Noto Sans"/>
               </a:rPr>
-              <a:t>customer reply and status.</a:t>
+              <a:t>Reply in the same composer.</a:t>
             </a:r>
           </a:p>
         </p:txBody>
@@ -3568,7 +3566,7 @@
     </p:spTree>
     <p:extLst>
       <p:ext uri="{BB962C8B-B14F-4D97-AF65-F5344CB8AC3E}">
-        <p14:creationId xmlns:p14="http://schemas.microsoft.com/office/powerpoint/2010/main" val="369806862"/>
+        <p14:creationId xmlns:p14="http://schemas.microsoft.com/office/powerpoint/2010/main" val="1053909103"/>
       </p:ext>
     </p:extLst>
   </p:cSld>
@@ -3599,7 +3597,7 @@
           <p:cNvPr id="19" name="">
             <a:extLst xmlns:a="http://schemas.openxmlformats.org/drawingml/2006/main">
               <a:ext uri="{FF2B5EF4-FFF2-40B4-BE49-F238E27FC236}">
-                <a16:creationId xmlns:a16="http://schemas.microsoft.com/office/drawing/2014/main" id="{48DD85EA-F621-4887-BBB9-5331E6D9FEB1}"/>
+                <a16:creationId xmlns:a16="http://schemas.microsoft.com/office/drawing/2014/main" id="{D0687950-6AB2-41D6-A58D-55803F6B35EE}"/>
               </a:ext>
             </a:extLst>
           </p:cNvPr>
@@ -3656,7 +3654,7 @@
           <p:cNvPr id="2" name="">
             <a:extLst xmlns:a="http://schemas.openxmlformats.org/drawingml/2006/main">
               <a:ext uri="{FF2B5EF4-FFF2-40B4-BE49-F238E27FC236}">
-                <a16:creationId xmlns:a16="http://schemas.microsoft.com/office/drawing/2014/main" id="{AD223706-5504-4582-BE8D-BE9160266CDA}"/>
+                <a16:creationId xmlns:a16="http://schemas.microsoft.com/office/drawing/2014/main" id="{08FD23A8-405B-4367-A581-0F1C8F3C4A39}"/>
               </a:ext>
             </a:extLst>
           </p:cNvPr>
@@ -3713,7 +3711,7 @@
           <p:cNvPr id="3" name="">
             <a:extLst xmlns:a="http://schemas.openxmlformats.org/drawingml/2006/main">
               <a:ext uri="{FF2B5EF4-FFF2-40B4-BE49-F238E27FC236}">
-                <a16:creationId xmlns:a16="http://schemas.microsoft.com/office/drawing/2014/main" id="{B7A43573-474A-48DF-8227-5E29949B85A0}"/>
+                <a16:creationId xmlns:a16="http://schemas.microsoft.com/office/drawing/2014/main" id="{08CE34D5-83AD-4003-A025-1F4EE885C070}"/>
               </a:ext>
             </a:extLst>
           </p:cNvPr>
@@ -3770,7 +3768,7 @@
           <p:cNvPr id="4" name="">
             <a:extLst xmlns:a="http://schemas.openxmlformats.org/drawingml/2006/main">
               <a:ext uri="{FF2B5EF4-FFF2-40B4-BE49-F238E27FC236}">
-                <a16:creationId xmlns:a16="http://schemas.microsoft.com/office/drawing/2014/main" id="{E30FF52F-2DA1-4735-8B6E-C3F42E59D639}"/>
+                <a16:creationId xmlns:a16="http://schemas.microsoft.com/office/drawing/2014/main" id="{2A81E5B3-FCD0-4890-95F9-1F6DA89C2FE4}"/>
               </a:ext>
             </a:extLst>
           </p:cNvPr>
@@ -3829,7 +3827,7 @@
           <p:cNvPr id="5" name="">
             <a:extLst xmlns:a="http://schemas.openxmlformats.org/drawingml/2006/main">
               <a:ext uri="{FF2B5EF4-FFF2-40B4-BE49-F238E27FC236}">
-                <a16:creationId xmlns:a16="http://schemas.microsoft.com/office/drawing/2014/main" id="{5D9B76A0-E26D-4715-A57D-C232BA2A906C}"/>
+                <a16:creationId xmlns:a16="http://schemas.microsoft.com/office/drawing/2014/main" id="{7252E241-914D-48E2-94A3-B27390004632}"/>
               </a:ext>
             </a:extLst>
           </p:cNvPr>
@@ -3911,7 +3909,7 @@
           <p:cNvPr id="6" name="">
             <a:extLst xmlns:a="http://schemas.openxmlformats.org/drawingml/2006/main">
               <a:ext uri="{FF2B5EF4-FFF2-40B4-BE49-F238E27FC236}">
-                <a16:creationId xmlns:a16="http://schemas.microsoft.com/office/drawing/2014/main" id="{8AEDA6F6-86B3-459F-B929-6CD1BAA29EE7}"/>
+                <a16:creationId xmlns:a16="http://schemas.microsoft.com/office/drawing/2014/main" id="{C2FA89AC-E7CA-4BCD-8DF1-8D6B530BF144}"/>
               </a:ext>
             </a:extLst>
           </p:cNvPr>
@@ -3993,7 +3991,7 @@
           <p:cNvPr id="7" name="">
             <a:extLst xmlns:a="http://schemas.openxmlformats.org/drawingml/2006/main">
               <a:ext uri="{FF2B5EF4-FFF2-40B4-BE49-F238E27FC236}">
-                <a16:creationId xmlns:a16="http://schemas.microsoft.com/office/drawing/2014/main" id="{BDD3DA9E-00D9-4EB5-92B0-F69AFDB3471D}"/>
+                <a16:creationId xmlns:a16="http://schemas.microsoft.com/office/drawing/2014/main" id="{96FC9337-7E48-46EE-ACDC-2230A6C66481}"/>
               </a:ext>
             </a:extLst>
           </p:cNvPr>
@@ -4075,7 +4073,7 @@
           <p:cNvPr id="8" name="">
             <a:extLst xmlns:a="http://schemas.openxmlformats.org/drawingml/2006/main">
               <a:ext uri="{FF2B5EF4-FFF2-40B4-BE49-F238E27FC236}">
-                <a16:creationId xmlns:a16="http://schemas.microsoft.com/office/drawing/2014/main" id="{AC024DCA-B7E8-4973-8501-EC7DE0FF6A29}"/>
+                <a16:creationId xmlns:a16="http://schemas.microsoft.com/office/drawing/2014/main" id="{60C7BDB4-3503-47D8-A11D-FA89CF47D672}"/>
               </a:ext>
             </a:extLst>
           </p:cNvPr>
@@ -4157,7 +4155,7 @@
           <p:cNvPr id="9" name="">
             <a:extLst xmlns:a="http://schemas.openxmlformats.org/drawingml/2006/main">
               <a:ext uri="{FF2B5EF4-FFF2-40B4-BE49-F238E27FC236}">
-                <a16:creationId xmlns:a16="http://schemas.microsoft.com/office/drawing/2014/main" id="{C8CD0C96-638D-4806-8DC2-15EF555C04A7}"/>
+                <a16:creationId xmlns:a16="http://schemas.microsoft.com/office/drawing/2014/main" id="{EC0660B6-4FD4-4C61-80BC-1A460DFAC4F4}"/>
               </a:ext>
             </a:extLst>
           </p:cNvPr>
@@ -4239,7 +4237,7 @@
           <p:cNvPr id="10" name="">
             <a:extLst xmlns:a="http://schemas.openxmlformats.org/drawingml/2006/main">
               <a:ext uri="{FF2B5EF4-FFF2-40B4-BE49-F238E27FC236}">
-                <a16:creationId xmlns:a16="http://schemas.microsoft.com/office/drawing/2014/main" id="{46F756A0-B5C5-46A8-AE7D-60D6EA771E54}"/>
+                <a16:creationId xmlns:a16="http://schemas.microsoft.com/office/drawing/2014/main" id="{D0D5EBC2-994A-43BA-B4D5-73922100FBB9}"/>
               </a:ext>
             </a:extLst>
           </p:cNvPr>
@@ -4471,7 +4469,7 @@
           <p:cNvPr id="17" name="">
             <a:extLst xmlns:a="http://schemas.openxmlformats.org/drawingml/2006/main">
               <a:ext uri="{FF2B5EF4-FFF2-40B4-BE49-F238E27FC236}">
-                <a16:creationId xmlns:a16="http://schemas.microsoft.com/office/drawing/2014/main" id="{0C4ABB0C-EA1B-4BDE-9B09-D9C164436701}"/>
+                <a16:creationId xmlns:a16="http://schemas.microsoft.com/office/drawing/2014/main" id="{9716D60A-BB04-4DC0-8135-8E02AAB05EA2}"/>
               </a:ext>
             </a:extLst>
           </p:cNvPr>
@@ -4574,7 +4572,7 @@
           <p:cNvPr id="18" name="">
             <a:extLst xmlns:a="http://schemas.openxmlformats.org/drawingml/2006/main">
               <a:ext uri="{FF2B5EF4-FFF2-40B4-BE49-F238E27FC236}">
-                <a16:creationId xmlns:a16="http://schemas.microsoft.com/office/drawing/2014/main" id="{1C35C1DF-D01B-430F-844C-1D4B4A1ED99C}"/>
+                <a16:creationId xmlns:a16="http://schemas.microsoft.com/office/drawing/2014/main" id="{D9F4CED5-026F-45A3-A27A-8141A949A782}"/>
               </a:ext>
             </a:extLst>
           </p:cNvPr>
@@ -4629,7 +4627,7 @@
     </p:spTree>
     <p:extLst>
       <p:ext uri="{BB962C8B-B14F-4D97-AF65-F5344CB8AC3E}">
-        <p14:creationId xmlns:p14="http://schemas.microsoft.com/office/powerpoint/2010/main" val="2020346041"/>
+        <p14:creationId xmlns:p14="http://schemas.microsoft.com/office/powerpoint/2010/main" val="2130007651"/>
       </p:ext>
     </p:extLst>
   </p:cSld>
@@ -4660,7 +4658,7 @@
           <p:cNvPr id="13" name="">
             <a:extLst xmlns:a="http://schemas.openxmlformats.org/drawingml/2006/main">
               <a:ext uri="{FF2B5EF4-FFF2-40B4-BE49-F238E27FC236}">
-                <a16:creationId xmlns:a16="http://schemas.microsoft.com/office/drawing/2014/main" id="{1A972775-8A74-4E7D-AA98-C8991AAD600B}"/>
+                <a16:creationId xmlns:a16="http://schemas.microsoft.com/office/drawing/2014/main" id="{AAC89148-783D-410A-BBD6-A71CB34616E2}"/>
               </a:ext>
             </a:extLst>
           </p:cNvPr>
@@ -4717,7 +4715,7 @@
           <p:cNvPr id="2" name="">
             <a:extLst xmlns:a="http://schemas.openxmlformats.org/drawingml/2006/main">
               <a:ext uri="{FF2B5EF4-FFF2-40B4-BE49-F238E27FC236}">
-                <a16:creationId xmlns:a16="http://schemas.microsoft.com/office/drawing/2014/main" id="{A8A810AB-0E98-4267-927E-0CE3C07BF9BC}"/>
+                <a16:creationId xmlns:a16="http://schemas.microsoft.com/office/drawing/2014/main" id="{3BB9DFDE-AE8C-43E4-8F1F-70D3AC26D9D7}"/>
               </a:ext>
             </a:extLst>
           </p:cNvPr>
@@ -4774,7 +4772,7 @@
           <p:cNvPr id="3" name="">
             <a:extLst xmlns:a="http://schemas.openxmlformats.org/drawingml/2006/main">
               <a:ext uri="{FF2B5EF4-FFF2-40B4-BE49-F238E27FC236}">
-                <a16:creationId xmlns:a16="http://schemas.microsoft.com/office/drawing/2014/main" id="{FED72CA0-818B-4A72-9223-E2A4B2C4C9E3}"/>
+                <a16:creationId xmlns:a16="http://schemas.microsoft.com/office/drawing/2014/main" id="{90824D11-AB4C-4805-834E-D2BC4FF719B1}"/>
               </a:ext>
             </a:extLst>
           </p:cNvPr>
@@ -4831,7 +4829,7 @@
           <p:cNvPr id="4" name="">
             <a:extLst xmlns:a="http://schemas.openxmlformats.org/drawingml/2006/main">
               <a:ext uri="{FF2B5EF4-FFF2-40B4-BE49-F238E27FC236}">
-                <a16:creationId xmlns:a16="http://schemas.microsoft.com/office/drawing/2014/main" id="{20C139CD-32EB-47F4-9A24-9A35F4D41081}"/>
+                <a16:creationId xmlns:a16="http://schemas.microsoft.com/office/drawing/2014/main" id="{1376B8B0-E09E-4471-9A7C-710926A37801}"/>
               </a:ext>
             </a:extLst>
           </p:cNvPr>
@@ -4934,7 +4932,7 @@
           <p:cNvPr id="5" name="">
             <a:extLst xmlns:a="http://schemas.openxmlformats.org/drawingml/2006/main">
               <a:ext uri="{FF2B5EF4-FFF2-40B4-BE49-F238E27FC236}">
-                <a16:creationId xmlns:a16="http://schemas.microsoft.com/office/drawing/2014/main" id="{E37F50AA-BC62-49AC-8B6E-732B45BFF14A}"/>
+                <a16:creationId xmlns:a16="http://schemas.microsoft.com/office/drawing/2014/main" id="{E1B607F9-D793-4811-89D3-484F0ACC47C4}"/>
               </a:ext>
             </a:extLst>
           </p:cNvPr>
@@ -4991,7 +4989,7 @@
           <p:cNvPr id="6" name="">
             <a:extLst xmlns:a="http://schemas.openxmlformats.org/drawingml/2006/main">
               <a:ext uri="{FF2B5EF4-FFF2-40B4-BE49-F238E27FC236}">
-                <a16:creationId xmlns:a16="http://schemas.microsoft.com/office/drawing/2014/main" id="{8B35FCFD-312D-48B8-9FBD-1372CDE18884}"/>
+                <a16:creationId xmlns:a16="http://schemas.microsoft.com/office/drawing/2014/main" id="{64A4F78A-1AD8-40A5-8CF8-660AB2D45BB2}"/>
               </a:ext>
             </a:extLst>
           </p:cNvPr>
@@ -5094,7 +5092,7 @@
           <p:cNvPr id="7" name="">
             <a:extLst xmlns:a="http://schemas.openxmlformats.org/drawingml/2006/main">
               <a:ext uri="{FF2B5EF4-FFF2-40B4-BE49-F238E27FC236}">
-                <a16:creationId xmlns:a16="http://schemas.microsoft.com/office/drawing/2014/main" id="{45D98E21-4E7B-4C7A-921F-B112EE1DB0F5}"/>
+                <a16:creationId xmlns:a16="http://schemas.microsoft.com/office/drawing/2014/main" id="{270DF2A6-4402-4C80-9E71-A79B42A0F14D}"/>
               </a:ext>
             </a:extLst>
           </p:cNvPr>
@@ -5151,7 +5149,7 @@
           <p:cNvPr id="8" name="">
             <a:extLst xmlns:a="http://schemas.openxmlformats.org/drawingml/2006/main">
               <a:ext uri="{FF2B5EF4-FFF2-40B4-BE49-F238E27FC236}">
-                <a16:creationId xmlns:a16="http://schemas.microsoft.com/office/drawing/2014/main" id="{5959AC15-E5F2-4C60-919F-9AF36917E698}"/>
+                <a16:creationId xmlns:a16="http://schemas.microsoft.com/office/drawing/2014/main" id="{13AD4579-CD31-4242-B0D7-49DFF6BFFC0C}"/>
               </a:ext>
             </a:extLst>
           </p:cNvPr>
@@ -5215,7 +5213,7 @@
         </p:xfrm>
         <a:graphic xmlns:a="http://schemas.openxmlformats.org/drawingml/2006/main">
           <a:graphicData uri="http://schemas.openxmlformats.org/drawingml/2006/chart">
-            <c:chart xmlns:r="http://schemas.openxmlformats.org/officeDocument/2006/relationships" xmlns:c="http://schemas.openxmlformats.org/drawingml/2006/chart" r:id="R69af81f195f74134"/>
+            <c:chart xmlns:r="http://schemas.openxmlformats.org/officeDocument/2006/relationships" xmlns:c="http://schemas.openxmlformats.org/drawingml/2006/chart" r:id="Rd40bcac2942147bf"/>
           </a:graphicData>
         </a:graphic>
       </p:graphicFrame>
@@ -5224,7 +5222,7 @@
           <p:cNvPr id="10" name="">
             <a:extLst xmlns:a="http://schemas.openxmlformats.org/drawingml/2006/main">
               <a:ext uri="{FF2B5EF4-FFF2-40B4-BE49-F238E27FC236}">
-                <a16:creationId xmlns:a16="http://schemas.microsoft.com/office/drawing/2014/main" id="{8E413214-556B-4F7B-9303-3C4BE35F0D26}"/>
+                <a16:creationId xmlns:a16="http://schemas.microsoft.com/office/drawing/2014/main" id="{E0F38D4F-E443-4A54-A9EA-E06D4EAF930E}"/>
               </a:ext>
             </a:extLst>
           </p:cNvPr>
@@ -5281,7 +5279,7 @@
           <p:cNvPr id="11" name="">
             <a:extLst xmlns:a="http://schemas.openxmlformats.org/drawingml/2006/main">
               <a:ext uri="{FF2B5EF4-FFF2-40B4-BE49-F238E27FC236}">
-                <a16:creationId xmlns:a16="http://schemas.microsoft.com/office/drawing/2014/main" id="{E2A29645-D4CA-4C99-B330-F7DBDB388392}"/>
+                <a16:creationId xmlns:a16="http://schemas.microsoft.com/office/drawing/2014/main" id="{5979F1CD-C770-4CF0-A62C-95C74F8022A5}"/>
               </a:ext>
             </a:extLst>
           </p:cNvPr>
@@ -5361,7 +5359,7 @@
           <p:cNvPr id="12" name="">
             <a:extLst xmlns:a="http://schemas.openxmlformats.org/drawingml/2006/main">
               <a:ext uri="{FF2B5EF4-FFF2-40B4-BE49-F238E27FC236}">
-                <a16:creationId xmlns:a16="http://schemas.microsoft.com/office/drawing/2014/main" id="{DAC0EA6E-2E63-4E98-BE44-970AB55150E7}"/>
+                <a16:creationId xmlns:a16="http://schemas.microsoft.com/office/drawing/2014/main" id="{FFDAC15A-F8AE-48CA-918D-F56108E7E029}"/>
               </a:ext>
             </a:extLst>
           </p:cNvPr>
@@ -5416,7 +5414,7 @@
     </p:spTree>
     <p:extLst>
       <p:ext uri="{BB962C8B-B14F-4D97-AF65-F5344CB8AC3E}">
-        <p14:creationId xmlns:p14="http://schemas.microsoft.com/office/powerpoint/2010/main" val="1922396985"/>
+        <p14:creationId xmlns:p14="http://schemas.microsoft.com/office/powerpoint/2010/main" val="479116985"/>
       </p:ext>
     </p:extLst>
   </p:cSld>
@@ -5447,7 +5445,7 @@
           <p:cNvPr id="13" name="">
             <a:extLst xmlns:a="http://schemas.openxmlformats.org/drawingml/2006/main">
               <a:ext uri="{FF2B5EF4-FFF2-40B4-BE49-F238E27FC236}">
-                <a16:creationId xmlns:a16="http://schemas.microsoft.com/office/drawing/2014/main" id="{8884DF14-2A04-4F71-B934-670C8E14895B}"/>
+                <a16:creationId xmlns:a16="http://schemas.microsoft.com/office/drawing/2014/main" id="{741C003B-754A-4724-806E-5D58E568B0EF}"/>
               </a:ext>
             </a:extLst>
           </p:cNvPr>
@@ -5504,7 +5502,7 @@
           <p:cNvPr id="2" name="">
             <a:extLst xmlns:a="http://schemas.openxmlformats.org/drawingml/2006/main">
               <a:ext uri="{FF2B5EF4-FFF2-40B4-BE49-F238E27FC236}">
-                <a16:creationId xmlns:a16="http://schemas.microsoft.com/office/drawing/2014/main" id="{BEB3EF82-A594-4337-A880-3BF4D4D3C750}"/>
+                <a16:creationId xmlns:a16="http://schemas.microsoft.com/office/drawing/2014/main" id="{6D227275-ADE4-44AB-974A-119194E40852}"/>
               </a:ext>
             </a:extLst>
           </p:cNvPr>
@@ -5561,7 +5559,7 @@
           <p:cNvPr id="3" name="">
             <a:extLst xmlns:a="http://schemas.openxmlformats.org/drawingml/2006/main">
               <a:ext uri="{FF2B5EF4-FFF2-40B4-BE49-F238E27FC236}">
-                <a16:creationId xmlns:a16="http://schemas.microsoft.com/office/drawing/2014/main" id="{4C6988F4-40F0-447D-ADAD-0990AF7BA8AC}"/>
+                <a16:creationId xmlns:a16="http://schemas.microsoft.com/office/drawing/2014/main" id="{125A39BF-2B26-4E4A-8B78-9B35274F0FCF}"/>
               </a:ext>
             </a:extLst>
           </p:cNvPr>
@@ -5618,7 +5616,7 @@
           <p:cNvPr id="4" name="">
             <a:extLst xmlns:a="http://schemas.openxmlformats.org/drawingml/2006/main">
               <a:ext uri="{FF2B5EF4-FFF2-40B4-BE49-F238E27FC236}">
-                <a16:creationId xmlns:a16="http://schemas.microsoft.com/office/drawing/2014/main" id="{CA5161D5-DE60-4D1D-8631-2AED03ED0C4F}"/>
+                <a16:creationId xmlns:a16="http://schemas.microsoft.com/office/drawing/2014/main" id="{B87814BC-9E26-45B6-B75B-E8B9EFBB2C73}"/>
               </a:ext>
             </a:extLst>
           </p:cNvPr>
@@ -5682,7 +5680,7 @@
         </p:xfrm>
         <a:graphic xmlns:a="http://schemas.openxmlformats.org/drawingml/2006/main">
           <a:graphicData uri="http://schemas.openxmlformats.org/drawingml/2006/chart">
-            <c:chart xmlns:r="http://schemas.openxmlformats.org/officeDocument/2006/relationships" xmlns:c="http://schemas.openxmlformats.org/drawingml/2006/chart" r:id="R53dda46d526e4237"/>
+            <c:chart xmlns:r="http://schemas.openxmlformats.org/officeDocument/2006/relationships" xmlns:c="http://schemas.openxmlformats.org/drawingml/2006/chart" r:id="R231e224b0f8e4fca"/>
           </a:graphicData>
         </a:graphic>
       </p:graphicFrame>
@@ -5691,7 +5689,7 @@
           <p:cNvPr id="6" name="">
             <a:extLst xmlns:a="http://schemas.openxmlformats.org/drawingml/2006/main">
               <a:ext uri="{FF2B5EF4-FFF2-40B4-BE49-F238E27FC236}">
-                <a16:creationId xmlns:a16="http://schemas.microsoft.com/office/drawing/2014/main" id="{D80550C6-578A-418C-982B-9EBB1B483D4E}"/>
+                <a16:creationId xmlns:a16="http://schemas.microsoft.com/office/drawing/2014/main" id="{59C64771-127A-4ADA-91DF-33E835323D98}"/>
               </a:ext>
             </a:extLst>
           </p:cNvPr>
@@ -5738,7 +5736,7 @@
                 <a:ea typeface="Noto Sans"/>
                 <a:cs typeface="Noto Sans"/>
               </a:rPr>
-              <a:t>Current local workflow</a:t>
+              <a:t>Current chat regression</a:t>
             </a:r>
           </a:p>
         </p:txBody>
@@ -5748,7 +5746,7 @@
           <p:cNvPr id="7" name="">
             <a:extLst xmlns:a="http://schemas.openxmlformats.org/drawingml/2006/main">
               <a:ext uri="{FF2B5EF4-FFF2-40B4-BE49-F238E27FC236}">
-                <a16:creationId xmlns:a16="http://schemas.microsoft.com/office/drawing/2014/main" id="{AB179CB1-2832-47B7-8CB2-83FD99E11582}"/>
+                <a16:creationId xmlns:a16="http://schemas.microsoft.com/office/drawing/2014/main" id="{7F571322-F273-41E8-BE4E-B767B24DA22A}"/>
               </a:ext>
             </a:extLst>
           </p:cNvPr>
@@ -5812,7 +5810,7 @@
         </p:xfrm>
         <a:graphic xmlns:a="http://schemas.openxmlformats.org/drawingml/2006/main">
           <a:graphicData uri="http://schemas.openxmlformats.org/drawingml/2006/chart">
-            <c:chart xmlns:r="http://schemas.openxmlformats.org/officeDocument/2006/relationships" xmlns:c="http://schemas.openxmlformats.org/drawingml/2006/chart" r:id="R8d59a20d0d5a41f4"/>
+            <c:chart xmlns:r="http://schemas.openxmlformats.org/officeDocument/2006/relationships" xmlns:c="http://schemas.openxmlformats.org/drawingml/2006/chart" r:id="R947b0da69a084fed"/>
           </a:graphicData>
         </a:graphic>
       </p:graphicFrame>
@@ -5821,7 +5819,7 @@
           <p:cNvPr id="9" name="">
             <a:extLst xmlns:a="http://schemas.openxmlformats.org/drawingml/2006/main">
               <a:ext uri="{FF2B5EF4-FFF2-40B4-BE49-F238E27FC236}">
-                <a16:creationId xmlns:a16="http://schemas.microsoft.com/office/drawing/2014/main" id="{2C370169-DF68-4DD2-8E25-099CE2948DFF}"/>
+                <a16:creationId xmlns:a16="http://schemas.microsoft.com/office/drawing/2014/main" id="{4933C9D9-5D7D-4791-9811-44035AFF0209}"/>
               </a:ext>
             </a:extLst>
           </p:cNvPr>
@@ -5868,7 +5866,7 @@
                 <a:ea typeface="Noto Sans"/>
                 <a:cs typeface="Noto Sans"/>
               </a:rPr>
-              <a:t>117/140 exact labels correct</a:t>
+              <a:t>Historical intent labels: 117/140</a:t>
             </a:r>
           </a:p>
         </p:txBody>
@@ -5878,7 +5876,7 @@
           <p:cNvPr id="10" name="">
             <a:extLst xmlns:a="http://schemas.openxmlformats.org/drawingml/2006/main">
               <a:ext uri="{FF2B5EF4-FFF2-40B4-BE49-F238E27FC236}">
-                <a16:creationId xmlns:a16="http://schemas.microsoft.com/office/drawing/2014/main" id="{007669F8-A7CB-4713-B9C1-03A8C156218E}"/>
+                <a16:creationId xmlns:a16="http://schemas.microsoft.com/office/drawing/2014/main" id="{0E7F1846-A710-40FA-9D3C-1A48DA59E17B}"/>
               </a:ext>
             </a:extLst>
           </p:cNvPr>
@@ -5925,7 +5923,7 @@
                 <a:ea typeface="Noto Sans"/>
                 <a:cs typeface="Noto Sans"/>
               </a:rPr>
-              <a:t>60/60 handoffs preserve the request</a:t>
+              <a:t>60/60 handoffs; 10 workflow errors</a:t>
             </a:r>
           </a:p>
         </p:txBody>
@@ -5935,7 +5933,7 @@
           <p:cNvPr id="11" name="">
             <a:extLst xmlns:a="http://schemas.openxmlformats.org/drawingml/2006/main">
               <a:ext uri="{FF2B5EF4-FFF2-40B4-BE49-F238E27FC236}">
-                <a16:creationId xmlns:a16="http://schemas.microsoft.com/office/drawing/2014/main" id="{F5232CE0-5889-4A23-93DF-0DF14E898BCE}"/>
+                <a16:creationId xmlns:a16="http://schemas.microsoft.com/office/drawing/2014/main" id="{FA5C6FBF-BD9C-4911-B43E-0CE4AF5B545E}"/>
               </a:ext>
             </a:extLst>
           </p:cNvPr>
@@ -5982,7 +5980,7 @@
                 <a:ea typeface="Noto Sans"/>
                 <a:cs typeface="Noto Sans"/>
               </a:rPr>
-              <a:t>Six status/currency strata: 122/140 each. Same utterances, no demographic claim.</a:t>
+              <a:t>Current six status/currency strata: 130/140 each. Same authored utterances.</a:t>
             </a:r>
           </a:p>
         </p:txBody>
@@ -5992,7 +5990,7 @@
           <p:cNvPr id="12" name="">
             <a:extLst xmlns:a="http://schemas.openxmlformats.org/drawingml/2006/main">
               <a:ext uri="{FF2B5EF4-FFF2-40B4-BE49-F238E27FC236}">
-                <a16:creationId xmlns:a16="http://schemas.microsoft.com/office/drawing/2014/main" id="{77A3BC32-EF99-4E14-AB4C-1B3D84978713}"/>
+                <a16:creationId xmlns:a16="http://schemas.microsoft.com/office/drawing/2014/main" id="{F632CEA5-7492-46FA-B542-7CBEFE2943B7}"/>
               </a:ext>
             </a:extLst>
           </p:cNvPr>
@@ -6039,7 +6037,7 @@
                 <a:ea typeface="Noto Sans"/>
                 <a:cs typeface="Noto Sans"/>
               </a:rPr>
-              <a:t>Authored tests, no independent human review. New 70-case provider challenge unscored.</a:t>
+              <a:t>Stronger case grounding scorer. Exposed authored regressions, no independent human review.</a:t>
             </a:r>
           </a:p>
         </p:txBody>
@@ -6047,7 +6045,7 @@
     </p:spTree>
     <p:extLst>
       <p:ext uri="{BB962C8B-B14F-4D97-AF65-F5344CB8AC3E}">
-        <p14:creationId xmlns:p14="http://schemas.microsoft.com/office/powerpoint/2010/main" val="1794214335"/>
+        <p14:creationId xmlns:p14="http://schemas.microsoft.com/office/powerpoint/2010/main" val="342198508"/>
       </p:ext>
     </p:extLst>
   </p:cSld>
@@ -6078,7 +6076,7 @@
           <p:cNvPr id="11" name="">
             <a:extLst xmlns:a="http://schemas.openxmlformats.org/drawingml/2006/main">
               <a:ext uri="{FF2B5EF4-FFF2-40B4-BE49-F238E27FC236}">
-                <a16:creationId xmlns:a16="http://schemas.microsoft.com/office/drawing/2014/main" id="{56500774-B1C5-44F9-A047-524E6B49B9DD}"/>
+                <a16:creationId xmlns:a16="http://schemas.microsoft.com/office/drawing/2014/main" id="{BE436B56-442B-4603-9C7D-9EECDC38DC62}"/>
               </a:ext>
             </a:extLst>
           </p:cNvPr>
@@ -6135,7 +6133,7 @@
           <p:cNvPr id="2" name="">
             <a:extLst xmlns:a="http://schemas.openxmlformats.org/drawingml/2006/main">
               <a:ext uri="{FF2B5EF4-FFF2-40B4-BE49-F238E27FC236}">
-                <a16:creationId xmlns:a16="http://schemas.microsoft.com/office/drawing/2014/main" id="{F27AE826-6CC7-4A75-85DA-B72EC77110C2}"/>
+                <a16:creationId xmlns:a16="http://schemas.microsoft.com/office/drawing/2014/main" id="{3956A237-DE56-4F24-909F-5E30FD20B085}"/>
               </a:ext>
             </a:extLst>
           </p:cNvPr>
@@ -6196,16 +6194,14 @@
           <p:nvPr/>
         </p:nvPicPr>
         <p:blipFill>
-          <a:blip xmlns:r="http://schemas.openxmlformats.org/officeDocument/2006/relationships" xmlns:a="http://schemas.openxmlformats.org/drawingml/2006/main" r:embed="R386a6be8073445b0"/>
-          <a:srcRect xmlns:a="http://schemas.openxmlformats.org/drawingml/2006/main" l="0" t="7749" r="0" b="7749"/>
-          <a:stretch xmlns:a="http://schemas.openxmlformats.org/drawingml/2006/main">
-            <a:fillRect l="0" t="0" r="0" b="0"/>
-          </a:stretch>
+          <a:blip xmlns:r="http://schemas.openxmlformats.org/officeDocument/2006/relationships" xmlns:a="http://schemas.openxmlformats.org/drawingml/2006/main" r:embed="Ra18ae027daa54f75"/>
+          <a:srcRect xmlns:a="http://schemas.openxmlformats.org/drawingml/2006/main" l="46976" t="43064" r="3159" b="10116"/>
+          <a:stretch xmlns:a="http://schemas.openxmlformats.org/drawingml/2006/main"/>
         </p:blipFill>
         <p:spPr>
           <a:xfrm xmlns:a="http://schemas.openxmlformats.org/drawingml/2006/main">
-            <a:off x="609600" y="1590675"/>
-            <a:ext cx="5429250" cy="3200400"/>
+            <a:off x="609600" y="1741445"/>
+            <a:ext cx="5429250" cy="3556086"/>
           </a:xfrm>
           <a:prstGeom xmlns:a="http://schemas.openxmlformats.org/drawingml/2006/main" prst="rect">
             <a:avLst/>
@@ -6217,7 +6213,7 @@
           <p:cNvPr id="4" name="">
             <a:extLst xmlns:a="http://schemas.openxmlformats.org/drawingml/2006/main">
               <a:ext uri="{FF2B5EF4-FFF2-40B4-BE49-F238E27FC236}">
-                <a16:creationId xmlns:a16="http://schemas.microsoft.com/office/drawing/2014/main" id="{9126824C-848C-4943-B6BF-55C2C666D5B4}"/>
+                <a16:creationId xmlns:a16="http://schemas.microsoft.com/office/drawing/2014/main" id="{3315EE2D-4E60-48CE-8506-4A89A6375328}"/>
               </a:ext>
             </a:extLst>
           </p:cNvPr>
@@ -6228,8 +6224,8 @@
         </p:nvSpPr>
         <p:spPr>
           <a:xfrm xmlns:a="http://schemas.openxmlformats.org/drawingml/2006/main">
-            <a:off x="609600" y="4905375"/>
-            <a:ext cx="5619750" cy="400050"/>
+            <a:off x="609600" y="5553075"/>
+            <a:ext cx="5619750" cy="333375"/>
           </a:xfrm>
           <a:prstGeom xmlns:a="http://schemas.openxmlformats.org/drawingml/2006/main" prst="rect">
             <a:avLst/>
@@ -6246,7 +6242,7 @@
           <a:lstStyle xmlns:a="http://schemas.openxmlformats.org/drawingml/2006/main"/>
           <a:p xmlns:a="http://schemas.openxmlformats.org/drawingml/2006/main">
             <a:pPr algn="l">
-              <a:defRPr sz="1875" b="1">
+              <a:defRPr sz="1725" b="1">
                 <a:solidFill>
                   <a:srgbClr val="67E2C4"/>
                 </a:solidFill>
@@ -6256,7 +6252,7 @@
               </a:defRPr>
             </a:pPr>
             <a:r>
-              <a:rPr sz="1875" b="1">
+              <a:rPr sz="1725" b="1">
                 <a:solidFill>
                   <a:srgbClr val="67E2C4"/>
                 </a:solidFill>
@@ -6264,7 +6260,7 @@
                 <a:ea typeface="Noto Sans"/>
                 <a:cs typeface="Noto Sans"/>
               </a:rPr>
-              <a:t>Public demo / release receipt linked</a:t>
+              <a:t>Prior v1.1 hosted demo</a:t>
             </a:r>
           </a:p>
         </p:txBody>
@@ -6274,7 +6270,7 @@
           <p:cNvPr id="5" name="">
             <a:extLst xmlns:a="http://schemas.openxmlformats.org/drawingml/2006/main">
               <a:ext uri="{FF2B5EF4-FFF2-40B4-BE49-F238E27FC236}">
-                <a16:creationId xmlns:a16="http://schemas.microsoft.com/office/drawing/2014/main" id="{3D1AC7C3-749D-4B36-8ED6-A86D5031B4C3}"/>
+                <a16:creationId xmlns:a16="http://schemas.microsoft.com/office/drawing/2014/main" id="{A85AE64E-29A7-428A-AF05-356314A8429B}"/>
               </a:ext>
             </a:extLst>
           </p:cNvPr>
@@ -6285,8 +6281,8 @@
         </p:nvSpPr>
         <p:spPr>
           <a:xfrm xmlns:a="http://schemas.openxmlformats.org/drawingml/2006/main">
-            <a:off x="609600" y="5362575"/>
-            <a:ext cx="5619750" cy="733425"/>
+            <a:off x="609600" y="5953125"/>
+            <a:ext cx="5619750" cy="381000"/>
           </a:xfrm>
           <a:prstGeom xmlns:a="http://schemas.openxmlformats.org/drawingml/2006/main" prst="rect">
             <a:avLst/>
@@ -6303,7 +6299,7 @@
           <a:lstStyle xmlns:a="http://schemas.openxmlformats.org/drawingml/2006/main"/>
           <a:p xmlns:a="http://schemas.openxmlformats.org/drawingml/2006/main">
             <a:pPr algn="l">
-              <a:defRPr sz="1500" b="0">
+              <a:defRPr sz="1200" b="0">
                 <a:solidFill>
                   <a:srgbClr val="F7FAFC"/>
                 </a:solidFill>
@@ -6313,7 +6309,7 @@
               </a:defRPr>
             </a:pPr>
             <a:r>
-              <a:rPr sz="1500" b="0">
+              <a:rPr sz="1200" b="0">
                 <a:solidFill>
                   <a:srgbClr val="F7FAFC"/>
                 </a:solidFill>
@@ -6331,7 +6327,7 @@
           <p:cNvPr id="6" name="">
             <a:extLst xmlns:a="http://schemas.openxmlformats.org/drawingml/2006/main">
               <a:ext uri="{FF2B5EF4-FFF2-40B4-BE49-F238E27FC236}">
-                <a16:creationId xmlns:a16="http://schemas.microsoft.com/office/drawing/2014/main" id="{2CAC9F97-BFEE-4BC7-ADB8-E3F199D05434}"/>
+                <a16:creationId xmlns:a16="http://schemas.microsoft.com/office/drawing/2014/main" id="{978656DC-C656-4F83-87FA-DC1FC7882758}"/>
               </a:ext>
             </a:extLst>
           </p:cNvPr>
@@ -6388,7 +6384,7 @@
           <p:cNvPr id="7" name="">
             <a:extLst xmlns:a="http://schemas.openxmlformats.org/drawingml/2006/main">
               <a:ext uri="{FF2B5EF4-FFF2-40B4-BE49-F238E27FC236}">
-                <a16:creationId xmlns:a16="http://schemas.microsoft.com/office/drawing/2014/main" id="{2A4694A8-CA0E-4B6A-9770-73CF7EC148CE}"/>
+                <a16:creationId xmlns:a16="http://schemas.microsoft.com/office/drawing/2014/main" id="{4AC2A95B-8054-4872-8BEC-D106758C970D}"/>
               </a:ext>
             </a:extLst>
           </p:cNvPr>
@@ -6491,7 +6487,7 @@
           <p:cNvPr id="8" name="">
             <a:extLst xmlns:a="http://schemas.openxmlformats.org/drawingml/2006/main">
               <a:ext uri="{FF2B5EF4-FFF2-40B4-BE49-F238E27FC236}">
-                <a16:creationId xmlns:a16="http://schemas.microsoft.com/office/drawing/2014/main" id="{37104DFE-EE70-4159-8288-00B1706785A2}"/>
+                <a16:creationId xmlns:a16="http://schemas.microsoft.com/office/drawing/2014/main" id="{275CF8C7-37B4-4CAE-8FA3-36CD0D8DE677}"/>
               </a:ext>
             </a:extLst>
           </p:cNvPr>
@@ -6594,7 +6590,7 @@
           <p:cNvPr id="9" name="">
             <a:extLst xmlns:a="http://schemas.openxmlformats.org/drawingml/2006/main">
               <a:ext uri="{FF2B5EF4-FFF2-40B4-BE49-F238E27FC236}">
-                <a16:creationId xmlns:a16="http://schemas.microsoft.com/office/drawing/2014/main" id="{C7E4D431-1B83-47E7-B0DE-FADA05046868}"/>
+                <a16:creationId xmlns:a16="http://schemas.microsoft.com/office/drawing/2014/main" id="{0179501B-E3E2-46EE-8297-B64D29201ADE}"/>
               </a:ext>
             </a:extLst>
           </p:cNvPr>
@@ -6651,7 +6647,7 @@
           <p:cNvPr id="10" name="">
             <a:extLst xmlns:a="http://schemas.openxmlformats.org/drawingml/2006/main">
               <a:ext uri="{FF2B5EF4-FFF2-40B4-BE49-F238E27FC236}">
-                <a16:creationId xmlns:a16="http://schemas.microsoft.com/office/drawing/2014/main" id="{4C5B1D7D-9034-460B-AB20-EE7D850E9B6A}"/>
+                <a16:creationId xmlns:a16="http://schemas.microsoft.com/office/drawing/2014/main" id="{67EB4FA9-0C04-4B10-BF2E-ABBE6541FD50}"/>
               </a:ext>
             </a:extLst>
           </p:cNvPr>
@@ -6729,7 +6725,7 @@
     </p:spTree>
     <p:extLst>
       <p:ext uri="{BB962C8B-B14F-4D97-AF65-F5344CB8AC3E}">
-        <p14:creationId xmlns:p14="http://schemas.microsoft.com/office/powerpoint/2010/main" val="186951206"/>
+        <p14:creationId xmlns:p14="http://schemas.microsoft.com/office/powerpoint/2010/main" val="1941918709"/>
       </p:ext>
     </p:extLst>
   </p:cSld>

</xml_diff>

<commit_message>
Resolve final chat review findings and refresh proven demo evidence
</commit_message>
<xml_diff>
--- a/submission/Claro-Hackathon-2026.pptx
+++ b/submission/Claro-Hackathon-2026.pptx
@@ -2,18 +2,18 @@
 <file path=ppt/presentation.xml><?xml version="1.0" encoding="utf-8"?>
 <p:presentation xmlns:p="http://schemas.openxmlformats.org/presentationml/2006/main">
   <p:sldMasterIdLst>
-    <p:sldMasterId xmlns:r="http://schemas.openxmlformats.org/officeDocument/2006/relationships" id="2147483648" r:id="Rb38acc3795834b0c"/>
+    <p:sldMasterId xmlns:r="http://schemas.openxmlformats.org/officeDocument/2006/relationships" id="2147483648" r:id="R8be612e034384eb4"/>
   </p:sldMasterIdLst>
   <p:notesMasterIdLst>
-    <p:notesMasterId xmlns:r="http://schemas.openxmlformats.org/officeDocument/2006/relationships" r:id="R87151ddffe9a4de9"/>
+    <p:notesMasterId xmlns:r="http://schemas.openxmlformats.org/officeDocument/2006/relationships" r:id="R39999bb0da03487f"/>
   </p:notesMasterIdLst>
   <p:sldIdLst>
-    <p:sldId xmlns:r="http://schemas.openxmlformats.org/officeDocument/2006/relationships" id="256" r:id="R0430d690aa9e4ef2"/>
-    <p:sldId xmlns:r="http://schemas.openxmlformats.org/officeDocument/2006/relationships" id="257" r:id="Rbc124856a8cf48c1"/>
-    <p:sldId xmlns:r="http://schemas.openxmlformats.org/officeDocument/2006/relationships" id="258" r:id="Rb01446d11fd34802"/>
-    <p:sldId xmlns:r="http://schemas.openxmlformats.org/officeDocument/2006/relationships" id="259" r:id="R8721c1c67cf84262"/>
-    <p:sldId xmlns:r="http://schemas.openxmlformats.org/officeDocument/2006/relationships" id="260" r:id="R5cffc4a3f5df4a3d"/>
-    <p:sldId xmlns:r="http://schemas.openxmlformats.org/officeDocument/2006/relationships" id="261" r:id="Rafa164445f2a4ac9"/>
+    <p:sldId xmlns:r="http://schemas.openxmlformats.org/officeDocument/2006/relationships" id="256" r:id="Rf0e624af19d24b3d"/>
+    <p:sldId xmlns:r="http://schemas.openxmlformats.org/officeDocument/2006/relationships" id="257" r:id="Rc807c72537ed4227"/>
+    <p:sldId xmlns:r="http://schemas.openxmlformats.org/officeDocument/2006/relationships" id="258" r:id="Rdb647a4494b14ce9"/>
+    <p:sldId xmlns:r="http://schemas.openxmlformats.org/officeDocument/2006/relationships" id="259" r:id="Ra6cf97db031d4856"/>
+    <p:sldId xmlns:r="http://schemas.openxmlformats.org/officeDocument/2006/relationships" id="260" r:id="R3bf677607fd7414d"/>
+    <p:sldId xmlns:r="http://schemas.openxmlformats.org/officeDocument/2006/relationships" id="261" r:id="R9e4c003dd4d94578"/>
   </p:sldIdLst>
   <p:sldSz cx="12192000" cy="6858000"/>
   <p:notesSz cx="6858000" cy="9144000"/>
@@ -517,7 +517,7 @@
           <a:lstStyle xmlns:a="http://schemas.openxmlformats.org/drawingml/2006/main"/>
           <a:p xmlns:a="http://schemas.openxmlformats.org/drawingml/2006/main">
             <a:r>
-              <a:t>Screenshot: current local Claro chat captured with CUA at http://127.0.0.1:8096 on October 4, 2026 America/Bogota, team-authored synthetic fixtures and external providers disabled. The UI creates a trusted sandbox session without persona or language selectors. ES/PT detection never changes customer identity. Exact references narrow validated authorized records and ambiguity prompts clarification. The customer report preserves specific redacted allegations through transaction clarification and is labeled unverified; permitted record facts remain separate. Customer sees the text before confirming. Atomic case commit and fresh read-back precede the receipt. The reviewer route is /?review=1. The owning customer answers a persisted question in the same composer. Case events remain scoped and idempotent. No real money movement, refunds or card blocking. Sources: docs/SYSTEM_EVALUATION.md, docs/OPERATIONS.md, api.py, privacy.py, store.py and workflow.py.</a:t>
+              <a:t>Screenshot provenance: CUA Chrome, http://127.0.0.1:8096, 2026-10-05 UTC; actual isolated sandbox with team-authored fixtures and external providers disabled; final backend/static hashes and checks in docs/evidence/chat-browser-checks.json. The UI creates a trusted sandbox session without persona or language selectors. ES/PT detection never changes customer identity. Exact references narrow validated authorized records and ambiguity prompts clarification. The customer report preserves specific redacted allegations through transaction clarification and is labeled unverified; permitted record facts remain separate. Customer sees the specific redacted report and attached transaction ID, merchant, amount/currency and recorded status before confirming. Explicit general human-review requests attach no transaction. Atomic case commit and fresh read-back precede the receipt. The reviewer route is /?review=1. The owning customer answers a persisted question in the same composer. Case events remain scoped and idempotent. No real money movement, refunds or card blocking. Sources: docs/SYSTEM_EVALUATION.md, docs/OPERATIONS.md, api.py, privacy.py, store.py and workflow.py.</a:t>
             </a:r>
           </a:p>
         </p:txBody>
@@ -797,7 +797,7 @@
           <a:lstStyle xmlns:a="http://schemas.openxmlformats.org/drawingml/2006/main"/>
           <a:p xmlns:a="http://schemas.openxmlformats.org/drawingml/2006/main">
             <a:r>
-              <a:t>Repository: https://github.com/nicoceron/factored-hackathon-2026-nicoceron . Public URL is tied to the prior v1.1 commit and verification date in submission/deployment.json. The current chat redesign is local and has not been deployed. Reviewer access is /?review=1 and customer chat is /. Current local screenshots do not independently prove that a newer branch is deployed. Optional Jev/DeepSeek adapters are implemented/mocked but live inference remains unverified pending authorized metered use. External tariff estimates are not invoice spend. Screenshot is a declared geometry crop of the current local reviewer timeline. Its Spanish interface retains the original Spanish report plus Portuguese question and reply; the filename does not imply a Portuguese-only interface. Screenshot was captured with CUA at http://127.0.0.1:8096 on October 4, 2026 America/Bogota using team fixtures and disabled providers. Free-host filesystem may reset. Sources: docs/AI_PROVIDERS.md, docs/OPERATIONS.md and submission/deployment.json. Real-bank requirements include approved identity/entitlements/MFA/policies, durable data, monitored rollout, privacy controls, independent ES/PT review and staffing. Organizer submission is intentionally outside requested scope. No real-bank operation or production safety certification.</a:t>
+              <a:t>Repository: https://github.com/nicoceron/factored-hackathon-2026-nicoceron . Public URL remains tied to the prior v1.1 receipt. The current chat redesign is local and has not been deployed. Reviewer access is /?review=1 and customer chat is /. Current local screenshots do not independently prove that a newer branch is deployed. Optional Jev/DeepSeek adapters are implemented/mocked but live inference remains unverified pending authorized metered use. External tariff estimates are not invoice spend. Screenshot is a declared geometry crop of the current local reviewer timeline. Its Spanish interface retains the original Spanish report plus Portuguese question and reply; the filename does not imply a Portuguese-only interface. Declared screenshot provenance: CUA Chrome, http://127.0.0.1:8096, 2026-10-05 UTC; actual isolated sandbox with team-authored fixtures and external providers disabled; final backend/static hashes and checks in docs/evidence/chat-browser-checks.json. Free-host filesystem may reset. Sources: docs/AI_PROVIDERS.md, docs/OPERATIONS.md and submission/deployment.json. Real-bank requirements include approved identity/entitlements/MFA/policies, durable data, monitored rollout, privacy controls, independent ES/PT review and staffing. Organizer submission is intentionally outside requested scope. No real-bank operation or production safety certification.</a:t>
             </a:r>
           </a:p>
         </p:txBody>
@@ -865,7 +865,7 @@
   </p:cSld>
   <p:clrMap bg1="lt1" tx1="dk1" bg2="lt2" tx2="dk2" accent1="accent1" accent2="accent2" accent3="accent3" accent4="accent4" accent5="accent5" accent6="accent6" hlink="hlink" folHlink="folHlink"/>
   <p:sldLayoutIdLst>
-    <p:sldLayoutId xmlns:r="http://schemas.openxmlformats.org/officeDocument/2006/relationships" id="2147483649" r:id="R3512fa17c0534a58"/>
+    <p:sldLayoutId xmlns:r="http://schemas.openxmlformats.org/officeDocument/2006/relationships" id="2147483649" r:id="R598ace7b97f64e01"/>
   </p:sldLayoutIdLst>
   <p:txStyles>
     <p:titleStyle>
@@ -2409,7 +2409,7 @@
           <p:cNvPr id="10" name="">
             <a:extLst xmlns:a="http://schemas.openxmlformats.org/drawingml/2006/main">
               <a:ext uri="{FF2B5EF4-FFF2-40B4-BE49-F238E27FC236}">
-                <a16:creationId xmlns:a16="http://schemas.microsoft.com/office/drawing/2014/main" id="{528F6D99-C8DE-4663-9572-023DB6F4C27B}"/>
+                <a16:creationId xmlns:a16="http://schemas.microsoft.com/office/drawing/2014/main" id="{954E80DB-65D8-4FA4-8C4F-DC9093546443}"/>
               </a:ext>
             </a:extLst>
           </p:cNvPr>
@@ -2466,7 +2466,7 @@
           <p:cNvPr id="2" name="">
             <a:extLst xmlns:a="http://schemas.openxmlformats.org/drawingml/2006/main">
               <a:ext uri="{FF2B5EF4-FFF2-40B4-BE49-F238E27FC236}">
-                <a16:creationId xmlns:a16="http://schemas.microsoft.com/office/drawing/2014/main" id="{E79BCA99-06BE-4DC3-948A-546972ED164F}"/>
+                <a16:creationId xmlns:a16="http://schemas.microsoft.com/office/drawing/2014/main" id="{CA87188A-25DA-4863-A46E-735804BA1513}"/>
               </a:ext>
             </a:extLst>
           </p:cNvPr>
@@ -2546,7 +2546,7 @@
           <p:cNvPr id="3" name="">
             <a:extLst xmlns:a="http://schemas.openxmlformats.org/drawingml/2006/main">
               <a:ext uri="{FF2B5EF4-FFF2-40B4-BE49-F238E27FC236}">
-                <a16:creationId xmlns:a16="http://schemas.microsoft.com/office/drawing/2014/main" id="{2EA5A2D1-9B37-4CA5-A429-CF082A8929CA}"/>
+                <a16:creationId xmlns:a16="http://schemas.microsoft.com/office/drawing/2014/main" id="{4122BE13-450C-46EA-8EA5-E428C6226BC5}"/>
               </a:ext>
             </a:extLst>
           </p:cNvPr>
@@ -2626,7 +2626,7 @@
           <p:cNvPr id="4" name="">
             <a:extLst xmlns:a="http://schemas.openxmlformats.org/drawingml/2006/main">
               <a:ext uri="{FF2B5EF4-FFF2-40B4-BE49-F238E27FC236}">
-                <a16:creationId xmlns:a16="http://schemas.microsoft.com/office/drawing/2014/main" id="{14CF9785-B531-41F2-9A38-93BE998048F7}"/>
+                <a16:creationId xmlns:a16="http://schemas.microsoft.com/office/drawing/2014/main" id="{05F29862-4898-4600-B114-C940B084E2C7}"/>
               </a:ext>
             </a:extLst>
           </p:cNvPr>
@@ -2683,7 +2683,7 @@
           <p:cNvPr id="5" name="">
             <a:extLst xmlns:a="http://schemas.openxmlformats.org/drawingml/2006/main">
               <a:ext uri="{FF2B5EF4-FFF2-40B4-BE49-F238E27FC236}">
-                <a16:creationId xmlns:a16="http://schemas.microsoft.com/office/drawing/2014/main" id="{33A3483D-53F7-453F-8AC3-E2E79656E7F4}"/>
+                <a16:creationId xmlns:a16="http://schemas.microsoft.com/office/drawing/2014/main" id="{329A1AEB-C745-4E36-9750-75F2CB9A8F8A}"/>
               </a:ext>
             </a:extLst>
           </p:cNvPr>
@@ -2740,7 +2740,7 @@
           <p:cNvPr id="6" name="">
             <a:extLst xmlns:a="http://schemas.openxmlformats.org/drawingml/2006/main">
               <a:ext uri="{FF2B5EF4-FFF2-40B4-BE49-F238E27FC236}">
-                <a16:creationId xmlns:a16="http://schemas.microsoft.com/office/drawing/2014/main" id="{E0C1C79C-2F1E-42B5-AF0B-397C05DE24DF}"/>
+                <a16:creationId xmlns:a16="http://schemas.microsoft.com/office/drawing/2014/main" id="{BC831CB8-817B-4B22-A1AD-CF868DA16986}"/>
               </a:ext>
             </a:extLst>
           </p:cNvPr>
@@ -2797,7 +2797,7 @@
           <p:cNvPr id="7" name="">
             <a:extLst xmlns:a="http://schemas.openxmlformats.org/drawingml/2006/main">
               <a:ext uri="{FF2B5EF4-FFF2-40B4-BE49-F238E27FC236}">
-                <a16:creationId xmlns:a16="http://schemas.microsoft.com/office/drawing/2014/main" id="{E31A42E2-9BCB-4B9D-BD4B-7E8F96F94531}"/>
+                <a16:creationId xmlns:a16="http://schemas.microsoft.com/office/drawing/2014/main" id="{A9BD773A-BDC0-4223-AA8C-C46A1ECC7369}"/>
               </a:ext>
             </a:extLst>
           </p:cNvPr>
@@ -2877,7 +2877,7 @@
           <p:cNvPr id="8" name="">
             <a:extLst xmlns:a="http://schemas.openxmlformats.org/drawingml/2006/main">
               <a:ext uri="{FF2B5EF4-FFF2-40B4-BE49-F238E27FC236}">
-                <a16:creationId xmlns:a16="http://schemas.microsoft.com/office/drawing/2014/main" id="{B349D92E-130B-4ADE-A2F8-2228868310D4}"/>
+                <a16:creationId xmlns:a16="http://schemas.microsoft.com/office/drawing/2014/main" id="{9B370167-0626-4A0E-883A-FF7E94EEB7EF}"/>
               </a:ext>
             </a:extLst>
           </p:cNvPr>
@@ -2934,7 +2934,7 @@
           <p:cNvPr id="9" name="">
             <a:extLst xmlns:a="http://schemas.openxmlformats.org/drawingml/2006/main">
               <a:ext uri="{FF2B5EF4-FFF2-40B4-BE49-F238E27FC236}">
-                <a16:creationId xmlns:a16="http://schemas.microsoft.com/office/drawing/2014/main" id="{257126D9-4F0D-476C-8713-C81200472DE0}"/>
+                <a16:creationId xmlns:a16="http://schemas.microsoft.com/office/drawing/2014/main" id="{E472610D-CA77-413E-9F60-35910837F477}"/>
               </a:ext>
             </a:extLst>
           </p:cNvPr>
@@ -2989,7 +2989,7 @@
     </p:spTree>
     <p:extLst>
       <p:ext uri="{BB962C8B-B14F-4D97-AF65-F5344CB8AC3E}">
-        <p14:creationId xmlns:p14="http://schemas.microsoft.com/office/powerpoint/2010/main" val="1914710011"/>
+        <p14:creationId xmlns:p14="http://schemas.microsoft.com/office/powerpoint/2010/main" val="647948060"/>
       </p:ext>
     </p:extLst>
   </p:cSld>
@@ -3017,10 +3017,10 @@
       </p:grpSpPr>
       <p:sp>
         <p:nvSpPr>
-          <p:cNvPr id="10" name="">
+          <p:cNvPr id="13" name="">
             <a:extLst xmlns:a="http://schemas.openxmlformats.org/drawingml/2006/main">
               <a:ext uri="{FF2B5EF4-FFF2-40B4-BE49-F238E27FC236}">
-                <a16:creationId xmlns:a16="http://schemas.microsoft.com/office/drawing/2014/main" id="{E8BC33E3-1802-4895-ADDD-60952447150D}"/>
+                <a16:creationId xmlns:a16="http://schemas.microsoft.com/office/drawing/2014/main" id="{D39AC70A-AD1E-41DA-A3B6-720FC425253F}"/>
               </a:ext>
             </a:extLst>
           </p:cNvPr>
@@ -3077,7 +3077,7 @@
           <p:cNvPr id="2" name="">
             <a:extLst xmlns:a="http://schemas.openxmlformats.org/drawingml/2006/main">
               <a:ext uri="{FF2B5EF4-FFF2-40B4-BE49-F238E27FC236}">
-                <a16:creationId xmlns:a16="http://schemas.microsoft.com/office/drawing/2014/main" id="{75F02D76-F9D9-4CF2-9284-86E4C9EF513B}"/>
+                <a16:creationId xmlns:a16="http://schemas.microsoft.com/office/drawing/2014/main" id="{6BDE773E-0B5D-4A04-A7C6-D8331D022158}"/>
               </a:ext>
             </a:extLst>
           </p:cNvPr>
@@ -3131,21 +3131,21 @@
       </p:sp>
       <p:pic>
         <p:nvPicPr>
-          <p:cNvPr id="12" name=""/>
+          <p:cNvPr id="15" name=""/>
           <p:cNvPicPr>
             <a:picLocks xmlns:a="http://schemas.openxmlformats.org/drawingml/2006/main" noChangeAspect="1"/>
           </p:cNvPicPr>
           <p:nvPr/>
         </p:nvPicPr>
         <p:blipFill>
-          <a:blip xmlns:r="http://schemas.openxmlformats.org/officeDocument/2006/relationships" xmlns:a="http://schemas.openxmlformats.org/drawingml/2006/main" r:embed="R60d180a0fc934b98"/>
-          <a:srcRect xmlns:a="http://schemas.openxmlformats.org/drawingml/2006/main" l="33266" t="23121" r="33132" b="22447"/>
+          <a:blip xmlns:r="http://schemas.openxmlformats.org/officeDocument/2006/relationships" xmlns:a="http://schemas.openxmlformats.org/drawingml/2006/main" r:embed="Rd0959fcef7f94acb"/>
+          <a:srcRect xmlns:a="http://schemas.openxmlformats.org/drawingml/2006/main" l="33602" t="7225" r="33468" b="7514"/>
           <a:stretch xmlns:a="http://schemas.openxmlformats.org/drawingml/2006/main"/>
         </p:blipFill>
         <p:spPr>
           <a:xfrm xmlns:a="http://schemas.openxmlformats.org/drawingml/2006/main">
-            <a:off x="2396085" y="1647825"/>
-            <a:ext cx="3818429" cy="4314825"/>
+            <a:off x="786001" y="1457325"/>
+            <a:ext cx="2599948" cy="4695825"/>
           </a:xfrm>
           <a:prstGeom xmlns:a="http://schemas.openxmlformats.org/drawingml/2006/main" prst="rect">
             <a:avLst/>
@@ -3157,7 +3157,293 @@
           <p:cNvPr id="4" name="">
             <a:extLst xmlns:a="http://schemas.openxmlformats.org/drawingml/2006/main">
               <a:ext uri="{FF2B5EF4-FFF2-40B4-BE49-F238E27FC236}">
-                <a16:creationId xmlns:a16="http://schemas.microsoft.com/office/drawing/2014/main" id="{3AC32383-CBDF-4384-9E06-C5A80189218C}"/>
+                <a16:creationId xmlns:a16="http://schemas.microsoft.com/office/drawing/2014/main" id="{0FE213A5-5AE4-4802-8452-60A430323D6D}"/>
+              </a:ext>
+            </a:extLst>
+          </p:cNvPr>
+          <p:cNvSpPr>
+            <a:spLocks xmlns:a="http://schemas.openxmlformats.org/drawingml/2006/main" noGrp="1"/>
+          </p:cNvSpPr>
+          <p:nvPr/>
+        </p:nvSpPr>
+        <p:spPr>
+          <a:xfrm xmlns:a="http://schemas.openxmlformats.org/drawingml/2006/main">
+            <a:off x="3857625" y="2162175"/>
+            <a:ext cx="4000500" cy="381000"/>
+          </a:xfrm>
+          <a:prstGeom xmlns:a="http://schemas.openxmlformats.org/drawingml/2006/main" prst="rect">
+            <a:avLst/>
+          </a:prstGeom>
+          <a:noFill xmlns:a="http://schemas.openxmlformats.org/drawingml/2006/main"/>
+          <a:ln xmlns:a="http://schemas.openxmlformats.org/drawingml/2006/main" w="0">
+            <a:noFill/>
+          </a:ln>
+        </p:spPr>
+        <p:txBody>
+          <a:bodyPr xmlns:a="http://schemas.openxmlformats.org/drawingml/2006/main" lIns="0" tIns="0" rIns="0" bIns="0" anchor="t">
+            <a:noAutofit/>
+          </a:bodyPr>
+          <a:lstStyle xmlns:a="http://schemas.openxmlformats.org/drawingml/2006/main"/>
+          <a:p xmlns:a="http://schemas.openxmlformats.org/drawingml/2006/main">
+            <a:pPr algn="l">
+              <a:defRPr sz="1875" b="1">
+                <a:solidFill>
+                  <a:srgbClr val="149F8E"/>
+                </a:solidFill>
+                <a:latin typeface="Noto Sans"/>
+                <a:ea typeface="Noto Sans"/>
+                <a:cs typeface="Noto Sans"/>
+              </a:defRPr>
+            </a:pPr>
+            <a:r>
+              <a:rPr sz="1875" b="1">
+                <a:solidFill>
+                  <a:srgbClr val="149F8E"/>
+                </a:solidFill>
+                <a:latin typeface="Noto Sans"/>
+                <a:ea typeface="Noto Sans"/>
+                <a:cs typeface="Noto Sans"/>
+              </a:rPr>
+              <a:t>Attached record in this capture</a:t>
+            </a:r>
+          </a:p>
+        </p:txBody>
+      </p:sp>
+      <p:sp>
+        <p:nvSpPr>
+          <p:cNvPr id="5" name="">
+            <a:extLst xmlns:a="http://schemas.openxmlformats.org/drawingml/2006/main">
+              <a:ext uri="{FF2B5EF4-FFF2-40B4-BE49-F238E27FC236}">
+                <a16:creationId xmlns:a16="http://schemas.microsoft.com/office/drawing/2014/main" id="{77C24116-2F86-44C0-B29F-03EEA105D890}"/>
+              </a:ext>
+            </a:extLst>
+          </p:cNvPr>
+          <p:cNvSpPr>
+            <a:spLocks xmlns:a="http://schemas.openxmlformats.org/drawingml/2006/main" noGrp="1"/>
+          </p:cNvSpPr>
+          <p:nvPr/>
+        </p:nvSpPr>
+        <p:spPr>
+          <a:xfrm xmlns:a="http://schemas.openxmlformats.org/drawingml/2006/main">
+            <a:off x="3857625" y="2686050"/>
+            <a:ext cx="4000500" cy="1943100"/>
+          </a:xfrm>
+          <a:prstGeom xmlns:a="http://schemas.openxmlformats.org/drawingml/2006/main" prst="rect">
+            <a:avLst/>
+          </a:prstGeom>
+          <a:noFill xmlns:a="http://schemas.openxmlformats.org/drawingml/2006/main"/>
+          <a:ln xmlns:a="http://schemas.openxmlformats.org/drawingml/2006/main" w="0">
+            <a:noFill/>
+          </a:ln>
+        </p:spPr>
+        <p:txBody>
+          <a:bodyPr xmlns:a="http://schemas.openxmlformats.org/drawingml/2006/main" lIns="0" tIns="0" rIns="0" bIns="0" anchor="t">
+            <a:noAutofit/>
+          </a:bodyPr>
+          <a:lstStyle xmlns:a="http://schemas.openxmlformats.org/drawingml/2006/main"/>
+          <a:p xmlns:a="http://schemas.openxmlformats.org/drawingml/2006/main">
+            <a:pPr algn="l">
+              <a:defRPr sz="1875" b="0">
+                <a:solidFill>
+                  <a:srgbClr val="14243B"/>
+                </a:solidFill>
+                <a:latin typeface="Noto Sans"/>
+                <a:ea typeface="Noto Sans"/>
+                <a:cs typeface="Noto Sans"/>
+              </a:defRPr>
+            </a:pPr>
+            <a:r>
+              <a:rPr sz="1875" b="0">
+                <a:solidFill>
+                  <a:srgbClr val="14243B"/>
+                </a:solidFill>
+                <a:latin typeface="Noto Sans"/>
+                <a:ea typeface="Noto Sans"/>
+                <a:cs typeface="Noto Sans"/>
+              </a:rPr>
+              <a:t>TX-ES-102</a:t>
+            </a:r>
+          </a:p>
+          <a:p xmlns:a="http://schemas.openxmlformats.org/drawingml/2006/main">
+            <a:pPr algn="l">
+              <a:defRPr sz="1875" b="0">
+                <a:solidFill>
+                  <a:srgbClr val="14243B"/>
+                </a:solidFill>
+                <a:latin typeface="Noto Sans"/>
+                <a:ea typeface="Noto Sans"/>
+                <a:cs typeface="Noto Sans"/>
+              </a:defRPr>
+            </a:pPr>
+            <a:r>
+              <a:rPr sz="1875" b="0">
+                <a:solidFill>
+                  <a:srgbClr val="14243B"/>
+                </a:solidFill>
+                <a:latin typeface="Noto Sans"/>
+                <a:ea typeface="Noto Sans"/>
+                <a:cs typeface="Noto Sans"/>
+              </a:rPr>
+              <a:t>Tienda Demo</a:t>
+            </a:r>
+          </a:p>
+          <a:p xmlns:a="http://schemas.openxmlformats.org/drawingml/2006/main">
+            <a:pPr algn="l">
+              <a:defRPr sz="1875" b="0">
+                <a:solidFill>
+                  <a:srgbClr val="14243B"/>
+                </a:solidFill>
+                <a:latin typeface="Noto Sans"/>
+                <a:ea typeface="Noto Sans"/>
+                <a:cs typeface="Noto Sans"/>
+              </a:defRPr>
+            </a:pPr>
+            <a:r>
+              <a:rPr sz="1875" b="0">
+                <a:solidFill>
+                  <a:srgbClr val="14243B"/>
+                </a:solidFill>
+                <a:latin typeface="Noto Sans"/>
+                <a:ea typeface="Noto Sans"/>
+                <a:cs typeface="Noto Sans"/>
+              </a:rPr>
+              <a:t>COP 129000.00</a:t>
+            </a:r>
+          </a:p>
+          <a:p xmlns:a="http://schemas.openxmlformats.org/drawingml/2006/main">
+            <a:pPr algn="l">
+              <a:defRPr sz="1875" b="0">
+                <a:solidFill>
+                  <a:srgbClr val="14243B"/>
+                </a:solidFill>
+                <a:latin typeface="Noto Sans"/>
+                <a:ea typeface="Noto Sans"/>
+                <a:cs typeface="Noto Sans"/>
+              </a:defRPr>
+            </a:pPr>
+            <a:r>
+              <a:rPr sz="1875" b="0">
+                <a:solidFill>
+                  <a:srgbClr val="14243B"/>
+                </a:solidFill>
+                <a:latin typeface="Noto Sans"/>
+                <a:ea typeface="Noto Sans"/>
+                <a:cs typeface="Noto Sans"/>
+              </a:rPr>
+              <a:t>Pending</a:t>
+            </a:r>
+          </a:p>
+          <a:p xmlns:a="http://schemas.openxmlformats.org/drawingml/2006/main">
+            <a:pPr algn="l">
+              <a:defRPr sz="1875" b="0">
+                <a:solidFill>
+                  <a:srgbClr val="14243B"/>
+                </a:solidFill>
+                <a:latin typeface="Noto Sans"/>
+                <a:ea typeface="Noto Sans"/>
+                <a:cs typeface="Noto Sans"/>
+              </a:defRPr>
+            </a:pPr>
+            <a:r>
+              <a:rPr sz="1875" b="0">
+                <a:solidFill>
+                  <a:srgbClr val="14243B"/>
+                </a:solidFill>
+                <a:latin typeface="Noto Sans"/>
+                <a:ea typeface="Noto Sans"/>
+                <a:cs typeface="Noto Sans"/>
+              </a:rPr>
+              <a:t>17 June 2026 snapshot</a:t>
+            </a:r>
+          </a:p>
+        </p:txBody>
+      </p:sp>
+      <p:sp>
+        <p:nvSpPr>
+          <p:cNvPr id="6" name="">
+            <a:extLst xmlns:a="http://schemas.openxmlformats.org/drawingml/2006/main">
+              <a:ext uri="{FF2B5EF4-FFF2-40B4-BE49-F238E27FC236}">
+                <a16:creationId xmlns:a16="http://schemas.microsoft.com/office/drawing/2014/main" id="{07D422B4-E6E4-47AA-A225-0B4CCC5720BF}"/>
+              </a:ext>
+            </a:extLst>
+          </p:cNvPr>
+          <p:cNvSpPr>
+            <a:spLocks xmlns:a="http://schemas.openxmlformats.org/drawingml/2006/main" noGrp="1"/>
+          </p:cNvSpPr>
+          <p:nvPr/>
+        </p:nvSpPr>
+        <p:spPr>
+          <a:xfrm xmlns:a="http://schemas.openxmlformats.org/drawingml/2006/main">
+            <a:off x="3857625" y="4962525"/>
+            <a:ext cx="4000500" cy="714375"/>
+          </a:xfrm>
+          <a:prstGeom xmlns:a="http://schemas.openxmlformats.org/drawingml/2006/main" prst="rect">
+            <a:avLst/>
+          </a:prstGeom>
+          <a:noFill xmlns:a="http://schemas.openxmlformats.org/drawingml/2006/main"/>
+          <a:ln xmlns:a="http://schemas.openxmlformats.org/drawingml/2006/main" w="0">
+            <a:noFill/>
+          </a:ln>
+        </p:spPr>
+        <p:txBody>
+          <a:bodyPr xmlns:a="http://schemas.openxmlformats.org/drawingml/2006/main" lIns="0" tIns="0" rIns="0" bIns="0" anchor="t">
+            <a:noAutofit/>
+          </a:bodyPr>
+          <a:lstStyle xmlns:a="http://schemas.openxmlformats.org/drawingml/2006/main"/>
+          <a:p xmlns:a="http://schemas.openxmlformats.org/drawingml/2006/main">
+            <a:pPr algn="l">
+              <a:defRPr sz="1650" b="0">
+                <a:solidFill>
+                  <a:srgbClr val="587087"/>
+                </a:solidFill>
+                <a:latin typeface="Noto Sans"/>
+                <a:ea typeface="Noto Sans"/>
+                <a:cs typeface="Noto Sans"/>
+              </a:defRPr>
+            </a:pPr>
+            <a:r>
+              <a:rPr sz="1650" b="0">
+                <a:solidFill>
+                  <a:srgbClr val="587087"/>
+                </a:solidFill>
+                <a:latin typeface="Noto Sans"/>
+                <a:ea typeface="Noto Sans"/>
+                <a:cs typeface="Noto Sans"/>
+              </a:rPr>
+              <a:t>The augmented redacted report</a:t>
+            </a:r>
+          </a:p>
+          <a:p xmlns:a="http://schemas.openxmlformats.org/drawingml/2006/main">
+            <a:pPr algn="l">
+              <a:defRPr sz="1650" b="0">
+                <a:solidFill>
+                  <a:srgbClr val="587087"/>
+                </a:solidFill>
+                <a:latin typeface="Noto Sans"/>
+                <a:ea typeface="Noto Sans"/>
+                <a:cs typeface="Noto Sans"/>
+              </a:defRPr>
+            </a:pPr>
+            <a:r>
+              <a:rPr sz="1650" b="0">
+                <a:solidFill>
+                  <a:srgbClr val="587087"/>
+                </a:solidFill>
+                <a:latin typeface="Noto Sans"/>
+                <a:ea typeface="Noto Sans"/>
+                <a:cs typeface="Noto Sans"/>
+              </a:rPr>
+              <a:t>is visible before confirmation.</a:t>
+            </a:r>
+          </a:p>
+        </p:txBody>
+      </p:sp>
+      <p:sp>
+        <p:nvSpPr>
+          <p:cNvPr id="7" name="">
+            <a:extLst xmlns:a="http://schemas.openxmlformats.org/drawingml/2006/main">
+              <a:ext uri="{FF2B5EF4-FFF2-40B4-BE49-F238E27FC236}">
+                <a16:creationId xmlns:a16="http://schemas.microsoft.com/office/drawing/2014/main" id="{FEBF39BA-06BF-4799-8C72-A617DB8A0AF0}"/>
               </a:ext>
             </a:extLst>
           </p:cNvPr>
@@ -3211,10 +3497,10 @@
       </p:sp>
       <p:sp>
         <p:nvSpPr>
-          <p:cNvPr id="5" name="">
+          <p:cNvPr id="8" name="">
             <a:extLst xmlns:a="http://schemas.openxmlformats.org/drawingml/2006/main">
               <a:ext uri="{FF2B5EF4-FFF2-40B4-BE49-F238E27FC236}">
-                <a16:creationId xmlns:a16="http://schemas.microsoft.com/office/drawing/2014/main" id="{1101482C-FEA1-4D39-B7E5-73EE3A4809D7}"/>
+                <a16:creationId xmlns:a16="http://schemas.microsoft.com/office/drawing/2014/main" id="{460F722D-9744-46AA-B016-4BC8AFEE26EB}"/>
               </a:ext>
             </a:extLst>
           </p:cNvPr>
@@ -3291,10 +3577,10 @@
       </p:sp>
       <p:sp>
         <p:nvSpPr>
-          <p:cNvPr id="6" name="">
+          <p:cNvPr id="9" name="">
             <a:extLst xmlns:a="http://schemas.openxmlformats.org/drawingml/2006/main">
               <a:ext uri="{FF2B5EF4-FFF2-40B4-BE49-F238E27FC236}">
-                <a16:creationId xmlns:a16="http://schemas.microsoft.com/office/drawing/2014/main" id="{7B42EBA1-6580-4DAC-8265-5ACA045267B4}"/>
+                <a16:creationId xmlns:a16="http://schemas.microsoft.com/office/drawing/2014/main" id="{0DFD6A7D-5C0C-46F0-AEC7-914F5AA9A7E5}"/>
               </a:ext>
             </a:extLst>
           </p:cNvPr>
@@ -3348,10 +3634,10 @@
       </p:sp>
       <p:sp>
         <p:nvSpPr>
-          <p:cNvPr id="7" name="">
+          <p:cNvPr id="10" name="">
             <a:extLst xmlns:a="http://schemas.openxmlformats.org/drawingml/2006/main">
               <a:ext uri="{FF2B5EF4-FFF2-40B4-BE49-F238E27FC236}">
-                <a16:creationId xmlns:a16="http://schemas.microsoft.com/office/drawing/2014/main" id="{68B56CEC-1A34-44CF-B148-78EB9335D66F}"/>
+                <a16:creationId xmlns:a16="http://schemas.microsoft.com/office/drawing/2014/main" id="{FBC93444-F402-408F-BC36-CF5AB5B404D5}"/>
               </a:ext>
             </a:extLst>
           </p:cNvPr>
@@ -3398,7 +3684,7 @@
                 <a:ea typeface="Noto Sans"/>
                 <a:cs typeface="Noto Sans"/>
               </a:rPr>
-              <a:t>Commit one sandbox case.</a:t>
+              <a:t>Inspect the attached record.</a:t>
             </a:r>
           </a:p>
           <a:p xmlns:a="http://schemas.openxmlformats.org/drawingml/2006/main">
@@ -3421,17 +3707,17 @@
                 <a:ea typeface="Noto Sans"/>
                 <a:cs typeface="Noto Sans"/>
               </a:rPr>
-              <a:t>Read it back before success.</a:t>
-            </a:r>
-          </a:p>
-        </p:txBody>
-      </p:sp>
-      <p:sp>
-        <p:nvSpPr>
-          <p:cNvPr id="8" name="">
+              <a:t>Confirm, then read back.</a:t>
+            </a:r>
+          </a:p>
+        </p:txBody>
+      </p:sp>
+      <p:sp>
+        <p:nvSpPr>
+          <p:cNvPr id="11" name="">
             <a:extLst xmlns:a="http://schemas.openxmlformats.org/drawingml/2006/main">
               <a:ext uri="{FF2B5EF4-FFF2-40B4-BE49-F238E27FC236}">
-                <a16:creationId xmlns:a16="http://schemas.microsoft.com/office/drawing/2014/main" id="{0175D72D-4538-46EB-B433-92CC9E682E42}"/>
+                <a16:creationId xmlns:a16="http://schemas.microsoft.com/office/drawing/2014/main" id="{AB391D31-BBF6-4578-ACBE-CADA8958AFF5}"/>
               </a:ext>
             </a:extLst>
           </p:cNvPr>
@@ -3485,10 +3771,10 @@
       </p:sp>
       <p:sp>
         <p:nvSpPr>
-          <p:cNvPr id="9" name="">
+          <p:cNvPr id="12" name="">
             <a:extLst xmlns:a="http://schemas.openxmlformats.org/drawingml/2006/main">
               <a:ext uri="{FF2B5EF4-FFF2-40B4-BE49-F238E27FC236}">
-                <a16:creationId xmlns:a16="http://schemas.microsoft.com/office/drawing/2014/main" id="{AC992A43-49E7-4040-964E-3974519034C2}"/>
+                <a16:creationId xmlns:a16="http://schemas.microsoft.com/office/drawing/2014/main" id="{A02F70D2-0907-4B0D-AE25-B784E3995D6B}"/>
               </a:ext>
             </a:extLst>
           </p:cNvPr>
@@ -3566,7 +3852,7 @@
     </p:spTree>
     <p:extLst>
       <p:ext uri="{BB962C8B-B14F-4D97-AF65-F5344CB8AC3E}">
-        <p14:creationId xmlns:p14="http://schemas.microsoft.com/office/powerpoint/2010/main" val="1053909103"/>
+        <p14:creationId xmlns:p14="http://schemas.microsoft.com/office/powerpoint/2010/main" val="793164492"/>
       </p:ext>
     </p:extLst>
   </p:cSld>
@@ -3597,7 +3883,7 @@
           <p:cNvPr id="19" name="">
             <a:extLst xmlns:a="http://schemas.openxmlformats.org/drawingml/2006/main">
               <a:ext uri="{FF2B5EF4-FFF2-40B4-BE49-F238E27FC236}">
-                <a16:creationId xmlns:a16="http://schemas.microsoft.com/office/drawing/2014/main" id="{D0687950-6AB2-41D6-A58D-55803F6B35EE}"/>
+                <a16:creationId xmlns:a16="http://schemas.microsoft.com/office/drawing/2014/main" id="{C48DDBA7-7C02-48FB-A94A-5688B75DA05F}"/>
               </a:ext>
             </a:extLst>
           </p:cNvPr>
@@ -3654,7 +3940,7 @@
           <p:cNvPr id="2" name="">
             <a:extLst xmlns:a="http://schemas.openxmlformats.org/drawingml/2006/main">
               <a:ext uri="{FF2B5EF4-FFF2-40B4-BE49-F238E27FC236}">
-                <a16:creationId xmlns:a16="http://schemas.microsoft.com/office/drawing/2014/main" id="{08FD23A8-405B-4367-A581-0F1C8F3C4A39}"/>
+                <a16:creationId xmlns:a16="http://schemas.microsoft.com/office/drawing/2014/main" id="{406618EE-C10F-413E-BDC5-038784C2869E}"/>
               </a:ext>
             </a:extLst>
           </p:cNvPr>
@@ -3711,7 +3997,7 @@
           <p:cNvPr id="3" name="">
             <a:extLst xmlns:a="http://schemas.openxmlformats.org/drawingml/2006/main">
               <a:ext uri="{FF2B5EF4-FFF2-40B4-BE49-F238E27FC236}">
-                <a16:creationId xmlns:a16="http://schemas.microsoft.com/office/drawing/2014/main" id="{08CE34D5-83AD-4003-A025-1F4EE885C070}"/>
+                <a16:creationId xmlns:a16="http://schemas.microsoft.com/office/drawing/2014/main" id="{9B7CF0A0-26EC-4E50-A666-C3F3229FACBE}"/>
               </a:ext>
             </a:extLst>
           </p:cNvPr>
@@ -3768,7 +4054,7 @@
           <p:cNvPr id="4" name="">
             <a:extLst xmlns:a="http://schemas.openxmlformats.org/drawingml/2006/main">
               <a:ext uri="{FF2B5EF4-FFF2-40B4-BE49-F238E27FC236}">
-                <a16:creationId xmlns:a16="http://schemas.microsoft.com/office/drawing/2014/main" id="{2A81E5B3-FCD0-4890-95F9-1F6DA89C2FE4}"/>
+                <a16:creationId xmlns:a16="http://schemas.microsoft.com/office/drawing/2014/main" id="{A25B9C9A-CC4E-43C9-BF76-60D64A84578D}"/>
               </a:ext>
             </a:extLst>
           </p:cNvPr>
@@ -3827,7 +4113,7 @@
           <p:cNvPr id="5" name="">
             <a:extLst xmlns:a="http://schemas.openxmlformats.org/drawingml/2006/main">
               <a:ext uri="{FF2B5EF4-FFF2-40B4-BE49-F238E27FC236}">
-                <a16:creationId xmlns:a16="http://schemas.microsoft.com/office/drawing/2014/main" id="{7252E241-914D-48E2-94A3-B27390004632}"/>
+                <a16:creationId xmlns:a16="http://schemas.microsoft.com/office/drawing/2014/main" id="{6AC81C41-4329-4D2E-A4AB-87CF8CAE07DE}"/>
               </a:ext>
             </a:extLst>
           </p:cNvPr>
@@ -3909,7 +4195,7 @@
           <p:cNvPr id="6" name="">
             <a:extLst xmlns:a="http://schemas.openxmlformats.org/drawingml/2006/main">
               <a:ext uri="{FF2B5EF4-FFF2-40B4-BE49-F238E27FC236}">
-                <a16:creationId xmlns:a16="http://schemas.microsoft.com/office/drawing/2014/main" id="{C2FA89AC-E7CA-4BCD-8DF1-8D6B530BF144}"/>
+                <a16:creationId xmlns:a16="http://schemas.microsoft.com/office/drawing/2014/main" id="{A4F3ED7A-3A45-4F6D-ACE2-E962B077E18B}"/>
               </a:ext>
             </a:extLst>
           </p:cNvPr>
@@ -3991,7 +4277,7 @@
           <p:cNvPr id="7" name="">
             <a:extLst xmlns:a="http://schemas.openxmlformats.org/drawingml/2006/main">
               <a:ext uri="{FF2B5EF4-FFF2-40B4-BE49-F238E27FC236}">
-                <a16:creationId xmlns:a16="http://schemas.microsoft.com/office/drawing/2014/main" id="{96FC9337-7E48-46EE-ACDC-2230A6C66481}"/>
+                <a16:creationId xmlns:a16="http://schemas.microsoft.com/office/drawing/2014/main" id="{DBEF2A09-03EA-42B4-A4AB-5812F5F87043}"/>
               </a:ext>
             </a:extLst>
           </p:cNvPr>
@@ -4073,7 +4359,7 @@
           <p:cNvPr id="8" name="">
             <a:extLst xmlns:a="http://schemas.openxmlformats.org/drawingml/2006/main">
               <a:ext uri="{FF2B5EF4-FFF2-40B4-BE49-F238E27FC236}">
-                <a16:creationId xmlns:a16="http://schemas.microsoft.com/office/drawing/2014/main" id="{60C7BDB4-3503-47D8-A11D-FA89CF47D672}"/>
+                <a16:creationId xmlns:a16="http://schemas.microsoft.com/office/drawing/2014/main" id="{5A6270AD-A09E-4BD7-9D0B-1661EFA4C252}"/>
               </a:ext>
             </a:extLst>
           </p:cNvPr>
@@ -4155,7 +4441,7 @@
           <p:cNvPr id="9" name="">
             <a:extLst xmlns:a="http://schemas.openxmlformats.org/drawingml/2006/main">
               <a:ext uri="{FF2B5EF4-FFF2-40B4-BE49-F238E27FC236}">
-                <a16:creationId xmlns:a16="http://schemas.microsoft.com/office/drawing/2014/main" id="{EC0660B6-4FD4-4C61-80BC-1A460DFAC4F4}"/>
+                <a16:creationId xmlns:a16="http://schemas.microsoft.com/office/drawing/2014/main" id="{4E3D4F28-6E15-4E3A-8C2D-5A3ED648B60F}"/>
               </a:ext>
             </a:extLst>
           </p:cNvPr>
@@ -4237,7 +4523,7 @@
           <p:cNvPr id="10" name="">
             <a:extLst xmlns:a="http://schemas.openxmlformats.org/drawingml/2006/main">
               <a:ext uri="{FF2B5EF4-FFF2-40B4-BE49-F238E27FC236}">
-                <a16:creationId xmlns:a16="http://schemas.microsoft.com/office/drawing/2014/main" id="{D0D5EBC2-994A-43BA-B4D5-73922100FBB9}"/>
+                <a16:creationId xmlns:a16="http://schemas.microsoft.com/office/drawing/2014/main" id="{180EC040-04E4-4430-9C00-B685CA865FA6}"/>
               </a:ext>
             </a:extLst>
           </p:cNvPr>
@@ -4469,7 +4755,7 @@
           <p:cNvPr id="17" name="">
             <a:extLst xmlns:a="http://schemas.openxmlformats.org/drawingml/2006/main">
               <a:ext uri="{FF2B5EF4-FFF2-40B4-BE49-F238E27FC236}">
-                <a16:creationId xmlns:a16="http://schemas.microsoft.com/office/drawing/2014/main" id="{9716D60A-BB04-4DC0-8135-8E02AAB05EA2}"/>
+                <a16:creationId xmlns:a16="http://schemas.microsoft.com/office/drawing/2014/main" id="{C206509F-7A29-4301-9D27-D00AB119D027}"/>
               </a:ext>
             </a:extLst>
           </p:cNvPr>
@@ -4572,7 +4858,7 @@
           <p:cNvPr id="18" name="">
             <a:extLst xmlns:a="http://schemas.openxmlformats.org/drawingml/2006/main">
               <a:ext uri="{FF2B5EF4-FFF2-40B4-BE49-F238E27FC236}">
-                <a16:creationId xmlns:a16="http://schemas.microsoft.com/office/drawing/2014/main" id="{D9F4CED5-026F-45A3-A27A-8141A949A782}"/>
+                <a16:creationId xmlns:a16="http://schemas.microsoft.com/office/drawing/2014/main" id="{DB105639-254D-4FE4-92BC-AD0B70215B32}"/>
               </a:ext>
             </a:extLst>
           </p:cNvPr>
@@ -4627,7 +4913,7 @@
     </p:spTree>
     <p:extLst>
       <p:ext uri="{BB962C8B-B14F-4D97-AF65-F5344CB8AC3E}">
-        <p14:creationId xmlns:p14="http://schemas.microsoft.com/office/powerpoint/2010/main" val="2130007651"/>
+        <p14:creationId xmlns:p14="http://schemas.microsoft.com/office/powerpoint/2010/main" val="1954842873"/>
       </p:ext>
     </p:extLst>
   </p:cSld>
@@ -4658,7 +4944,7 @@
           <p:cNvPr id="13" name="">
             <a:extLst xmlns:a="http://schemas.openxmlformats.org/drawingml/2006/main">
               <a:ext uri="{FF2B5EF4-FFF2-40B4-BE49-F238E27FC236}">
-                <a16:creationId xmlns:a16="http://schemas.microsoft.com/office/drawing/2014/main" id="{AAC89148-783D-410A-BBD6-A71CB34616E2}"/>
+                <a16:creationId xmlns:a16="http://schemas.microsoft.com/office/drawing/2014/main" id="{31C55AF5-3D51-4050-BBCD-CA35032A4247}"/>
               </a:ext>
             </a:extLst>
           </p:cNvPr>
@@ -4715,7 +5001,7 @@
           <p:cNvPr id="2" name="">
             <a:extLst xmlns:a="http://schemas.openxmlformats.org/drawingml/2006/main">
               <a:ext uri="{FF2B5EF4-FFF2-40B4-BE49-F238E27FC236}">
-                <a16:creationId xmlns:a16="http://schemas.microsoft.com/office/drawing/2014/main" id="{3BB9DFDE-AE8C-43E4-8F1F-70D3AC26D9D7}"/>
+                <a16:creationId xmlns:a16="http://schemas.microsoft.com/office/drawing/2014/main" id="{CA7E7886-2487-4611-9F3C-8ECB91CF032C}"/>
               </a:ext>
             </a:extLst>
           </p:cNvPr>
@@ -4772,7 +5058,7 @@
           <p:cNvPr id="3" name="">
             <a:extLst xmlns:a="http://schemas.openxmlformats.org/drawingml/2006/main">
               <a:ext uri="{FF2B5EF4-FFF2-40B4-BE49-F238E27FC236}">
-                <a16:creationId xmlns:a16="http://schemas.microsoft.com/office/drawing/2014/main" id="{90824D11-AB4C-4805-834E-D2BC4FF719B1}"/>
+                <a16:creationId xmlns:a16="http://schemas.microsoft.com/office/drawing/2014/main" id="{FF10100E-0FA2-4019-9F07-13BEFCAB6621}"/>
               </a:ext>
             </a:extLst>
           </p:cNvPr>
@@ -4829,7 +5115,7 @@
           <p:cNvPr id="4" name="">
             <a:extLst xmlns:a="http://schemas.openxmlformats.org/drawingml/2006/main">
               <a:ext uri="{FF2B5EF4-FFF2-40B4-BE49-F238E27FC236}">
-                <a16:creationId xmlns:a16="http://schemas.microsoft.com/office/drawing/2014/main" id="{1376B8B0-E09E-4471-9A7C-710926A37801}"/>
+                <a16:creationId xmlns:a16="http://schemas.microsoft.com/office/drawing/2014/main" id="{E9CA6522-5A26-4417-B03C-8E481BDEFDF0}"/>
               </a:ext>
             </a:extLst>
           </p:cNvPr>
@@ -4932,7 +5218,7 @@
           <p:cNvPr id="5" name="">
             <a:extLst xmlns:a="http://schemas.openxmlformats.org/drawingml/2006/main">
               <a:ext uri="{FF2B5EF4-FFF2-40B4-BE49-F238E27FC236}">
-                <a16:creationId xmlns:a16="http://schemas.microsoft.com/office/drawing/2014/main" id="{E1B607F9-D793-4811-89D3-484F0ACC47C4}"/>
+                <a16:creationId xmlns:a16="http://schemas.microsoft.com/office/drawing/2014/main" id="{8F9E4CB2-DA7A-43F7-8EF9-8BD97C6E3931}"/>
               </a:ext>
             </a:extLst>
           </p:cNvPr>
@@ -4989,7 +5275,7 @@
           <p:cNvPr id="6" name="">
             <a:extLst xmlns:a="http://schemas.openxmlformats.org/drawingml/2006/main">
               <a:ext uri="{FF2B5EF4-FFF2-40B4-BE49-F238E27FC236}">
-                <a16:creationId xmlns:a16="http://schemas.microsoft.com/office/drawing/2014/main" id="{64A4F78A-1AD8-40A5-8CF8-660AB2D45BB2}"/>
+                <a16:creationId xmlns:a16="http://schemas.microsoft.com/office/drawing/2014/main" id="{154FD183-8F04-429A-A48F-5E604D5C96CC}"/>
               </a:ext>
             </a:extLst>
           </p:cNvPr>
@@ -5092,7 +5378,7 @@
           <p:cNvPr id="7" name="">
             <a:extLst xmlns:a="http://schemas.openxmlformats.org/drawingml/2006/main">
               <a:ext uri="{FF2B5EF4-FFF2-40B4-BE49-F238E27FC236}">
-                <a16:creationId xmlns:a16="http://schemas.microsoft.com/office/drawing/2014/main" id="{270DF2A6-4402-4C80-9E71-A79B42A0F14D}"/>
+                <a16:creationId xmlns:a16="http://schemas.microsoft.com/office/drawing/2014/main" id="{E54A62B6-76C0-4623-BD84-C54B3410FE4F}"/>
               </a:ext>
             </a:extLst>
           </p:cNvPr>
@@ -5149,7 +5435,7 @@
           <p:cNvPr id="8" name="">
             <a:extLst xmlns:a="http://schemas.openxmlformats.org/drawingml/2006/main">
               <a:ext uri="{FF2B5EF4-FFF2-40B4-BE49-F238E27FC236}">
-                <a16:creationId xmlns:a16="http://schemas.microsoft.com/office/drawing/2014/main" id="{13AD4579-CD31-4242-B0D7-49DFF6BFFC0C}"/>
+                <a16:creationId xmlns:a16="http://schemas.microsoft.com/office/drawing/2014/main" id="{F8D48A34-0988-43CD-B188-A27A1017387E}"/>
               </a:ext>
             </a:extLst>
           </p:cNvPr>
@@ -5213,7 +5499,7 @@
         </p:xfrm>
         <a:graphic xmlns:a="http://schemas.openxmlformats.org/drawingml/2006/main">
           <a:graphicData uri="http://schemas.openxmlformats.org/drawingml/2006/chart">
-            <c:chart xmlns:r="http://schemas.openxmlformats.org/officeDocument/2006/relationships" xmlns:c="http://schemas.openxmlformats.org/drawingml/2006/chart" r:id="Rd40bcac2942147bf"/>
+            <c:chart xmlns:r="http://schemas.openxmlformats.org/officeDocument/2006/relationships" xmlns:c="http://schemas.openxmlformats.org/drawingml/2006/chart" r:id="R62ec38f8c58f4479"/>
           </a:graphicData>
         </a:graphic>
       </p:graphicFrame>
@@ -5222,7 +5508,7 @@
           <p:cNvPr id="10" name="">
             <a:extLst xmlns:a="http://schemas.openxmlformats.org/drawingml/2006/main">
               <a:ext uri="{FF2B5EF4-FFF2-40B4-BE49-F238E27FC236}">
-                <a16:creationId xmlns:a16="http://schemas.microsoft.com/office/drawing/2014/main" id="{E0F38D4F-E443-4A54-A9EA-E06D4EAF930E}"/>
+                <a16:creationId xmlns:a16="http://schemas.microsoft.com/office/drawing/2014/main" id="{67B63188-C689-41F4-A8F1-9FA53E9ADA54}"/>
               </a:ext>
             </a:extLst>
           </p:cNvPr>
@@ -5279,7 +5565,7 @@
           <p:cNvPr id="11" name="">
             <a:extLst xmlns:a="http://schemas.openxmlformats.org/drawingml/2006/main">
               <a:ext uri="{FF2B5EF4-FFF2-40B4-BE49-F238E27FC236}">
-                <a16:creationId xmlns:a16="http://schemas.microsoft.com/office/drawing/2014/main" id="{5979F1CD-C770-4CF0-A62C-95C74F8022A5}"/>
+                <a16:creationId xmlns:a16="http://schemas.microsoft.com/office/drawing/2014/main" id="{DCBCD4F1-78C9-4026-A952-E18B06F01049}"/>
               </a:ext>
             </a:extLst>
           </p:cNvPr>
@@ -5359,7 +5645,7 @@
           <p:cNvPr id="12" name="">
             <a:extLst xmlns:a="http://schemas.openxmlformats.org/drawingml/2006/main">
               <a:ext uri="{FF2B5EF4-FFF2-40B4-BE49-F238E27FC236}">
-                <a16:creationId xmlns:a16="http://schemas.microsoft.com/office/drawing/2014/main" id="{FFDAC15A-F8AE-48CA-918D-F56108E7E029}"/>
+                <a16:creationId xmlns:a16="http://schemas.microsoft.com/office/drawing/2014/main" id="{8A19709E-B1E2-4CDD-92F5-10B0251C9D62}"/>
               </a:ext>
             </a:extLst>
           </p:cNvPr>
@@ -5414,7 +5700,7 @@
     </p:spTree>
     <p:extLst>
       <p:ext uri="{BB962C8B-B14F-4D97-AF65-F5344CB8AC3E}">
-        <p14:creationId xmlns:p14="http://schemas.microsoft.com/office/powerpoint/2010/main" val="479116985"/>
+        <p14:creationId xmlns:p14="http://schemas.microsoft.com/office/powerpoint/2010/main" val="929045976"/>
       </p:ext>
     </p:extLst>
   </p:cSld>
@@ -5445,7 +5731,7 @@
           <p:cNvPr id="13" name="">
             <a:extLst xmlns:a="http://schemas.openxmlformats.org/drawingml/2006/main">
               <a:ext uri="{FF2B5EF4-FFF2-40B4-BE49-F238E27FC236}">
-                <a16:creationId xmlns:a16="http://schemas.microsoft.com/office/drawing/2014/main" id="{741C003B-754A-4724-806E-5D58E568B0EF}"/>
+                <a16:creationId xmlns:a16="http://schemas.microsoft.com/office/drawing/2014/main" id="{2B572132-D3B2-4321-BB96-1FBD1FB0D14F}"/>
               </a:ext>
             </a:extLst>
           </p:cNvPr>
@@ -5502,7 +5788,7 @@
           <p:cNvPr id="2" name="">
             <a:extLst xmlns:a="http://schemas.openxmlformats.org/drawingml/2006/main">
               <a:ext uri="{FF2B5EF4-FFF2-40B4-BE49-F238E27FC236}">
-                <a16:creationId xmlns:a16="http://schemas.microsoft.com/office/drawing/2014/main" id="{6D227275-ADE4-44AB-974A-119194E40852}"/>
+                <a16:creationId xmlns:a16="http://schemas.microsoft.com/office/drawing/2014/main" id="{5704EB60-A99D-4A0D-9A90-6DD3734F93FC}"/>
               </a:ext>
             </a:extLst>
           </p:cNvPr>
@@ -5559,7 +5845,7 @@
           <p:cNvPr id="3" name="">
             <a:extLst xmlns:a="http://schemas.openxmlformats.org/drawingml/2006/main">
               <a:ext uri="{FF2B5EF4-FFF2-40B4-BE49-F238E27FC236}">
-                <a16:creationId xmlns:a16="http://schemas.microsoft.com/office/drawing/2014/main" id="{125A39BF-2B26-4E4A-8B78-9B35274F0FCF}"/>
+                <a16:creationId xmlns:a16="http://schemas.microsoft.com/office/drawing/2014/main" id="{5116C19D-FD67-43E3-835B-E891D5D424DE}"/>
               </a:ext>
             </a:extLst>
           </p:cNvPr>
@@ -5616,7 +5902,7 @@
           <p:cNvPr id="4" name="">
             <a:extLst xmlns:a="http://schemas.openxmlformats.org/drawingml/2006/main">
               <a:ext uri="{FF2B5EF4-FFF2-40B4-BE49-F238E27FC236}">
-                <a16:creationId xmlns:a16="http://schemas.microsoft.com/office/drawing/2014/main" id="{B87814BC-9E26-45B6-B75B-E8B9EFBB2C73}"/>
+                <a16:creationId xmlns:a16="http://schemas.microsoft.com/office/drawing/2014/main" id="{E68ADAE7-C1A6-4258-86DB-878FCC5B9119}"/>
               </a:ext>
             </a:extLst>
           </p:cNvPr>
@@ -5680,7 +5966,7 @@
         </p:xfrm>
         <a:graphic xmlns:a="http://schemas.openxmlformats.org/drawingml/2006/main">
           <a:graphicData uri="http://schemas.openxmlformats.org/drawingml/2006/chart">
-            <c:chart xmlns:r="http://schemas.openxmlformats.org/officeDocument/2006/relationships" xmlns:c="http://schemas.openxmlformats.org/drawingml/2006/chart" r:id="R231e224b0f8e4fca"/>
+            <c:chart xmlns:r="http://schemas.openxmlformats.org/officeDocument/2006/relationships" xmlns:c="http://schemas.openxmlformats.org/drawingml/2006/chart" r:id="R0ac38c70f84f4ef9"/>
           </a:graphicData>
         </a:graphic>
       </p:graphicFrame>
@@ -5689,7 +5975,7 @@
           <p:cNvPr id="6" name="">
             <a:extLst xmlns:a="http://schemas.openxmlformats.org/drawingml/2006/main">
               <a:ext uri="{FF2B5EF4-FFF2-40B4-BE49-F238E27FC236}">
-                <a16:creationId xmlns:a16="http://schemas.microsoft.com/office/drawing/2014/main" id="{59C64771-127A-4ADA-91DF-33E835323D98}"/>
+                <a16:creationId xmlns:a16="http://schemas.microsoft.com/office/drawing/2014/main" id="{550A69A1-06D0-406A-A444-A05A27C67155}"/>
               </a:ext>
             </a:extLst>
           </p:cNvPr>
@@ -5746,7 +6032,7 @@
           <p:cNvPr id="7" name="">
             <a:extLst xmlns:a="http://schemas.openxmlformats.org/drawingml/2006/main">
               <a:ext uri="{FF2B5EF4-FFF2-40B4-BE49-F238E27FC236}">
-                <a16:creationId xmlns:a16="http://schemas.microsoft.com/office/drawing/2014/main" id="{7F571322-F273-41E8-BE4E-B767B24DA22A}"/>
+                <a16:creationId xmlns:a16="http://schemas.microsoft.com/office/drawing/2014/main" id="{6D660CF0-6AA4-416D-8691-51E8144F3FC3}"/>
               </a:ext>
             </a:extLst>
           </p:cNvPr>
@@ -5810,7 +6096,7 @@
         </p:xfrm>
         <a:graphic xmlns:a="http://schemas.openxmlformats.org/drawingml/2006/main">
           <a:graphicData uri="http://schemas.openxmlformats.org/drawingml/2006/chart">
-            <c:chart xmlns:r="http://schemas.openxmlformats.org/officeDocument/2006/relationships" xmlns:c="http://schemas.openxmlformats.org/drawingml/2006/chart" r:id="R947b0da69a084fed"/>
+            <c:chart xmlns:r="http://schemas.openxmlformats.org/officeDocument/2006/relationships" xmlns:c="http://schemas.openxmlformats.org/drawingml/2006/chart" r:id="R44d2367e55934186"/>
           </a:graphicData>
         </a:graphic>
       </p:graphicFrame>
@@ -5819,7 +6105,7 @@
           <p:cNvPr id="9" name="">
             <a:extLst xmlns:a="http://schemas.openxmlformats.org/drawingml/2006/main">
               <a:ext uri="{FF2B5EF4-FFF2-40B4-BE49-F238E27FC236}">
-                <a16:creationId xmlns:a16="http://schemas.microsoft.com/office/drawing/2014/main" id="{4933C9D9-5D7D-4791-9811-44035AFF0209}"/>
+                <a16:creationId xmlns:a16="http://schemas.microsoft.com/office/drawing/2014/main" id="{57ABBF99-2A6F-4FA3-AEF0-D0E0CA1821FE}"/>
               </a:ext>
             </a:extLst>
           </p:cNvPr>
@@ -5876,7 +6162,7 @@
           <p:cNvPr id="10" name="">
             <a:extLst xmlns:a="http://schemas.openxmlformats.org/drawingml/2006/main">
               <a:ext uri="{FF2B5EF4-FFF2-40B4-BE49-F238E27FC236}">
-                <a16:creationId xmlns:a16="http://schemas.microsoft.com/office/drawing/2014/main" id="{0E7F1846-A710-40FA-9D3C-1A48DA59E17B}"/>
+                <a16:creationId xmlns:a16="http://schemas.microsoft.com/office/drawing/2014/main" id="{3C9B6DDD-F203-435B-97B8-E58F000EC8C0}"/>
               </a:ext>
             </a:extLst>
           </p:cNvPr>
@@ -5933,7 +6219,7 @@
           <p:cNvPr id="11" name="">
             <a:extLst xmlns:a="http://schemas.openxmlformats.org/drawingml/2006/main">
               <a:ext uri="{FF2B5EF4-FFF2-40B4-BE49-F238E27FC236}">
-                <a16:creationId xmlns:a16="http://schemas.microsoft.com/office/drawing/2014/main" id="{FA5C6FBF-BD9C-4911-B43E-0CE4AF5B545E}"/>
+                <a16:creationId xmlns:a16="http://schemas.microsoft.com/office/drawing/2014/main" id="{468552DC-A528-48AD-BD3F-25858E0860C8}"/>
               </a:ext>
             </a:extLst>
           </p:cNvPr>
@@ -5990,7 +6276,7 @@
           <p:cNvPr id="12" name="">
             <a:extLst xmlns:a="http://schemas.openxmlformats.org/drawingml/2006/main">
               <a:ext uri="{FF2B5EF4-FFF2-40B4-BE49-F238E27FC236}">
-                <a16:creationId xmlns:a16="http://schemas.microsoft.com/office/drawing/2014/main" id="{F632CEA5-7492-46FA-B542-7CBEFE2943B7}"/>
+                <a16:creationId xmlns:a16="http://schemas.microsoft.com/office/drawing/2014/main" id="{67F7224D-C678-44F1-A39C-49F573AD9D90}"/>
               </a:ext>
             </a:extLst>
           </p:cNvPr>
@@ -6045,7 +6331,7 @@
     </p:spTree>
     <p:extLst>
       <p:ext uri="{BB962C8B-B14F-4D97-AF65-F5344CB8AC3E}">
-        <p14:creationId xmlns:p14="http://schemas.microsoft.com/office/powerpoint/2010/main" val="342198508"/>
+        <p14:creationId xmlns:p14="http://schemas.microsoft.com/office/powerpoint/2010/main" val="279147430"/>
       </p:ext>
     </p:extLst>
   </p:cSld>
@@ -6073,10 +6359,10 @@
       </p:grpSpPr>
       <p:sp>
         <p:nvSpPr>
-          <p:cNvPr id="11" name="">
+          <p:cNvPr id="12" name="">
             <a:extLst xmlns:a="http://schemas.openxmlformats.org/drawingml/2006/main">
               <a:ext uri="{FF2B5EF4-FFF2-40B4-BE49-F238E27FC236}">
-                <a16:creationId xmlns:a16="http://schemas.microsoft.com/office/drawing/2014/main" id="{BE436B56-442B-4603-9C7D-9EECDC38DC62}"/>
+                <a16:creationId xmlns:a16="http://schemas.microsoft.com/office/drawing/2014/main" id="{6961FA43-7322-4FE1-87B4-972BCD2A8E2E}"/>
               </a:ext>
             </a:extLst>
           </p:cNvPr>
@@ -6133,7 +6419,7 @@
           <p:cNvPr id="2" name="">
             <a:extLst xmlns:a="http://schemas.openxmlformats.org/drawingml/2006/main">
               <a:ext uri="{FF2B5EF4-FFF2-40B4-BE49-F238E27FC236}">
-                <a16:creationId xmlns:a16="http://schemas.microsoft.com/office/drawing/2014/main" id="{3956A237-DE56-4F24-909F-5E30FD20B085}"/>
+                <a16:creationId xmlns:a16="http://schemas.microsoft.com/office/drawing/2014/main" id="{C81684E3-DF20-4CDB-A557-B1F9D14A321A}"/>
               </a:ext>
             </a:extLst>
           </p:cNvPr>
@@ -6187,21 +6473,21 @@
       </p:sp>
       <p:pic>
         <p:nvPicPr>
-          <p:cNvPr id="13" name=""/>
+          <p:cNvPr id="14" name=""/>
           <p:cNvPicPr>
             <a:picLocks xmlns:a="http://schemas.openxmlformats.org/drawingml/2006/main" noChangeAspect="1"/>
           </p:cNvPicPr>
           <p:nvPr/>
         </p:nvPicPr>
         <p:blipFill>
-          <a:blip xmlns:r="http://schemas.openxmlformats.org/officeDocument/2006/relationships" xmlns:a="http://schemas.openxmlformats.org/drawingml/2006/main" r:embed="Ra18ae027daa54f75"/>
-          <a:srcRect xmlns:a="http://schemas.openxmlformats.org/drawingml/2006/main" l="46976" t="43064" r="3159" b="10116"/>
+          <a:blip xmlns:r="http://schemas.openxmlformats.org/officeDocument/2006/relationships" xmlns:a="http://schemas.openxmlformats.org/drawingml/2006/main" r:embed="Re74ba77aa3894902"/>
+          <a:srcRect xmlns:a="http://schemas.openxmlformats.org/drawingml/2006/main" l="46976" t="41242" r="3159" b="9878"/>
           <a:stretch xmlns:a="http://schemas.openxmlformats.org/drawingml/2006/main"/>
         </p:blipFill>
         <p:spPr>
           <a:xfrm xmlns:a="http://schemas.openxmlformats.org/drawingml/2006/main">
-            <a:off x="609600" y="1741445"/>
-            <a:ext cx="5429250" cy="3556086"/>
+            <a:off x="637084" y="1857375"/>
+            <a:ext cx="5374283" cy="3476625"/>
           </a:xfrm>
           <a:prstGeom xmlns:a="http://schemas.openxmlformats.org/drawingml/2006/main" prst="rect">
             <a:avLst/>
@@ -6213,7 +6499,64 @@
           <p:cNvPr id="4" name="">
             <a:extLst xmlns:a="http://schemas.openxmlformats.org/drawingml/2006/main">
               <a:ext uri="{FF2B5EF4-FFF2-40B4-BE49-F238E27FC236}">
-                <a16:creationId xmlns:a16="http://schemas.microsoft.com/office/drawing/2014/main" id="{3315EE2D-4E60-48CE-8506-4A89A6375328}"/>
+                <a16:creationId xmlns:a16="http://schemas.microsoft.com/office/drawing/2014/main" id="{EB78CE6D-D2E9-4447-9867-2016062FF59A}"/>
+              </a:ext>
+            </a:extLst>
+          </p:cNvPr>
+          <p:cNvSpPr>
+            <a:spLocks xmlns:a="http://schemas.openxmlformats.org/drawingml/2006/main" noGrp="1"/>
+          </p:cNvSpPr>
+          <p:nvPr/>
+        </p:nvSpPr>
+        <p:spPr>
+          <a:xfrm xmlns:a="http://schemas.openxmlformats.org/drawingml/2006/main">
+            <a:off x="609600" y="1504950"/>
+            <a:ext cx="5429250" cy="266700"/>
+          </a:xfrm>
+          <a:prstGeom xmlns:a="http://schemas.openxmlformats.org/drawingml/2006/main" prst="rect">
+            <a:avLst/>
+          </a:prstGeom>
+          <a:noFill xmlns:a="http://schemas.openxmlformats.org/drawingml/2006/main"/>
+          <a:ln xmlns:a="http://schemas.openxmlformats.org/drawingml/2006/main" w="0">
+            <a:noFill/>
+          </a:ln>
+        </p:spPr>
+        <p:txBody>
+          <a:bodyPr xmlns:a="http://schemas.openxmlformats.org/drawingml/2006/main" lIns="0" tIns="0" rIns="0" bIns="0" anchor="t">
+            <a:noAutofit/>
+          </a:bodyPr>
+          <a:lstStyle xmlns:a="http://schemas.openxmlformats.org/drawingml/2006/main"/>
+          <a:p xmlns:a="http://schemas.openxmlformats.org/drawingml/2006/main">
+            <a:pPr algn="l">
+              <a:defRPr sz="1275" b="1">
+                <a:solidFill>
+                  <a:srgbClr val="A4B7C8"/>
+                </a:solidFill>
+                <a:latin typeface="Noto Sans"/>
+                <a:ea typeface="Noto Sans"/>
+                <a:cs typeface="Noto Sans"/>
+              </a:defRPr>
+            </a:pPr>
+            <a:r>
+              <a:rPr sz="1275" b="1">
+                <a:solidFill>
+                  <a:srgbClr val="A4B7C8"/>
+                </a:solidFill>
+                <a:latin typeface="Noto Sans"/>
+                <a:ea typeface="Noto Sans"/>
+                <a:cs typeface="Noto Sans"/>
+              </a:rPr>
+              <a:t>LOCAL SANDBOX CAPTURE</a:t>
+            </a:r>
+          </a:p>
+        </p:txBody>
+      </p:sp>
+      <p:sp>
+        <p:nvSpPr>
+          <p:cNvPr id="5" name="">
+            <a:extLst xmlns:a="http://schemas.openxmlformats.org/drawingml/2006/main">
+              <a:ext uri="{FF2B5EF4-FFF2-40B4-BE49-F238E27FC236}">
+                <a16:creationId xmlns:a16="http://schemas.microsoft.com/office/drawing/2014/main" id="{0E9FD99C-D2E6-49AE-A8D0-66879073C47B}"/>
               </a:ext>
             </a:extLst>
           </p:cNvPr>
@@ -6260,17 +6603,17 @@
                 <a:ea typeface="Noto Sans"/>
                 <a:cs typeface="Noto Sans"/>
               </a:rPr>
-              <a:t>Prior v1.1 hosted demo</a:t>
-            </a:r>
-          </a:p>
-        </p:txBody>
-      </p:sp>
-      <p:sp>
-        <p:nvSpPr>
-          <p:cNvPr id="5" name="">
+              <a:t>Prior v1.1 host; new chat is local</a:t>
+            </a:r>
+          </a:p>
+        </p:txBody>
+      </p:sp>
+      <p:sp>
+        <p:nvSpPr>
+          <p:cNvPr id="6" name="">
             <a:extLst xmlns:a="http://schemas.openxmlformats.org/drawingml/2006/main">
               <a:ext uri="{FF2B5EF4-FFF2-40B4-BE49-F238E27FC236}">
-                <a16:creationId xmlns:a16="http://schemas.microsoft.com/office/drawing/2014/main" id="{A85AE64E-29A7-428A-AF05-356314A8429B}"/>
+                <a16:creationId xmlns:a16="http://schemas.microsoft.com/office/drawing/2014/main" id="{E06AEBF1-B854-425B-8241-565FDE00FEB8}"/>
               </a:ext>
             </a:extLst>
           </p:cNvPr>
@@ -6324,10 +6667,10 @@
       </p:sp>
       <p:sp>
         <p:nvSpPr>
-          <p:cNvPr id="6" name="">
+          <p:cNvPr id="7" name="">
             <a:extLst xmlns:a="http://schemas.openxmlformats.org/drawingml/2006/main">
               <a:ext uri="{FF2B5EF4-FFF2-40B4-BE49-F238E27FC236}">
-                <a16:creationId xmlns:a16="http://schemas.microsoft.com/office/drawing/2014/main" id="{978656DC-C656-4F83-87FA-DC1FC7882758}"/>
+                <a16:creationId xmlns:a16="http://schemas.microsoft.com/office/drawing/2014/main" id="{8078DFB0-32B2-4747-BDEF-B0C22911E2C8}"/>
               </a:ext>
             </a:extLst>
           </p:cNvPr>
@@ -6381,10 +6724,10 @@
       </p:sp>
       <p:sp>
         <p:nvSpPr>
-          <p:cNvPr id="7" name="">
+          <p:cNvPr id="8" name="">
             <a:extLst xmlns:a="http://schemas.openxmlformats.org/drawingml/2006/main">
               <a:ext uri="{FF2B5EF4-FFF2-40B4-BE49-F238E27FC236}">
-                <a16:creationId xmlns:a16="http://schemas.microsoft.com/office/drawing/2014/main" id="{4AC2A95B-8054-4872-8BEC-D106758C970D}"/>
+                <a16:creationId xmlns:a16="http://schemas.microsoft.com/office/drawing/2014/main" id="{A97E2CB0-27C7-4788-8742-9EE57525D8A5}"/>
               </a:ext>
             </a:extLst>
           </p:cNvPr>
@@ -6484,10 +6827,10 @@
       </p:sp>
       <p:sp>
         <p:nvSpPr>
-          <p:cNvPr id="8" name="">
+          <p:cNvPr id="9" name="">
             <a:extLst xmlns:a="http://schemas.openxmlformats.org/drawingml/2006/main">
               <a:ext uri="{FF2B5EF4-FFF2-40B4-BE49-F238E27FC236}">
-                <a16:creationId xmlns:a16="http://schemas.microsoft.com/office/drawing/2014/main" id="{275CF8C7-37B4-4CAE-8FA3-36CD0D8DE677}"/>
+                <a16:creationId xmlns:a16="http://schemas.microsoft.com/office/drawing/2014/main" id="{B6A4B374-FD26-4007-B165-772562913BA8}"/>
               </a:ext>
             </a:extLst>
           </p:cNvPr>
@@ -6587,10 +6930,10 @@
       </p:sp>
       <p:sp>
         <p:nvSpPr>
-          <p:cNvPr id="9" name="">
+          <p:cNvPr id="10" name="">
             <a:extLst xmlns:a="http://schemas.openxmlformats.org/drawingml/2006/main">
               <a:ext uri="{FF2B5EF4-FFF2-40B4-BE49-F238E27FC236}">
-                <a16:creationId xmlns:a16="http://schemas.microsoft.com/office/drawing/2014/main" id="{0179501B-E3E2-46EE-8297-B64D29201ADE}"/>
+                <a16:creationId xmlns:a16="http://schemas.microsoft.com/office/drawing/2014/main" id="{FEF3C55F-5BD9-4BA2-8FA9-38F21ECE06F9}"/>
               </a:ext>
             </a:extLst>
           </p:cNvPr>
@@ -6644,10 +6987,10 @@
       </p:sp>
       <p:sp>
         <p:nvSpPr>
-          <p:cNvPr id="10" name="">
+          <p:cNvPr id="11" name="">
             <a:extLst xmlns:a="http://schemas.openxmlformats.org/drawingml/2006/main">
               <a:ext uri="{FF2B5EF4-FFF2-40B4-BE49-F238E27FC236}">
-                <a16:creationId xmlns:a16="http://schemas.microsoft.com/office/drawing/2014/main" id="{67EB4FA9-0C04-4B10-BF2E-ABBE6541FD50}"/>
+                <a16:creationId xmlns:a16="http://schemas.microsoft.com/office/drawing/2014/main" id="{3A5E23C5-8916-4009-967A-89A1DE350B90}"/>
               </a:ext>
             </a:extLst>
           </p:cNvPr>
@@ -6725,7 +7068,7 @@
     </p:spTree>
     <p:extLst>
       <p:ext uri="{BB962C8B-B14F-4D97-AF65-F5344CB8AC3E}">
-        <p14:creationId xmlns:p14="http://schemas.microsoft.com/office/powerpoint/2010/main" val="1941918709"/>
+        <p14:creationId xmlns:p14="http://schemas.microsoft.com/office/powerpoint/2010/main" val="804392976"/>
       </p:ext>
     </p:extLst>
   </p:cSld>

</xml_diff>

<commit_message>
docs: finalize reviewed Claro chat demo package
</commit_message>
<xml_diff>
--- a/submission/Claro-Hackathon-2026.pptx
+++ b/submission/Claro-Hackathon-2026.pptx
@@ -2,18 +2,18 @@
 <file path=ppt/presentation.xml><?xml version="1.0" encoding="utf-8"?>
 <p:presentation xmlns:p="http://schemas.openxmlformats.org/presentationml/2006/main">
   <p:sldMasterIdLst>
-    <p:sldMasterId xmlns:r="http://schemas.openxmlformats.org/officeDocument/2006/relationships" id="2147483648" r:id="R8be612e034384eb4"/>
+    <p:sldMasterId xmlns:r="http://schemas.openxmlformats.org/officeDocument/2006/relationships" id="2147483648" r:id="R183764540d1941a4"/>
   </p:sldMasterIdLst>
   <p:notesMasterIdLst>
-    <p:notesMasterId xmlns:r="http://schemas.openxmlformats.org/officeDocument/2006/relationships" r:id="R39999bb0da03487f"/>
+    <p:notesMasterId xmlns:r="http://schemas.openxmlformats.org/officeDocument/2006/relationships" r:id="R63ad287788044371"/>
   </p:notesMasterIdLst>
   <p:sldIdLst>
-    <p:sldId xmlns:r="http://schemas.openxmlformats.org/officeDocument/2006/relationships" id="256" r:id="Rf0e624af19d24b3d"/>
-    <p:sldId xmlns:r="http://schemas.openxmlformats.org/officeDocument/2006/relationships" id="257" r:id="Rc807c72537ed4227"/>
-    <p:sldId xmlns:r="http://schemas.openxmlformats.org/officeDocument/2006/relationships" id="258" r:id="Rdb647a4494b14ce9"/>
-    <p:sldId xmlns:r="http://schemas.openxmlformats.org/officeDocument/2006/relationships" id="259" r:id="Ra6cf97db031d4856"/>
-    <p:sldId xmlns:r="http://schemas.openxmlformats.org/officeDocument/2006/relationships" id="260" r:id="R3bf677607fd7414d"/>
-    <p:sldId xmlns:r="http://schemas.openxmlformats.org/officeDocument/2006/relationships" id="261" r:id="R9e4c003dd4d94578"/>
+    <p:sldId xmlns:r="http://schemas.openxmlformats.org/officeDocument/2006/relationships" id="256" r:id="R4307979c8bf14a81"/>
+    <p:sldId xmlns:r="http://schemas.openxmlformats.org/officeDocument/2006/relationships" id="257" r:id="R35369e63c5094b58"/>
+    <p:sldId xmlns:r="http://schemas.openxmlformats.org/officeDocument/2006/relationships" id="258" r:id="Rdac8e13ac3d5463a"/>
+    <p:sldId xmlns:r="http://schemas.openxmlformats.org/officeDocument/2006/relationships" id="259" r:id="Rd4bbd90722274054"/>
+    <p:sldId xmlns:r="http://schemas.openxmlformats.org/officeDocument/2006/relationships" id="260" r:id="Re87375508abd4c52"/>
+    <p:sldId xmlns:r="http://schemas.openxmlformats.org/officeDocument/2006/relationships" id="261" r:id="R4649150e30944a86"/>
   </p:sldIdLst>
   <p:sldSz cx="12192000" cy="6858000"/>
   <p:notesSz cx="6858000" cy="9144000"/>
@@ -517,7 +517,7 @@
           <a:lstStyle xmlns:a="http://schemas.openxmlformats.org/drawingml/2006/main"/>
           <a:p xmlns:a="http://schemas.openxmlformats.org/drawingml/2006/main">
             <a:r>
-              <a:t>Screenshot provenance: CUA Chrome, http://127.0.0.1:8096, 2026-10-05 UTC; actual isolated sandbox with team-authored fixtures and external providers disabled; final backend/static hashes and checks in docs/evidence/chat-browser-checks.json. The UI creates a trusted sandbox session without persona or language selectors. ES/PT detection never changes customer identity. Exact references narrow validated authorized records and ambiguity prompts clarification. The customer report preserves specific redacted allegations through transaction clarification and is labeled unverified; permitted record facts remain separate. Customer sees the specific redacted report and attached transaction ID, merchant, amount/currency and recorded status before confirming. Explicit general human-review requests attach no transaction. Atomic case commit and fresh read-back precede the receipt. The reviewer route is /?review=1. The owning customer answers a persisted question in the same composer. Case events remain scoped and idempotent. No real money movement, refunds or card blocking. Sources: docs/SYSTEM_EVALUATION.md, docs/OPERATIONS.md, api.py, privacy.py, store.py and workflow.py.</a:t>
+              <a:t>Screenshot provenance: CUA Chrome, http://127.0.0.1:8096, 2026-10-05 UTC; actual isolated sandbox with team-authored fixtures and external providers disabled; original capture backend/static hashes in docs/evidence/chat-browser-checks.json; predates cache/F7/F8/M1/L1/N1/N2/P1–P4 and Q1/Q2 corrections. Final hosted source has separate API/browser and supplemental conversational HTTPS receipts; P4 additionally has source-matched privacy/history tests. Original capture backend/static hashes remain unchanged. The UI creates a trusted sandbox session without persona or language selectors. ES/PT detection never changes customer identity. Exact references narrow validated authorized records and ambiguity prompts clarification. The customer report preserves specific redacted allegations through transaction clarification and is labeled unverified; permitted record facts remain separate. Customer sees the specific redacted report and attached transaction ID, merchant, amount/currency and recorded status before confirming. Explicit general human-review requests attach no transaction. Atomic case commit and fresh read-back precede the receipt. The reviewer route is /?review=1. The owning customer answers a persisted question in the same composer. Case events remain scoped and idempotent. No real money movement, refunds or card blocking. Sources: docs/SYSTEM_EVALUATION.md, docs/OPERATIONS.md, api.py, privacy.py, store.py and workflow.py.</a:t>
             </a:r>
           </a:p>
         </p:txBody>
@@ -797,7 +797,7 @@
           <a:lstStyle xmlns:a="http://schemas.openxmlformats.org/drawingml/2006/main"/>
           <a:p xmlns:a="http://schemas.openxmlformats.org/drawingml/2006/main">
             <a:r>
-              <a:t>Repository: https://github.com/nicoceron/factored-hackathon-2026-nicoceron . Public URL remains tied to the prior v1.1 receipt. The current chat redesign is local and has not been deployed. Reviewer access is /?review=1 and customer chat is /. Current local screenshots do not independently prove that a newer branch is deployed. Optional Jev/DeepSeek adapters are implemented/mocked but live inference remains unverified pending authorized metered use. External tariff estimates are not invoice spend. Screenshot is a declared geometry crop of the current local reviewer timeline. Its Spanish interface retains the original Spanish report plus Portuguese question and reply; the filename does not imply a Portuguese-only interface. Declared screenshot provenance: CUA Chrome, http://127.0.0.1:8096, 2026-10-05 UTC; actual isolated sandbox with team-authored fixtures and external providers disabled; final backend/static hashes and checks in docs/evidence/chat-browser-checks.json. Free-host filesystem may reset. Sources: docs/AI_PROVIDERS.md, docs/OPERATIONS.md and submission/deployment.json. Real-bank requirements include approved identity/entitlements/MFA/policies, durable data, monitored rollout, privacy controls, independent ES/PT review and staffing. Organizer submission is intentionally outside requested scope. No real-bank operation or production safety certification.</a:t>
+              <a:t>Repository: https://github.com/nicoceron/factored-hackathon-2026-nicoceron . The separate deployment receipt verifies the current chat source and public assets at the recorded commit. Reviewer access is /?review=1 and customer chat is /. Seven original local screenshots retain their captured source hashes; later cache, F7 report-continuity, F8 reply-history/locale, M1 denial-polarity, L1 ordinal-choice and N1/N2 conversational-choice, P1 decimal-reference, P2 rejected-amount, P3 currency-constraint and P4 numeric-case-history, Q1 currency-symbol and Q2 rejected-choice task-continuity corrections are verified separately by the final public API/browser and supplemental conversational HTTPS receipts, focused source-matched privacy/history tests and four supplemental hosted captures. Optional Jev/DeepSeek adapters are implemented/mocked but live inference remains unverified pending authorized metered use. External tariff estimates are not invoice spend. Screenshot is a declared geometry crop of the original local reviewer timeline. Its Spanish interface retains the original Spanish report plus Portuguese question and reply; the filename does not imply a Portuguese-only interface. Declared screenshot provenance: CUA Chrome, http://127.0.0.1:8096, 2026-10-05 UTC; actual isolated sandbox with team-authored fixtures and external providers disabled; original capture backend/static hashes in docs/evidence/chat-browser-checks.json; predates cache/F7/F8/M1/L1/N1/N2/P1–P4 and Q1/Q2 corrections. Final hosted source has separate API/browser and supplemental conversational HTTPS receipts; P4 additionally has source-matched privacy/history tests. Original capture backend/static hashes remain unchanged. Free-host filesystem may reset. Sources: docs/AI_PROVIDERS.md, docs/OPERATIONS.md and submission/deployment.json. Real-bank requirements include approved identity/entitlements/MFA/policies, durable data, monitored rollout, privacy controls, independent ES/PT review and staffing. Organizer submission is intentionally outside requested scope. No real-bank operation or production safety certification.</a:t>
             </a:r>
           </a:p>
         </p:txBody>
@@ -865,7 +865,7 @@
   </p:cSld>
   <p:clrMap bg1="lt1" tx1="dk1" bg2="lt2" tx2="dk2" accent1="accent1" accent2="accent2" accent3="accent3" accent4="accent4" accent5="accent5" accent6="accent6" hlink="hlink" folHlink="folHlink"/>
   <p:sldLayoutIdLst>
-    <p:sldLayoutId xmlns:r="http://schemas.openxmlformats.org/officeDocument/2006/relationships" id="2147483649" r:id="R598ace7b97f64e01"/>
+    <p:sldLayoutId xmlns:r="http://schemas.openxmlformats.org/officeDocument/2006/relationships" id="2147483649" r:id="Rcec1b8abe06345eb"/>
   </p:sldLayoutIdLst>
   <p:txStyles>
     <p:titleStyle>
@@ -2149,7 +2149,7 @@
                         <a:ea typeface="Noto Sans"/>
                         <a:cs typeface="Noto Sans"/>
                       </a:rPr>
-                      <a:t>83 / 140</a:t>
+                      <a:t>85 / 140</a:t>
                     </a:r>
                   </a:p>
                 </c:rich>
@@ -2245,7 +2245,7 @@
                 <c:formatCode>0%</c:formatCode>
                 <c:ptCount val="2"/>
                 <c:pt idx="0">
-                  <c:v>0.592857143</c:v>
+                  <c:v>0.607142857</c:v>
                 </c:pt>
                 <c:pt idx="1">
                   <c:v>0.928571429</c:v>
@@ -2409,7 +2409,7 @@
           <p:cNvPr id="10" name="">
             <a:extLst xmlns:a="http://schemas.openxmlformats.org/drawingml/2006/main">
               <a:ext uri="{FF2B5EF4-FFF2-40B4-BE49-F238E27FC236}">
-                <a16:creationId xmlns:a16="http://schemas.microsoft.com/office/drawing/2014/main" id="{954E80DB-65D8-4FA4-8C4F-DC9093546443}"/>
+                <a16:creationId xmlns:a16="http://schemas.microsoft.com/office/drawing/2014/main" id="{9CED3DAB-7331-4723-AD78-CF9B3E64610D}"/>
               </a:ext>
             </a:extLst>
           </p:cNvPr>
@@ -2466,7 +2466,7 @@
           <p:cNvPr id="2" name="">
             <a:extLst xmlns:a="http://schemas.openxmlformats.org/drawingml/2006/main">
               <a:ext uri="{FF2B5EF4-FFF2-40B4-BE49-F238E27FC236}">
-                <a16:creationId xmlns:a16="http://schemas.microsoft.com/office/drawing/2014/main" id="{CA87188A-25DA-4863-A46E-735804BA1513}"/>
+                <a16:creationId xmlns:a16="http://schemas.microsoft.com/office/drawing/2014/main" id="{6D93E6BF-E609-4691-B2DB-8759E6563268}"/>
               </a:ext>
             </a:extLst>
           </p:cNvPr>
@@ -2546,7 +2546,7 @@
           <p:cNvPr id="3" name="">
             <a:extLst xmlns:a="http://schemas.openxmlformats.org/drawingml/2006/main">
               <a:ext uri="{FF2B5EF4-FFF2-40B4-BE49-F238E27FC236}">
-                <a16:creationId xmlns:a16="http://schemas.microsoft.com/office/drawing/2014/main" id="{4122BE13-450C-46EA-8EA5-E428C6226BC5}"/>
+                <a16:creationId xmlns:a16="http://schemas.microsoft.com/office/drawing/2014/main" id="{30F831D4-1789-41D3-975A-FC7115FBF3FC}"/>
               </a:ext>
             </a:extLst>
           </p:cNvPr>
@@ -2626,7 +2626,7 @@
           <p:cNvPr id="4" name="">
             <a:extLst xmlns:a="http://schemas.openxmlformats.org/drawingml/2006/main">
               <a:ext uri="{FF2B5EF4-FFF2-40B4-BE49-F238E27FC236}">
-                <a16:creationId xmlns:a16="http://schemas.microsoft.com/office/drawing/2014/main" id="{05F29862-4898-4600-B114-C940B084E2C7}"/>
+                <a16:creationId xmlns:a16="http://schemas.microsoft.com/office/drawing/2014/main" id="{2905200B-11C3-4B51-A5E6-AC1CB70A4DEE}"/>
               </a:ext>
             </a:extLst>
           </p:cNvPr>
@@ -2683,7 +2683,7 @@
           <p:cNvPr id="5" name="">
             <a:extLst xmlns:a="http://schemas.openxmlformats.org/drawingml/2006/main">
               <a:ext uri="{FF2B5EF4-FFF2-40B4-BE49-F238E27FC236}">
-                <a16:creationId xmlns:a16="http://schemas.microsoft.com/office/drawing/2014/main" id="{329A1AEB-C745-4E36-9750-75F2CB9A8F8A}"/>
+                <a16:creationId xmlns:a16="http://schemas.microsoft.com/office/drawing/2014/main" id="{AEFCF6B3-D728-473B-878B-D18C2015B8AE}"/>
               </a:ext>
             </a:extLst>
           </p:cNvPr>
@@ -2740,7 +2740,7 @@
           <p:cNvPr id="6" name="">
             <a:extLst xmlns:a="http://schemas.openxmlformats.org/drawingml/2006/main">
               <a:ext uri="{FF2B5EF4-FFF2-40B4-BE49-F238E27FC236}">
-                <a16:creationId xmlns:a16="http://schemas.microsoft.com/office/drawing/2014/main" id="{BC831CB8-817B-4B22-A1AD-CF868DA16986}"/>
+                <a16:creationId xmlns:a16="http://schemas.microsoft.com/office/drawing/2014/main" id="{17150398-F450-44EB-9C2C-3BBB0D542A43}"/>
               </a:ext>
             </a:extLst>
           </p:cNvPr>
@@ -2797,7 +2797,7 @@
           <p:cNvPr id="7" name="">
             <a:extLst xmlns:a="http://schemas.openxmlformats.org/drawingml/2006/main">
               <a:ext uri="{FF2B5EF4-FFF2-40B4-BE49-F238E27FC236}">
-                <a16:creationId xmlns:a16="http://schemas.microsoft.com/office/drawing/2014/main" id="{A9BD773A-BDC0-4223-AA8C-C46A1ECC7369}"/>
+                <a16:creationId xmlns:a16="http://schemas.microsoft.com/office/drawing/2014/main" id="{E2FD56F8-DEC9-4EBD-B939-E585BC7300F6}"/>
               </a:ext>
             </a:extLst>
           </p:cNvPr>
@@ -2877,7 +2877,7 @@
           <p:cNvPr id="8" name="">
             <a:extLst xmlns:a="http://schemas.openxmlformats.org/drawingml/2006/main">
               <a:ext uri="{FF2B5EF4-FFF2-40B4-BE49-F238E27FC236}">
-                <a16:creationId xmlns:a16="http://schemas.microsoft.com/office/drawing/2014/main" id="{9B370167-0626-4A0E-883A-FF7E94EEB7EF}"/>
+                <a16:creationId xmlns:a16="http://schemas.microsoft.com/office/drawing/2014/main" id="{DFB89158-413F-4968-862E-BEB2CD90373E}"/>
               </a:ext>
             </a:extLst>
           </p:cNvPr>
@@ -2934,7 +2934,7 @@
           <p:cNvPr id="9" name="">
             <a:extLst xmlns:a="http://schemas.openxmlformats.org/drawingml/2006/main">
               <a:ext uri="{FF2B5EF4-FFF2-40B4-BE49-F238E27FC236}">
-                <a16:creationId xmlns:a16="http://schemas.microsoft.com/office/drawing/2014/main" id="{E472610D-CA77-413E-9F60-35910837F477}"/>
+                <a16:creationId xmlns:a16="http://schemas.microsoft.com/office/drawing/2014/main" id="{62E95739-C920-49F6-99D4-3F5FB7225F5E}"/>
               </a:ext>
             </a:extLst>
           </p:cNvPr>
@@ -2989,7 +2989,7 @@
     </p:spTree>
     <p:extLst>
       <p:ext uri="{BB962C8B-B14F-4D97-AF65-F5344CB8AC3E}">
-        <p14:creationId xmlns:p14="http://schemas.microsoft.com/office/powerpoint/2010/main" val="647948060"/>
+        <p14:creationId xmlns:p14="http://schemas.microsoft.com/office/powerpoint/2010/main" val="380709841"/>
       </p:ext>
     </p:extLst>
   </p:cSld>
@@ -3020,7 +3020,7 @@
           <p:cNvPr id="13" name="">
             <a:extLst xmlns:a="http://schemas.openxmlformats.org/drawingml/2006/main">
               <a:ext uri="{FF2B5EF4-FFF2-40B4-BE49-F238E27FC236}">
-                <a16:creationId xmlns:a16="http://schemas.microsoft.com/office/drawing/2014/main" id="{D39AC70A-AD1E-41DA-A3B6-720FC425253F}"/>
+                <a16:creationId xmlns:a16="http://schemas.microsoft.com/office/drawing/2014/main" id="{127DF2F0-096F-4D29-A447-BDEBEE749157}"/>
               </a:ext>
             </a:extLst>
           </p:cNvPr>
@@ -3077,7 +3077,7 @@
           <p:cNvPr id="2" name="">
             <a:extLst xmlns:a="http://schemas.openxmlformats.org/drawingml/2006/main">
               <a:ext uri="{FF2B5EF4-FFF2-40B4-BE49-F238E27FC236}">
-                <a16:creationId xmlns:a16="http://schemas.microsoft.com/office/drawing/2014/main" id="{6BDE773E-0B5D-4A04-A7C6-D8331D022158}"/>
+                <a16:creationId xmlns:a16="http://schemas.microsoft.com/office/drawing/2014/main" id="{9E5AF2EF-33E3-41CA-9DF9-5D212C368734}"/>
               </a:ext>
             </a:extLst>
           </p:cNvPr>
@@ -3138,7 +3138,7 @@
           <p:nvPr/>
         </p:nvPicPr>
         <p:blipFill>
-          <a:blip xmlns:r="http://schemas.openxmlformats.org/officeDocument/2006/relationships" xmlns:a="http://schemas.openxmlformats.org/drawingml/2006/main" r:embed="Rd0959fcef7f94acb"/>
+          <a:blip xmlns:r="http://schemas.openxmlformats.org/officeDocument/2006/relationships" xmlns:a="http://schemas.openxmlformats.org/drawingml/2006/main" r:embed="Refac8499a0e84ce4"/>
           <a:srcRect xmlns:a="http://schemas.openxmlformats.org/drawingml/2006/main" l="33602" t="7225" r="33468" b="7514"/>
           <a:stretch xmlns:a="http://schemas.openxmlformats.org/drawingml/2006/main"/>
         </p:blipFill>
@@ -3157,7 +3157,7 @@
           <p:cNvPr id="4" name="">
             <a:extLst xmlns:a="http://schemas.openxmlformats.org/drawingml/2006/main">
               <a:ext uri="{FF2B5EF4-FFF2-40B4-BE49-F238E27FC236}">
-                <a16:creationId xmlns:a16="http://schemas.microsoft.com/office/drawing/2014/main" id="{0FE213A5-5AE4-4802-8452-60A430323D6D}"/>
+                <a16:creationId xmlns:a16="http://schemas.microsoft.com/office/drawing/2014/main" id="{B46EDCE7-8C68-4947-8A5F-426450EEE046}"/>
               </a:ext>
             </a:extLst>
           </p:cNvPr>
@@ -3214,7 +3214,7 @@
           <p:cNvPr id="5" name="">
             <a:extLst xmlns:a="http://schemas.openxmlformats.org/drawingml/2006/main">
               <a:ext uri="{FF2B5EF4-FFF2-40B4-BE49-F238E27FC236}">
-                <a16:creationId xmlns:a16="http://schemas.microsoft.com/office/drawing/2014/main" id="{77C24116-2F86-44C0-B29F-03EEA105D890}"/>
+                <a16:creationId xmlns:a16="http://schemas.microsoft.com/office/drawing/2014/main" id="{B6E53F60-0284-4601-ADAC-E6986EF2AE7C}"/>
               </a:ext>
             </a:extLst>
           </p:cNvPr>
@@ -3363,7 +3363,7 @@
           <p:cNvPr id="6" name="">
             <a:extLst xmlns:a="http://schemas.openxmlformats.org/drawingml/2006/main">
               <a:ext uri="{FF2B5EF4-FFF2-40B4-BE49-F238E27FC236}">
-                <a16:creationId xmlns:a16="http://schemas.microsoft.com/office/drawing/2014/main" id="{07D422B4-E6E4-47AA-A225-0B4CCC5720BF}"/>
+                <a16:creationId xmlns:a16="http://schemas.microsoft.com/office/drawing/2014/main" id="{334B91D8-C825-45DE-9F1E-A6F3CD653359}"/>
               </a:ext>
             </a:extLst>
           </p:cNvPr>
@@ -3443,7 +3443,7 @@
           <p:cNvPr id="7" name="">
             <a:extLst xmlns:a="http://schemas.openxmlformats.org/drawingml/2006/main">
               <a:ext uri="{FF2B5EF4-FFF2-40B4-BE49-F238E27FC236}">
-                <a16:creationId xmlns:a16="http://schemas.microsoft.com/office/drawing/2014/main" id="{FEBF39BA-06BF-4799-8C72-A617DB8A0AF0}"/>
+                <a16:creationId xmlns:a16="http://schemas.microsoft.com/office/drawing/2014/main" id="{8582653E-A074-4723-84D1-E1567ACEA034}"/>
               </a:ext>
             </a:extLst>
           </p:cNvPr>
@@ -3500,7 +3500,7 @@
           <p:cNvPr id="8" name="">
             <a:extLst xmlns:a="http://schemas.openxmlformats.org/drawingml/2006/main">
               <a:ext uri="{FF2B5EF4-FFF2-40B4-BE49-F238E27FC236}">
-                <a16:creationId xmlns:a16="http://schemas.microsoft.com/office/drawing/2014/main" id="{460F722D-9744-46AA-B016-4BC8AFEE26EB}"/>
+                <a16:creationId xmlns:a16="http://schemas.microsoft.com/office/drawing/2014/main" id="{9C54F086-4EE0-4283-8C9D-2F89465DF5CB}"/>
               </a:ext>
             </a:extLst>
           </p:cNvPr>
@@ -3580,7 +3580,7 @@
           <p:cNvPr id="9" name="">
             <a:extLst xmlns:a="http://schemas.openxmlformats.org/drawingml/2006/main">
               <a:ext uri="{FF2B5EF4-FFF2-40B4-BE49-F238E27FC236}">
-                <a16:creationId xmlns:a16="http://schemas.microsoft.com/office/drawing/2014/main" id="{0DFD6A7D-5C0C-46F0-AEC7-914F5AA9A7E5}"/>
+                <a16:creationId xmlns:a16="http://schemas.microsoft.com/office/drawing/2014/main" id="{76A3A81E-7754-40F5-AE55-39A0728428B7}"/>
               </a:ext>
             </a:extLst>
           </p:cNvPr>
@@ -3637,7 +3637,7 @@
           <p:cNvPr id="10" name="">
             <a:extLst xmlns:a="http://schemas.openxmlformats.org/drawingml/2006/main">
               <a:ext uri="{FF2B5EF4-FFF2-40B4-BE49-F238E27FC236}">
-                <a16:creationId xmlns:a16="http://schemas.microsoft.com/office/drawing/2014/main" id="{FBC93444-F402-408F-BC36-CF5AB5B404D5}"/>
+                <a16:creationId xmlns:a16="http://schemas.microsoft.com/office/drawing/2014/main" id="{82893D9F-C3F4-4DFC-9C59-E7225453216A}"/>
               </a:ext>
             </a:extLst>
           </p:cNvPr>
@@ -3717,7 +3717,7 @@
           <p:cNvPr id="11" name="">
             <a:extLst xmlns:a="http://schemas.openxmlformats.org/drawingml/2006/main">
               <a:ext uri="{FF2B5EF4-FFF2-40B4-BE49-F238E27FC236}">
-                <a16:creationId xmlns:a16="http://schemas.microsoft.com/office/drawing/2014/main" id="{AB391D31-BBF6-4578-ACBE-CADA8958AFF5}"/>
+                <a16:creationId xmlns:a16="http://schemas.microsoft.com/office/drawing/2014/main" id="{D979196E-4768-49AB-9552-2D1765AD040E}"/>
               </a:ext>
             </a:extLst>
           </p:cNvPr>
@@ -3774,7 +3774,7 @@
           <p:cNvPr id="12" name="">
             <a:extLst xmlns:a="http://schemas.openxmlformats.org/drawingml/2006/main">
               <a:ext uri="{FF2B5EF4-FFF2-40B4-BE49-F238E27FC236}">
-                <a16:creationId xmlns:a16="http://schemas.microsoft.com/office/drawing/2014/main" id="{A02F70D2-0907-4B0D-AE25-B784E3995D6B}"/>
+                <a16:creationId xmlns:a16="http://schemas.microsoft.com/office/drawing/2014/main" id="{97653172-5C31-4AA9-BAFE-E6083D9076B6}"/>
               </a:ext>
             </a:extLst>
           </p:cNvPr>
@@ -3852,7 +3852,7 @@
     </p:spTree>
     <p:extLst>
       <p:ext uri="{BB962C8B-B14F-4D97-AF65-F5344CB8AC3E}">
-        <p14:creationId xmlns:p14="http://schemas.microsoft.com/office/powerpoint/2010/main" val="793164492"/>
+        <p14:creationId xmlns:p14="http://schemas.microsoft.com/office/powerpoint/2010/main" val="433825187"/>
       </p:ext>
     </p:extLst>
   </p:cSld>
@@ -3883,7 +3883,7 @@
           <p:cNvPr id="19" name="">
             <a:extLst xmlns:a="http://schemas.openxmlformats.org/drawingml/2006/main">
               <a:ext uri="{FF2B5EF4-FFF2-40B4-BE49-F238E27FC236}">
-                <a16:creationId xmlns:a16="http://schemas.microsoft.com/office/drawing/2014/main" id="{C48DDBA7-7C02-48FB-A94A-5688B75DA05F}"/>
+                <a16:creationId xmlns:a16="http://schemas.microsoft.com/office/drawing/2014/main" id="{B1A88183-07EE-47F1-A75A-E9E22C5BDE72}"/>
               </a:ext>
             </a:extLst>
           </p:cNvPr>
@@ -3940,7 +3940,7 @@
           <p:cNvPr id="2" name="">
             <a:extLst xmlns:a="http://schemas.openxmlformats.org/drawingml/2006/main">
               <a:ext uri="{FF2B5EF4-FFF2-40B4-BE49-F238E27FC236}">
-                <a16:creationId xmlns:a16="http://schemas.microsoft.com/office/drawing/2014/main" id="{406618EE-C10F-413E-BDC5-038784C2869E}"/>
+                <a16:creationId xmlns:a16="http://schemas.microsoft.com/office/drawing/2014/main" id="{73A1D261-F3BF-4421-808B-C5B09AC9675C}"/>
               </a:ext>
             </a:extLst>
           </p:cNvPr>
@@ -3997,7 +3997,7 @@
           <p:cNvPr id="3" name="">
             <a:extLst xmlns:a="http://schemas.openxmlformats.org/drawingml/2006/main">
               <a:ext uri="{FF2B5EF4-FFF2-40B4-BE49-F238E27FC236}">
-                <a16:creationId xmlns:a16="http://schemas.microsoft.com/office/drawing/2014/main" id="{9B7CF0A0-26EC-4E50-A666-C3F3229FACBE}"/>
+                <a16:creationId xmlns:a16="http://schemas.microsoft.com/office/drawing/2014/main" id="{CEA668FB-3F68-45A5-B712-261D237AB1BA}"/>
               </a:ext>
             </a:extLst>
           </p:cNvPr>
@@ -4054,7 +4054,7 @@
           <p:cNvPr id="4" name="">
             <a:extLst xmlns:a="http://schemas.openxmlformats.org/drawingml/2006/main">
               <a:ext uri="{FF2B5EF4-FFF2-40B4-BE49-F238E27FC236}">
-                <a16:creationId xmlns:a16="http://schemas.microsoft.com/office/drawing/2014/main" id="{A25B9C9A-CC4E-43C9-BF76-60D64A84578D}"/>
+                <a16:creationId xmlns:a16="http://schemas.microsoft.com/office/drawing/2014/main" id="{3ECA36BF-A2CA-431C-ABCD-CD2D0ECA8FD2}"/>
               </a:ext>
             </a:extLst>
           </p:cNvPr>
@@ -4113,7 +4113,7 @@
           <p:cNvPr id="5" name="">
             <a:extLst xmlns:a="http://schemas.openxmlformats.org/drawingml/2006/main">
               <a:ext uri="{FF2B5EF4-FFF2-40B4-BE49-F238E27FC236}">
-                <a16:creationId xmlns:a16="http://schemas.microsoft.com/office/drawing/2014/main" id="{6AC81C41-4329-4D2E-A4AB-87CF8CAE07DE}"/>
+                <a16:creationId xmlns:a16="http://schemas.microsoft.com/office/drawing/2014/main" id="{6B8AFABD-F909-4D8F-8965-4C5B494E7CC9}"/>
               </a:ext>
             </a:extLst>
           </p:cNvPr>
@@ -4195,7 +4195,7 @@
           <p:cNvPr id="6" name="">
             <a:extLst xmlns:a="http://schemas.openxmlformats.org/drawingml/2006/main">
               <a:ext uri="{FF2B5EF4-FFF2-40B4-BE49-F238E27FC236}">
-                <a16:creationId xmlns:a16="http://schemas.microsoft.com/office/drawing/2014/main" id="{A4F3ED7A-3A45-4F6D-ACE2-E962B077E18B}"/>
+                <a16:creationId xmlns:a16="http://schemas.microsoft.com/office/drawing/2014/main" id="{BF179CCB-F4A6-4B30-B242-F6DDC47A9895}"/>
               </a:ext>
             </a:extLst>
           </p:cNvPr>
@@ -4277,7 +4277,7 @@
           <p:cNvPr id="7" name="">
             <a:extLst xmlns:a="http://schemas.openxmlformats.org/drawingml/2006/main">
               <a:ext uri="{FF2B5EF4-FFF2-40B4-BE49-F238E27FC236}">
-                <a16:creationId xmlns:a16="http://schemas.microsoft.com/office/drawing/2014/main" id="{DBEF2A09-03EA-42B4-A4AB-5812F5F87043}"/>
+                <a16:creationId xmlns:a16="http://schemas.microsoft.com/office/drawing/2014/main" id="{0ED0533F-0E7C-4AB6-8B15-1AA9A2839957}"/>
               </a:ext>
             </a:extLst>
           </p:cNvPr>
@@ -4359,7 +4359,7 @@
           <p:cNvPr id="8" name="">
             <a:extLst xmlns:a="http://schemas.openxmlformats.org/drawingml/2006/main">
               <a:ext uri="{FF2B5EF4-FFF2-40B4-BE49-F238E27FC236}">
-                <a16:creationId xmlns:a16="http://schemas.microsoft.com/office/drawing/2014/main" id="{5A6270AD-A09E-4BD7-9D0B-1661EFA4C252}"/>
+                <a16:creationId xmlns:a16="http://schemas.microsoft.com/office/drawing/2014/main" id="{D4C924E8-7239-4BB5-B170-D915148785D7}"/>
               </a:ext>
             </a:extLst>
           </p:cNvPr>
@@ -4441,7 +4441,7 @@
           <p:cNvPr id="9" name="">
             <a:extLst xmlns:a="http://schemas.openxmlformats.org/drawingml/2006/main">
               <a:ext uri="{FF2B5EF4-FFF2-40B4-BE49-F238E27FC236}">
-                <a16:creationId xmlns:a16="http://schemas.microsoft.com/office/drawing/2014/main" id="{4E3D4F28-6E15-4E3A-8C2D-5A3ED648B60F}"/>
+                <a16:creationId xmlns:a16="http://schemas.microsoft.com/office/drawing/2014/main" id="{E583271D-CA0F-41D0-B978-8A8CD49E5BA8}"/>
               </a:ext>
             </a:extLst>
           </p:cNvPr>
@@ -4523,7 +4523,7 @@
           <p:cNvPr id="10" name="">
             <a:extLst xmlns:a="http://schemas.openxmlformats.org/drawingml/2006/main">
               <a:ext uri="{FF2B5EF4-FFF2-40B4-BE49-F238E27FC236}">
-                <a16:creationId xmlns:a16="http://schemas.microsoft.com/office/drawing/2014/main" id="{180EC040-04E4-4430-9C00-B685CA865FA6}"/>
+                <a16:creationId xmlns:a16="http://schemas.microsoft.com/office/drawing/2014/main" id="{97AB6506-0B83-4DB3-B5A7-6A763ACF8FAC}"/>
               </a:ext>
             </a:extLst>
           </p:cNvPr>
@@ -4755,7 +4755,7 @@
           <p:cNvPr id="17" name="">
             <a:extLst xmlns:a="http://schemas.openxmlformats.org/drawingml/2006/main">
               <a:ext uri="{FF2B5EF4-FFF2-40B4-BE49-F238E27FC236}">
-                <a16:creationId xmlns:a16="http://schemas.microsoft.com/office/drawing/2014/main" id="{C206509F-7A29-4301-9D27-D00AB119D027}"/>
+                <a16:creationId xmlns:a16="http://schemas.microsoft.com/office/drawing/2014/main" id="{CDE62E99-92BF-47E4-A1C3-4FC2B967ECD4}"/>
               </a:ext>
             </a:extLst>
           </p:cNvPr>
@@ -4858,7 +4858,7 @@
           <p:cNvPr id="18" name="">
             <a:extLst xmlns:a="http://schemas.openxmlformats.org/drawingml/2006/main">
               <a:ext uri="{FF2B5EF4-FFF2-40B4-BE49-F238E27FC236}">
-                <a16:creationId xmlns:a16="http://schemas.microsoft.com/office/drawing/2014/main" id="{DB105639-254D-4FE4-92BC-AD0B70215B32}"/>
+                <a16:creationId xmlns:a16="http://schemas.microsoft.com/office/drawing/2014/main" id="{A4836049-6034-4829-A288-444F44B85058}"/>
               </a:ext>
             </a:extLst>
           </p:cNvPr>
@@ -4913,7 +4913,7 @@
     </p:spTree>
     <p:extLst>
       <p:ext uri="{BB962C8B-B14F-4D97-AF65-F5344CB8AC3E}">
-        <p14:creationId xmlns:p14="http://schemas.microsoft.com/office/powerpoint/2010/main" val="1954842873"/>
+        <p14:creationId xmlns:p14="http://schemas.microsoft.com/office/powerpoint/2010/main" val="472654886"/>
       </p:ext>
     </p:extLst>
   </p:cSld>
@@ -4944,7 +4944,7 @@
           <p:cNvPr id="13" name="">
             <a:extLst xmlns:a="http://schemas.openxmlformats.org/drawingml/2006/main">
               <a:ext uri="{FF2B5EF4-FFF2-40B4-BE49-F238E27FC236}">
-                <a16:creationId xmlns:a16="http://schemas.microsoft.com/office/drawing/2014/main" id="{31C55AF5-3D51-4050-BBCD-CA35032A4247}"/>
+                <a16:creationId xmlns:a16="http://schemas.microsoft.com/office/drawing/2014/main" id="{C360AA16-6069-4158-9E7F-09BB43A6A725}"/>
               </a:ext>
             </a:extLst>
           </p:cNvPr>
@@ -5001,7 +5001,7 @@
           <p:cNvPr id="2" name="">
             <a:extLst xmlns:a="http://schemas.openxmlformats.org/drawingml/2006/main">
               <a:ext uri="{FF2B5EF4-FFF2-40B4-BE49-F238E27FC236}">
-                <a16:creationId xmlns:a16="http://schemas.microsoft.com/office/drawing/2014/main" id="{CA7E7886-2487-4611-9F3C-8ECB91CF032C}"/>
+                <a16:creationId xmlns:a16="http://schemas.microsoft.com/office/drawing/2014/main" id="{7176B4EF-2F04-4FEF-A579-9A75F4E67FBD}"/>
               </a:ext>
             </a:extLst>
           </p:cNvPr>
@@ -5058,7 +5058,7 @@
           <p:cNvPr id="3" name="">
             <a:extLst xmlns:a="http://schemas.openxmlformats.org/drawingml/2006/main">
               <a:ext uri="{FF2B5EF4-FFF2-40B4-BE49-F238E27FC236}">
-                <a16:creationId xmlns:a16="http://schemas.microsoft.com/office/drawing/2014/main" id="{FF10100E-0FA2-4019-9F07-13BEFCAB6621}"/>
+                <a16:creationId xmlns:a16="http://schemas.microsoft.com/office/drawing/2014/main" id="{24C303F8-F53B-4387-ADD9-7E38F38881A0}"/>
               </a:ext>
             </a:extLst>
           </p:cNvPr>
@@ -5115,7 +5115,7 @@
           <p:cNvPr id="4" name="">
             <a:extLst xmlns:a="http://schemas.openxmlformats.org/drawingml/2006/main">
               <a:ext uri="{FF2B5EF4-FFF2-40B4-BE49-F238E27FC236}">
-                <a16:creationId xmlns:a16="http://schemas.microsoft.com/office/drawing/2014/main" id="{E9CA6522-5A26-4417-B03C-8E481BDEFDF0}"/>
+                <a16:creationId xmlns:a16="http://schemas.microsoft.com/office/drawing/2014/main" id="{4EBDC7FC-A17E-4BD7-9A49-78669FEA3862}"/>
               </a:ext>
             </a:extLst>
           </p:cNvPr>
@@ -5218,7 +5218,7 @@
           <p:cNvPr id="5" name="">
             <a:extLst xmlns:a="http://schemas.openxmlformats.org/drawingml/2006/main">
               <a:ext uri="{FF2B5EF4-FFF2-40B4-BE49-F238E27FC236}">
-                <a16:creationId xmlns:a16="http://schemas.microsoft.com/office/drawing/2014/main" id="{8F9E4CB2-DA7A-43F7-8EF9-8BD97C6E3931}"/>
+                <a16:creationId xmlns:a16="http://schemas.microsoft.com/office/drawing/2014/main" id="{799A7CB2-F05F-42C5-B9B2-FB5DF21F03B3}"/>
               </a:ext>
             </a:extLst>
           </p:cNvPr>
@@ -5275,7 +5275,7 @@
           <p:cNvPr id="6" name="">
             <a:extLst xmlns:a="http://schemas.openxmlformats.org/drawingml/2006/main">
               <a:ext uri="{FF2B5EF4-FFF2-40B4-BE49-F238E27FC236}">
-                <a16:creationId xmlns:a16="http://schemas.microsoft.com/office/drawing/2014/main" id="{154FD183-8F04-429A-A48F-5E604D5C96CC}"/>
+                <a16:creationId xmlns:a16="http://schemas.microsoft.com/office/drawing/2014/main" id="{192AA6B6-E07D-4903-9EB2-AD8922A91D03}"/>
               </a:ext>
             </a:extLst>
           </p:cNvPr>
@@ -5378,7 +5378,7 @@
           <p:cNvPr id="7" name="">
             <a:extLst xmlns:a="http://schemas.openxmlformats.org/drawingml/2006/main">
               <a:ext uri="{FF2B5EF4-FFF2-40B4-BE49-F238E27FC236}">
-                <a16:creationId xmlns:a16="http://schemas.microsoft.com/office/drawing/2014/main" id="{E54A62B6-76C0-4623-BD84-C54B3410FE4F}"/>
+                <a16:creationId xmlns:a16="http://schemas.microsoft.com/office/drawing/2014/main" id="{C99FCBD2-04D8-4BA0-BC7C-D3FFAA24EDAF}"/>
               </a:ext>
             </a:extLst>
           </p:cNvPr>
@@ -5435,7 +5435,7 @@
           <p:cNvPr id="8" name="">
             <a:extLst xmlns:a="http://schemas.openxmlformats.org/drawingml/2006/main">
               <a:ext uri="{FF2B5EF4-FFF2-40B4-BE49-F238E27FC236}">
-                <a16:creationId xmlns:a16="http://schemas.microsoft.com/office/drawing/2014/main" id="{F8D48A34-0988-43CD-B188-A27A1017387E}"/>
+                <a16:creationId xmlns:a16="http://schemas.microsoft.com/office/drawing/2014/main" id="{CFAC27B1-7E05-4641-898C-56B9F99B8C9D}"/>
               </a:ext>
             </a:extLst>
           </p:cNvPr>
@@ -5499,7 +5499,7 @@
         </p:xfrm>
         <a:graphic xmlns:a="http://schemas.openxmlformats.org/drawingml/2006/main">
           <a:graphicData uri="http://schemas.openxmlformats.org/drawingml/2006/chart">
-            <c:chart xmlns:r="http://schemas.openxmlformats.org/officeDocument/2006/relationships" xmlns:c="http://schemas.openxmlformats.org/drawingml/2006/chart" r:id="R62ec38f8c58f4479"/>
+            <c:chart xmlns:r="http://schemas.openxmlformats.org/officeDocument/2006/relationships" xmlns:c="http://schemas.openxmlformats.org/drawingml/2006/chart" r:id="Rb3b812dab7504cac"/>
           </a:graphicData>
         </a:graphic>
       </p:graphicFrame>
@@ -5508,7 +5508,7 @@
           <p:cNvPr id="10" name="">
             <a:extLst xmlns:a="http://schemas.openxmlformats.org/drawingml/2006/main">
               <a:ext uri="{FF2B5EF4-FFF2-40B4-BE49-F238E27FC236}">
-                <a16:creationId xmlns:a16="http://schemas.microsoft.com/office/drawing/2014/main" id="{67B63188-C689-41F4-A8F1-9FA53E9ADA54}"/>
+                <a16:creationId xmlns:a16="http://schemas.microsoft.com/office/drawing/2014/main" id="{1702F052-F186-4920-883B-7BB5896EB5DA}"/>
               </a:ext>
             </a:extLst>
           </p:cNvPr>
@@ -5565,7 +5565,7 @@
           <p:cNvPr id="11" name="">
             <a:extLst xmlns:a="http://schemas.openxmlformats.org/drawingml/2006/main">
               <a:ext uri="{FF2B5EF4-FFF2-40B4-BE49-F238E27FC236}">
-                <a16:creationId xmlns:a16="http://schemas.microsoft.com/office/drawing/2014/main" id="{DCBCD4F1-78C9-4026-A952-E18B06F01049}"/>
+                <a16:creationId xmlns:a16="http://schemas.microsoft.com/office/drawing/2014/main" id="{074F088A-778A-4E11-8AE7-865FDF61F7C6}"/>
               </a:ext>
             </a:extLst>
           </p:cNvPr>
@@ -5645,7 +5645,7 @@
           <p:cNvPr id="12" name="">
             <a:extLst xmlns:a="http://schemas.openxmlformats.org/drawingml/2006/main">
               <a:ext uri="{FF2B5EF4-FFF2-40B4-BE49-F238E27FC236}">
-                <a16:creationId xmlns:a16="http://schemas.microsoft.com/office/drawing/2014/main" id="{8A19709E-B1E2-4CDD-92F5-10B0251C9D62}"/>
+                <a16:creationId xmlns:a16="http://schemas.microsoft.com/office/drawing/2014/main" id="{F062249A-B890-434E-8B56-A994E88A9A06}"/>
               </a:ext>
             </a:extLst>
           </p:cNvPr>
@@ -5700,7 +5700,7 @@
     </p:spTree>
     <p:extLst>
       <p:ext uri="{BB962C8B-B14F-4D97-AF65-F5344CB8AC3E}">
-        <p14:creationId xmlns:p14="http://schemas.microsoft.com/office/powerpoint/2010/main" val="929045976"/>
+        <p14:creationId xmlns:p14="http://schemas.microsoft.com/office/powerpoint/2010/main" val="1703470272"/>
       </p:ext>
     </p:extLst>
   </p:cSld>
@@ -5731,7 +5731,7 @@
           <p:cNvPr id="13" name="">
             <a:extLst xmlns:a="http://schemas.openxmlformats.org/drawingml/2006/main">
               <a:ext uri="{FF2B5EF4-FFF2-40B4-BE49-F238E27FC236}">
-                <a16:creationId xmlns:a16="http://schemas.microsoft.com/office/drawing/2014/main" id="{2B572132-D3B2-4321-BB96-1FBD1FB0D14F}"/>
+                <a16:creationId xmlns:a16="http://schemas.microsoft.com/office/drawing/2014/main" id="{032FCAD2-B23D-4CEF-9EE6-521CFE8D6E94}"/>
               </a:ext>
             </a:extLst>
           </p:cNvPr>
@@ -5788,7 +5788,7 @@
           <p:cNvPr id="2" name="">
             <a:extLst xmlns:a="http://schemas.openxmlformats.org/drawingml/2006/main">
               <a:ext uri="{FF2B5EF4-FFF2-40B4-BE49-F238E27FC236}">
-                <a16:creationId xmlns:a16="http://schemas.microsoft.com/office/drawing/2014/main" id="{5704EB60-A99D-4A0D-9A90-6DD3734F93FC}"/>
+                <a16:creationId xmlns:a16="http://schemas.microsoft.com/office/drawing/2014/main" id="{8564CBA2-4301-4118-B4D9-0AFE60848350}"/>
               </a:ext>
             </a:extLst>
           </p:cNvPr>
@@ -5845,7 +5845,7 @@
           <p:cNvPr id="3" name="">
             <a:extLst xmlns:a="http://schemas.openxmlformats.org/drawingml/2006/main">
               <a:ext uri="{FF2B5EF4-FFF2-40B4-BE49-F238E27FC236}">
-                <a16:creationId xmlns:a16="http://schemas.microsoft.com/office/drawing/2014/main" id="{5116C19D-FD67-43E3-835B-E891D5D424DE}"/>
+                <a16:creationId xmlns:a16="http://schemas.microsoft.com/office/drawing/2014/main" id="{2EF5EF1A-C918-4E42-B58C-3FD2A4883EAB}"/>
               </a:ext>
             </a:extLst>
           </p:cNvPr>
@@ -5902,7 +5902,7 @@
           <p:cNvPr id="4" name="">
             <a:extLst xmlns:a="http://schemas.openxmlformats.org/drawingml/2006/main">
               <a:ext uri="{FF2B5EF4-FFF2-40B4-BE49-F238E27FC236}">
-                <a16:creationId xmlns:a16="http://schemas.microsoft.com/office/drawing/2014/main" id="{E68ADAE7-C1A6-4258-86DB-878FCC5B9119}"/>
+                <a16:creationId xmlns:a16="http://schemas.microsoft.com/office/drawing/2014/main" id="{4B3C0969-334C-439D-B6F5-19D3C1F6F8B4}"/>
               </a:ext>
             </a:extLst>
           </p:cNvPr>
@@ -5966,7 +5966,7 @@
         </p:xfrm>
         <a:graphic xmlns:a="http://schemas.openxmlformats.org/drawingml/2006/main">
           <a:graphicData uri="http://schemas.openxmlformats.org/drawingml/2006/chart">
-            <c:chart xmlns:r="http://schemas.openxmlformats.org/officeDocument/2006/relationships" xmlns:c="http://schemas.openxmlformats.org/drawingml/2006/chart" r:id="R0ac38c70f84f4ef9"/>
+            <c:chart xmlns:r="http://schemas.openxmlformats.org/officeDocument/2006/relationships" xmlns:c="http://schemas.openxmlformats.org/drawingml/2006/chart" r:id="R9d583637a0134d14"/>
           </a:graphicData>
         </a:graphic>
       </p:graphicFrame>
@@ -5975,7 +5975,7 @@
           <p:cNvPr id="6" name="">
             <a:extLst xmlns:a="http://schemas.openxmlformats.org/drawingml/2006/main">
               <a:ext uri="{FF2B5EF4-FFF2-40B4-BE49-F238E27FC236}">
-                <a16:creationId xmlns:a16="http://schemas.microsoft.com/office/drawing/2014/main" id="{550A69A1-06D0-406A-A444-A05A27C67155}"/>
+                <a16:creationId xmlns:a16="http://schemas.microsoft.com/office/drawing/2014/main" id="{97293413-FA9F-4D5C-9672-732BCCC49CD2}"/>
               </a:ext>
             </a:extLst>
           </p:cNvPr>
@@ -6032,7 +6032,7 @@
           <p:cNvPr id="7" name="">
             <a:extLst xmlns:a="http://schemas.openxmlformats.org/drawingml/2006/main">
               <a:ext uri="{FF2B5EF4-FFF2-40B4-BE49-F238E27FC236}">
-                <a16:creationId xmlns:a16="http://schemas.microsoft.com/office/drawing/2014/main" id="{6D660CF0-6AA4-416D-8691-51E8144F3FC3}"/>
+                <a16:creationId xmlns:a16="http://schemas.microsoft.com/office/drawing/2014/main" id="{546FDAD4-6D2F-42B0-8637-C929636E1B94}"/>
               </a:ext>
             </a:extLst>
           </p:cNvPr>
@@ -6096,7 +6096,7 @@
         </p:xfrm>
         <a:graphic xmlns:a="http://schemas.openxmlformats.org/drawingml/2006/main">
           <a:graphicData uri="http://schemas.openxmlformats.org/drawingml/2006/chart">
-            <c:chart xmlns:r="http://schemas.openxmlformats.org/officeDocument/2006/relationships" xmlns:c="http://schemas.openxmlformats.org/drawingml/2006/chart" r:id="R44d2367e55934186"/>
+            <c:chart xmlns:r="http://schemas.openxmlformats.org/officeDocument/2006/relationships" xmlns:c="http://schemas.openxmlformats.org/drawingml/2006/chart" r:id="R32953cd0a90c4203"/>
           </a:graphicData>
         </a:graphic>
       </p:graphicFrame>
@@ -6105,7 +6105,7 @@
           <p:cNvPr id="9" name="">
             <a:extLst xmlns:a="http://schemas.openxmlformats.org/drawingml/2006/main">
               <a:ext uri="{FF2B5EF4-FFF2-40B4-BE49-F238E27FC236}">
-                <a16:creationId xmlns:a16="http://schemas.microsoft.com/office/drawing/2014/main" id="{57ABBF99-2A6F-4FA3-AEF0-D0E0CA1821FE}"/>
+                <a16:creationId xmlns:a16="http://schemas.microsoft.com/office/drawing/2014/main" id="{AF0CA27E-1FB2-4091-8A73-695F85CF09D3}"/>
               </a:ext>
             </a:extLst>
           </p:cNvPr>
@@ -6162,7 +6162,7 @@
           <p:cNvPr id="10" name="">
             <a:extLst xmlns:a="http://schemas.openxmlformats.org/drawingml/2006/main">
               <a:ext uri="{FF2B5EF4-FFF2-40B4-BE49-F238E27FC236}">
-                <a16:creationId xmlns:a16="http://schemas.microsoft.com/office/drawing/2014/main" id="{3C9B6DDD-F203-435B-97B8-E58F000EC8C0}"/>
+                <a16:creationId xmlns:a16="http://schemas.microsoft.com/office/drawing/2014/main" id="{A47E96FD-AE70-46DD-B03C-71FC1B667E7C}"/>
               </a:ext>
             </a:extLst>
           </p:cNvPr>
@@ -6219,7 +6219,7 @@
           <p:cNvPr id="11" name="">
             <a:extLst xmlns:a="http://schemas.openxmlformats.org/drawingml/2006/main">
               <a:ext uri="{FF2B5EF4-FFF2-40B4-BE49-F238E27FC236}">
-                <a16:creationId xmlns:a16="http://schemas.microsoft.com/office/drawing/2014/main" id="{468552DC-A528-48AD-BD3F-25858E0860C8}"/>
+                <a16:creationId xmlns:a16="http://schemas.microsoft.com/office/drawing/2014/main" id="{431E4E99-3661-41D2-9AAD-27D4409E8C94}"/>
               </a:ext>
             </a:extLst>
           </p:cNvPr>
@@ -6276,7 +6276,7 @@
           <p:cNvPr id="12" name="">
             <a:extLst xmlns:a="http://schemas.openxmlformats.org/drawingml/2006/main">
               <a:ext uri="{FF2B5EF4-FFF2-40B4-BE49-F238E27FC236}">
-                <a16:creationId xmlns:a16="http://schemas.microsoft.com/office/drawing/2014/main" id="{67F7224D-C678-44F1-A39C-49F573AD9D90}"/>
+                <a16:creationId xmlns:a16="http://schemas.microsoft.com/office/drawing/2014/main" id="{6F48A611-047A-471E-9C1C-18FD2F153046}"/>
               </a:ext>
             </a:extLst>
           </p:cNvPr>
@@ -6331,7 +6331,7 @@
     </p:spTree>
     <p:extLst>
       <p:ext uri="{BB962C8B-B14F-4D97-AF65-F5344CB8AC3E}">
-        <p14:creationId xmlns:p14="http://schemas.microsoft.com/office/powerpoint/2010/main" val="279147430"/>
+        <p14:creationId xmlns:p14="http://schemas.microsoft.com/office/powerpoint/2010/main" val="566911408"/>
       </p:ext>
     </p:extLst>
   </p:cSld>
@@ -6362,7 +6362,7 @@
           <p:cNvPr id="12" name="">
             <a:extLst xmlns:a="http://schemas.openxmlformats.org/drawingml/2006/main">
               <a:ext uri="{FF2B5EF4-FFF2-40B4-BE49-F238E27FC236}">
-                <a16:creationId xmlns:a16="http://schemas.microsoft.com/office/drawing/2014/main" id="{6961FA43-7322-4FE1-87B4-972BCD2A8E2E}"/>
+                <a16:creationId xmlns:a16="http://schemas.microsoft.com/office/drawing/2014/main" id="{4301F6A9-D2AD-48A9-AAAC-55A4151B5591}"/>
               </a:ext>
             </a:extLst>
           </p:cNvPr>
@@ -6419,7 +6419,7 @@
           <p:cNvPr id="2" name="">
             <a:extLst xmlns:a="http://schemas.openxmlformats.org/drawingml/2006/main">
               <a:ext uri="{FF2B5EF4-FFF2-40B4-BE49-F238E27FC236}">
-                <a16:creationId xmlns:a16="http://schemas.microsoft.com/office/drawing/2014/main" id="{C81684E3-DF20-4CDB-A557-B1F9D14A321A}"/>
+                <a16:creationId xmlns:a16="http://schemas.microsoft.com/office/drawing/2014/main" id="{B16435C1-C91F-4FAD-B463-E400AC1995E3}"/>
               </a:ext>
             </a:extLst>
           </p:cNvPr>
@@ -6480,7 +6480,7 @@
           <p:nvPr/>
         </p:nvPicPr>
         <p:blipFill>
-          <a:blip xmlns:r="http://schemas.openxmlformats.org/officeDocument/2006/relationships" xmlns:a="http://schemas.openxmlformats.org/drawingml/2006/main" r:embed="Re74ba77aa3894902"/>
+          <a:blip xmlns:r="http://schemas.openxmlformats.org/officeDocument/2006/relationships" xmlns:a="http://schemas.openxmlformats.org/drawingml/2006/main" r:embed="R9b2c27c0daa84d46"/>
           <a:srcRect xmlns:a="http://schemas.openxmlformats.org/drawingml/2006/main" l="46976" t="41242" r="3159" b="9878"/>
           <a:stretch xmlns:a="http://schemas.openxmlformats.org/drawingml/2006/main"/>
         </p:blipFill>
@@ -6499,7 +6499,7 @@
           <p:cNvPr id="4" name="">
             <a:extLst xmlns:a="http://schemas.openxmlformats.org/drawingml/2006/main">
               <a:ext uri="{FF2B5EF4-FFF2-40B4-BE49-F238E27FC236}">
-                <a16:creationId xmlns:a16="http://schemas.microsoft.com/office/drawing/2014/main" id="{EB78CE6D-D2E9-4447-9867-2016062FF59A}"/>
+                <a16:creationId xmlns:a16="http://schemas.microsoft.com/office/drawing/2014/main" id="{81136DF8-6B66-4322-8F64-1F222876A1F2}"/>
               </a:ext>
             </a:extLst>
           </p:cNvPr>
@@ -6556,7 +6556,7 @@
           <p:cNvPr id="5" name="">
             <a:extLst xmlns:a="http://schemas.openxmlformats.org/drawingml/2006/main">
               <a:ext uri="{FF2B5EF4-FFF2-40B4-BE49-F238E27FC236}">
-                <a16:creationId xmlns:a16="http://schemas.microsoft.com/office/drawing/2014/main" id="{0E9FD99C-D2E6-49AE-A8D0-66879073C47B}"/>
+                <a16:creationId xmlns:a16="http://schemas.microsoft.com/office/drawing/2014/main" id="{64882465-CA5B-4580-BF3F-24AA6D1CB945}"/>
               </a:ext>
             </a:extLst>
           </p:cNvPr>
@@ -6603,7 +6603,7 @@
                 <a:ea typeface="Noto Sans"/>
                 <a:cs typeface="Noto Sans"/>
               </a:rPr>
-              <a:t>Prior v1.1 host; new chat is local</a:t>
+              <a:t>Hosted chat demo: verified</a:t>
             </a:r>
           </a:p>
         </p:txBody>
@@ -6613,7 +6613,7 @@
           <p:cNvPr id="6" name="">
             <a:extLst xmlns:a="http://schemas.openxmlformats.org/drawingml/2006/main">
               <a:ext uri="{FF2B5EF4-FFF2-40B4-BE49-F238E27FC236}">
-                <a16:creationId xmlns:a16="http://schemas.microsoft.com/office/drawing/2014/main" id="{E06AEBF1-B854-425B-8241-565FDE00FEB8}"/>
+                <a16:creationId xmlns:a16="http://schemas.microsoft.com/office/drawing/2014/main" id="{647A7B74-3538-4A15-80F9-027D57FEC9C8}"/>
               </a:ext>
             </a:extLst>
           </p:cNvPr>
@@ -6670,7 +6670,7 @@
           <p:cNvPr id="7" name="">
             <a:extLst xmlns:a="http://schemas.openxmlformats.org/drawingml/2006/main">
               <a:ext uri="{FF2B5EF4-FFF2-40B4-BE49-F238E27FC236}">
-                <a16:creationId xmlns:a16="http://schemas.microsoft.com/office/drawing/2014/main" id="{8078DFB0-32B2-4747-BDEF-B0C22911E2C8}"/>
+                <a16:creationId xmlns:a16="http://schemas.microsoft.com/office/drawing/2014/main" id="{BF41812F-E95E-4EDE-8A43-7FB23E66AD30}"/>
               </a:ext>
             </a:extLst>
           </p:cNvPr>
@@ -6727,7 +6727,7 @@
           <p:cNvPr id="8" name="">
             <a:extLst xmlns:a="http://schemas.openxmlformats.org/drawingml/2006/main">
               <a:ext uri="{FF2B5EF4-FFF2-40B4-BE49-F238E27FC236}">
-                <a16:creationId xmlns:a16="http://schemas.microsoft.com/office/drawing/2014/main" id="{A97E2CB0-27C7-4788-8742-9EE57525D8A5}"/>
+                <a16:creationId xmlns:a16="http://schemas.microsoft.com/office/drawing/2014/main" id="{05120900-F3B2-4BA7-8976-00322871E4D9}"/>
               </a:ext>
             </a:extLst>
           </p:cNvPr>
@@ -6830,7 +6830,7 @@
           <p:cNvPr id="9" name="">
             <a:extLst xmlns:a="http://schemas.openxmlformats.org/drawingml/2006/main">
               <a:ext uri="{FF2B5EF4-FFF2-40B4-BE49-F238E27FC236}">
-                <a16:creationId xmlns:a16="http://schemas.microsoft.com/office/drawing/2014/main" id="{B6A4B374-FD26-4007-B165-772562913BA8}"/>
+                <a16:creationId xmlns:a16="http://schemas.microsoft.com/office/drawing/2014/main" id="{B614820D-D1A7-48A9-911D-A265E5E87D5B}"/>
               </a:ext>
             </a:extLst>
           </p:cNvPr>
@@ -6933,7 +6933,7 @@
           <p:cNvPr id="10" name="">
             <a:extLst xmlns:a="http://schemas.openxmlformats.org/drawingml/2006/main">
               <a:ext uri="{FF2B5EF4-FFF2-40B4-BE49-F238E27FC236}">
-                <a16:creationId xmlns:a16="http://schemas.microsoft.com/office/drawing/2014/main" id="{FEF3C55F-5BD9-4BA2-8FA9-38F21ECE06F9}"/>
+                <a16:creationId xmlns:a16="http://schemas.microsoft.com/office/drawing/2014/main" id="{46E48759-7CC7-4EBF-9297-07D6EEB20153}"/>
               </a:ext>
             </a:extLst>
           </p:cNvPr>
@@ -6990,7 +6990,7 @@
           <p:cNvPr id="11" name="">
             <a:extLst xmlns:a="http://schemas.openxmlformats.org/drawingml/2006/main">
               <a:ext uri="{FF2B5EF4-FFF2-40B4-BE49-F238E27FC236}">
-                <a16:creationId xmlns:a16="http://schemas.microsoft.com/office/drawing/2014/main" id="{3A5E23C5-8916-4009-967A-89A1DE350B90}"/>
+                <a16:creationId xmlns:a16="http://schemas.microsoft.com/office/drawing/2014/main" id="{FA96332E-F303-4D68-A5B4-5821258CDAC6}"/>
               </a:ext>
             </a:extLst>
           </p:cNvPr>
@@ -7068,7 +7068,7 @@
     </p:spTree>
     <p:extLst>
       <p:ext uri="{BB962C8B-B14F-4D97-AF65-F5344CB8AC3E}">
-        <p14:creationId xmlns:p14="http://schemas.microsoft.com/office/powerpoint/2010/main" val="804392976"/>
+        <p14:creationId xmlns:p14="http://schemas.microsoft.com/office/powerpoint/2010/main" val="1101776651"/>
       </p:ext>
     </p:extLst>
   </p:cSld>

</xml_diff>